<commit_message>
Shrink the variant A emblem and centre it vertically on the right
Goes from 4.4" anchored near the top to 3.8" centred on the slide's
vertical axis, 0.7" clear of the right edge.

Co-Authored-By: Claude Opus 5 <noreply@anthropic.com>
Claude-Session: https://claude.ai/code/session_01GZfitk2JEKppZ4fGSDdghv
</commit_message>
<xml_diff>
--- a/docs/2027년_사무직원_채용계획안_A_우측엠블럼.pptx
+++ b/docs/2027년_사무직원_채용계획안_A_우측엠블럼.pptx
@@ -1970,8 +1970,8 @@
         </p:blipFill>
         <p:spPr>
           <a:xfrm>
-            <a:off x="7680960" y="1097280"/>
-            <a:ext cx="4023360" cy="4023360"/>
+            <a:off x="8046720" y="1691640"/>
+            <a:ext cx="3474720" cy="3474720"/>
           </a:xfrm>
           <a:prstGeom prst="rect">
             <a:avLst/>

</xml_diff>

<commit_message>
Put the school badge in the top-right corner of every content slide
- slideBase() now stamps the 교표 at 0.92" wide in the top-right; the
  cover opts out and keeps its larger badge on the left
- Drop the STEP number circles from slides 6-9, which sat where the
  badge now goes (the "STEP 01 …" eyebrow already carries the number)
- Drop the decorative circle on the summary slide, which covered the
  badge and no longer had a role

Co-Authored-By: Claude Opus 5 <noreply@anthropic.com>
Claude-Session: https://claude.ai/code/session_01GZfitk2JEKppZ4fGSDdghv
</commit_message>
<xml_diff>
--- a/docs/2027년_사무직원_채용계획안_A_우측엠블럼.pptx
+++ b/docs/2027년_사무직원_채용계획안_A_우측엠블럼.pptx
@@ -2469,9 +2469,33 @@
           <a:chExt cx="0" cy="0"/>
         </a:xfrm>
       </p:grpSpPr>
-      <p:sp>
-        <p:nvSpPr>
-          <p:cNvPr id="2" name="Text 0"/>
+      <p:pic>
+        <p:nvPicPr>
+          <p:cNvPr id="2" name="Image 0" descr="정석항공과학고등학교 교표">    </p:cNvPr>
+          <p:cNvPicPr>
+            <a:picLocks noChangeAspect="1"/>
+          </p:cNvPicPr>
+          <p:nvPr/>
+        </p:nvPicPr>
+        <p:blipFill>
+          <a:blip r:embed="rId1"/>
+          <a:stretch>
+            <a:fillRect/>
+          </a:stretch>
+        </p:blipFill>
+        <p:spPr>
+          <a:xfrm>
+            <a:off x="10753344" y="384048"/>
+            <a:ext cx="841248" cy="360274"/>
+          </a:xfrm>
+          <a:prstGeom prst="rect">
+            <a:avLst/>
+          </a:prstGeom>
+        </p:spPr>
+      </p:pic>
+      <p:sp>
+        <p:nvSpPr>
+          <p:cNvPr id="3" name="Text 0"/>
           <p:cNvSpPr txBox="1"/>
           <p:nvPr/>
         </p:nvSpPr>
@@ -2510,7 +2534,7 @@
       </p:sp>
       <p:sp>
         <p:nvSpPr>
-          <p:cNvPr id="3" name="Text 1"/>
+          <p:cNvPr id="4" name="Text 1"/>
           <p:cNvSpPr txBox="1"/>
           <p:nvPr/>
         </p:nvSpPr>
@@ -2549,7 +2573,7 @@
       </p:sp>
       <p:sp>
         <p:nvSpPr>
-          <p:cNvPr id="4" name="Shape 2"/>
+          <p:cNvPr id="5" name="Shape 2"/>
           <p:cNvSpPr/>
           <p:nvPr/>
         </p:nvSpPr>
@@ -2583,7 +2607,7 @@
       </p:sp>
       <p:sp>
         <p:nvSpPr>
-          <p:cNvPr id="5" name="Shape 3"/>
+          <p:cNvPr id="6" name="Shape 3"/>
           <p:cNvSpPr/>
           <p:nvPr/>
         </p:nvSpPr>
@@ -2603,7 +2627,7 @@
       </p:sp>
       <p:sp>
         <p:nvSpPr>
-          <p:cNvPr id="6" name="Text 4"/>
+          <p:cNvPr id="7" name="Text 4"/>
           <p:cNvSpPr txBox="1"/>
           <p:nvPr/>
         </p:nvSpPr>
@@ -2642,7 +2666,7 @@
       </p:sp>
       <p:sp>
         <p:nvSpPr>
-          <p:cNvPr id="7" name="Text 5"/>
+          <p:cNvPr id="8" name="Text 5"/>
           <p:cNvSpPr txBox="1"/>
           <p:nvPr/>
         </p:nvSpPr>
@@ -2681,7 +2705,7 @@
       </p:sp>
       <p:sp>
         <p:nvSpPr>
-          <p:cNvPr id="8" name="Text 6"/>
+          <p:cNvPr id="9" name="Text 6"/>
           <p:cNvSpPr txBox="1"/>
           <p:nvPr/>
         </p:nvSpPr>
@@ -2751,7 +2775,7 @@
       </p:sp>
       <p:sp>
         <p:nvSpPr>
-          <p:cNvPr id="9" name="Shape 7"/>
+          <p:cNvPr id="10" name="Shape 7"/>
           <p:cNvSpPr/>
           <p:nvPr/>
         </p:nvSpPr>
@@ -2785,7 +2809,7 @@
       </p:sp>
       <p:sp>
         <p:nvSpPr>
-          <p:cNvPr id="10" name="Shape 8"/>
+          <p:cNvPr id="11" name="Shape 8"/>
           <p:cNvSpPr/>
           <p:nvPr/>
         </p:nvSpPr>
@@ -2805,7 +2829,7 @@
       </p:sp>
       <p:sp>
         <p:nvSpPr>
-          <p:cNvPr id="11" name="Text 9"/>
+          <p:cNvPr id="12" name="Text 9"/>
           <p:cNvSpPr txBox="1"/>
           <p:nvPr/>
         </p:nvSpPr>
@@ -2844,7 +2868,7 @@
       </p:sp>
       <p:sp>
         <p:nvSpPr>
-          <p:cNvPr id="12" name="Text 10"/>
+          <p:cNvPr id="13" name="Text 10"/>
           <p:cNvSpPr txBox="1"/>
           <p:nvPr/>
         </p:nvSpPr>
@@ -2883,7 +2907,7 @@
       </p:sp>
       <p:sp>
         <p:nvSpPr>
-          <p:cNvPr id="13" name="Text 11"/>
+          <p:cNvPr id="14" name="Text 11"/>
           <p:cNvSpPr txBox="1"/>
           <p:nvPr/>
         </p:nvSpPr>
@@ -2929,7 +2953,7 @@
       </p:sp>
       <p:sp>
         <p:nvSpPr>
-          <p:cNvPr id="14" name="Shape 12"/>
+          <p:cNvPr id="15" name="Shape 12"/>
           <p:cNvSpPr/>
           <p:nvPr/>
         </p:nvSpPr>
@@ -2963,7 +2987,7 @@
       </p:sp>
       <p:sp>
         <p:nvSpPr>
-          <p:cNvPr id="15" name="Shape 13"/>
+          <p:cNvPr id="16" name="Shape 13"/>
           <p:cNvSpPr/>
           <p:nvPr/>
         </p:nvSpPr>
@@ -2983,7 +3007,7 @@
       </p:sp>
       <p:sp>
         <p:nvSpPr>
-          <p:cNvPr id="16" name="Text 14"/>
+          <p:cNvPr id="17" name="Text 14"/>
           <p:cNvSpPr txBox="1"/>
           <p:nvPr/>
         </p:nvSpPr>
@@ -3022,7 +3046,7 @@
       </p:sp>
       <p:sp>
         <p:nvSpPr>
-          <p:cNvPr id="17" name="Text 15"/>
+          <p:cNvPr id="18" name="Text 15"/>
           <p:cNvSpPr txBox="1"/>
           <p:nvPr/>
         </p:nvSpPr>
@@ -3061,7 +3085,7 @@
       </p:sp>
       <p:sp>
         <p:nvSpPr>
-          <p:cNvPr id="18" name="Text 16"/>
+          <p:cNvPr id="19" name="Text 16"/>
           <p:cNvSpPr txBox="1"/>
           <p:nvPr/>
         </p:nvSpPr>
@@ -3107,7 +3131,7 @@
       </p:sp>
       <p:sp>
         <p:nvSpPr>
-          <p:cNvPr id="19" name="Shape 17"/>
+          <p:cNvPr id="20" name="Shape 17"/>
           <p:cNvSpPr/>
           <p:nvPr/>
         </p:nvSpPr>
@@ -3141,7 +3165,7 @@
       </p:sp>
       <p:sp>
         <p:nvSpPr>
-          <p:cNvPr id="20" name="Text 18"/>
+          <p:cNvPr id="21" name="Text 18"/>
           <p:cNvSpPr txBox="1"/>
           <p:nvPr/>
         </p:nvSpPr>
@@ -3210,29 +3234,33 @@
           <a:chExt cx="0" cy="0"/>
         </a:xfrm>
       </p:grpSpPr>
-      <p:sp>
-        <p:nvSpPr>
-          <p:cNvPr id="2" name="Shape 0"/>
-          <p:cNvSpPr/>
-          <p:nvPr/>
-        </p:nvSpPr>
-        <p:spPr>
-          <a:xfrm>
-            <a:off x="9692640" y="-2743200"/>
-            <a:ext cx="4754880" cy="4754880"/>
-          </a:xfrm>
-          <a:prstGeom prst="ellipse">
-            <a:avLst/>
-          </a:prstGeom>
-          <a:solidFill>
-            <a:srgbClr val="141B44"/>
-          </a:solidFill>
-          <a:ln/>
-        </p:spPr>
-      </p:sp>
-      <p:sp>
-        <p:nvSpPr>
-          <p:cNvPr id="3" name="Text 1"/>
+      <p:pic>
+        <p:nvPicPr>
+          <p:cNvPr id="2" name="Image 0" descr="정석항공과학고등학교 교표">    </p:cNvPr>
+          <p:cNvPicPr>
+            <a:picLocks noChangeAspect="1"/>
+          </p:cNvPicPr>
+          <p:nvPr/>
+        </p:nvPicPr>
+        <p:blipFill>
+          <a:blip r:embed="rId1"/>
+          <a:stretch>
+            <a:fillRect/>
+          </a:stretch>
+        </p:blipFill>
+        <p:spPr>
+          <a:xfrm>
+            <a:off x="10753344" y="384048"/>
+            <a:ext cx="841248" cy="360274"/>
+          </a:xfrm>
+          <a:prstGeom prst="rect">
+            <a:avLst/>
+          </a:prstGeom>
+        </p:spPr>
+      </p:pic>
+      <p:sp>
+        <p:nvSpPr>
+          <p:cNvPr id="3" name="Text 0"/>
           <p:cNvSpPr txBox="1"/>
           <p:nvPr/>
         </p:nvSpPr>
@@ -3271,7 +3299,7 @@
       </p:sp>
       <p:sp>
         <p:nvSpPr>
-          <p:cNvPr id="4" name="Text 2"/>
+          <p:cNvPr id="4" name="Text 1"/>
           <p:cNvSpPr txBox="1"/>
           <p:nvPr/>
         </p:nvSpPr>
@@ -3310,7 +3338,7 @@
       </p:sp>
       <p:sp>
         <p:nvSpPr>
-          <p:cNvPr id="5" name="Shape 3"/>
+          <p:cNvPr id="5" name="Shape 2"/>
           <p:cNvSpPr/>
           <p:nvPr/>
         </p:nvSpPr>
@@ -3337,7 +3365,7 @@
       </p:sp>
       <p:sp>
         <p:nvSpPr>
-          <p:cNvPr id="6" name="Text 4"/>
+          <p:cNvPr id="6" name="Text 3"/>
           <p:cNvSpPr txBox="1"/>
           <p:nvPr/>
         </p:nvSpPr>
@@ -3376,7 +3404,7 @@
       </p:sp>
       <p:sp>
         <p:nvSpPr>
-          <p:cNvPr id="7" name="Text 5"/>
+          <p:cNvPr id="7" name="Text 4"/>
           <p:cNvSpPr txBox="1"/>
           <p:nvPr/>
         </p:nvSpPr>
@@ -3415,7 +3443,7 @@
       </p:sp>
       <p:sp>
         <p:nvSpPr>
-          <p:cNvPr id="8" name="Text 6"/>
+          <p:cNvPr id="8" name="Text 5"/>
           <p:cNvSpPr txBox="1"/>
           <p:nvPr/>
         </p:nvSpPr>
@@ -3457,7 +3485,7 @@
       </p:sp>
       <p:sp>
         <p:nvSpPr>
-          <p:cNvPr id="9" name="Shape 7"/>
+          <p:cNvPr id="9" name="Shape 6"/>
           <p:cNvSpPr/>
           <p:nvPr/>
         </p:nvSpPr>
@@ -3484,7 +3512,7 @@
       </p:sp>
       <p:sp>
         <p:nvSpPr>
-          <p:cNvPr id="10" name="Text 8"/>
+          <p:cNvPr id="10" name="Text 7"/>
           <p:cNvSpPr txBox="1"/>
           <p:nvPr/>
         </p:nvSpPr>
@@ -3523,7 +3551,7 @@
       </p:sp>
       <p:sp>
         <p:nvSpPr>
-          <p:cNvPr id="11" name="Text 9"/>
+          <p:cNvPr id="11" name="Text 8"/>
           <p:cNvSpPr txBox="1"/>
           <p:nvPr/>
         </p:nvSpPr>
@@ -3562,7 +3590,7 @@
       </p:sp>
       <p:sp>
         <p:nvSpPr>
-          <p:cNvPr id="12" name="Text 10"/>
+          <p:cNvPr id="12" name="Text 9"/>
           <p:cNvSpPr txBox="1"/>
           <p:nvPr/>
         </p:nvSpPr>
@@ -3604,7 +3632,7 @@
       </p:sp>
       <p:sp>
         <p:nvSpPr>
-          <p:cNvPr id="13" name="Shape 11"/>
+          <p:cNvPr id="13" name="Shape 10"/>
           <p:cNvSpPr/>
           <p:nvPr/>
         </p:nvSpPr>
@@ -3631,7 +3659,7 @@
       </p:sp>
       <p:sp>
         <p:nvSpPr>
-          <p:cNvPr id="14" name="Text 12"/>
+          <p:cNvPr id="14" name="Text 11"/>
           <p:cNvSpPr txBox="1"/>
           <p:nvPr/>
         </p:nvSpPr>
@@ -3670,7 +3698,7 @@
       </p:sp>
       <p:sp>
         <p:nvSpPr>
-          <p:cNvPr id="15" name="Text 13"/>
+          <p:cNvPr id="15" name="Text 12"/>
           <p:cNvSpPr txBox="1"/>
           <p:nvPr/>
         </p:nvSpPr>
@@ -3709,7 +3737,7 @@
       </p:sp>
       <p:sp>
         <p:nvSpPr>
-          <p:cNvPr id="16" name="Text 14"/>
+          <p:cNvPr id="16" name="Text 13"/>
           <p:cNvSpPr txBox="1"/>
           <p:nvPr/>
         </p:nvSpPr>
@@ -3751,7 +3779,7 @@
       </p:sp>
       <p:sp>
         <p:nvSpPr>
-          <p:cNvPr id="17" name="Shape 15"/>
+          <p:cNvPr id="17" name="Shape 14"/>
           <p:cNvSpPr/>
           <p:nvPr/>
         </p:nvSpPr>
@@ -3778,7 +3806,7 @@
       </p:sp>
       <p:sp>
         <p:nvSpPr>
-          <p:cNvPr id="18" name="Text 16"/>
+          <p:cNvPr id="18" name="Text 15"/>
           <p:cNvSpPr txBox="1"/>
           <p:nvPr/>
         </p:nvSpPr>
@@ -3817,7 +3845,7 @@
       </p:sp>
       <p:sp>
         <p:nvSpPr>
-          <p:cNvPr id="19" name="Text 17"/>
+          <p:cNvPr id="19" name="Text 16"/>
           <p:cNvSpPr txBox="1"/>
           <p:nvPr/>
         </p:nvSpPr>
@@ -3856,7 +3884,7 @@
       </p:sp>
       <p:sp>
         <p:nvSpPr>
-          <p:cNvPr id="20" name="Text 18"/>
+          <p:cNvPr id="20" name="Text 17"/>
           <p:cNvSpPr txBox="1"/>
           <p:nvPr/>
         </p:nvSpPr>
@@ -3898,7 +3926,7 @@
       </p:sp>
       <p:sp>
         <p:nvSpPr>
-          <p:cNvPr id="21" name="Text 19"/>
+          <p:cNvPr id="21" name="Text 18"/>
           <p:cNvSpPr txBox="1"/>
           <p:nvPr/>
         </p:nvSpPr>
@@ -3937,7 +3965,7 @@
       </p:sp>
       <p:sp>
         <p:nvSpPr>
-          <p:cNvPr id="22" name="Shape 20"/>
+          <p:cNvPr id="22" name="Shape 19"/>
           <p:cNvSpPr/>
           <p:nvPr/>
         </p:nvSpPr>
@@ -3957,7 +3985,7 @@
       </p:sp>
       <p:sp>
         <p:nvSpPr>
-          <p:cNvPr id="23" name="Text 21"/>
+          <p:cNvPr id="23" name="Text 20"/>
           <p:cNvSpPr txBox="1"/>
           <p:nvPr/>
         </p:nvSpPr>
@@ -3996,7 +4024,7 @@
       </p:sp>
       <p:sp>
         <p:nvSpPr>
-          <p:cNvPr id="24" name="Text 22"/>
+          <p:cNvPr id="24" name="Text 21"/>
           <p:cNvSpPr txBox="1"/>
           <p:nvPr/>
         </p:nvSpPr>
@@ -4038,7 +4066,7 @@
       </p:sp>
       <p:sp>
         <p:nvSpPr>
-          <p:cNvPr id="25" name="Shape 23"/>
+          <p:cNvPr id="25" name="Shape 22"/>
           <p:cNvSpPr/>
           <p:nvPr/>
         </p:nvSpPr>
@@ -4058,7 +4086,7 @@
       </p:sp>
       <p:sp>
         <p:nvSpPr>
-          <p:cNvPr id="26" name="Text 24"/>
+          <p:cNvPr id="26" name="Text 23"/>
           <p:cNvSpPr txBox="1"/>
           <p:nvPr/>
         </p:nvSpPr>
@@ -4097,7 +4125,7 @@
       </p:sp>
       <p:sp>
         <p:nvSpPr>
-          <p:cNvPr id="27" name="Text 25"/>
+          <p:cNvPr id="27" name="Text 24"/>
           <p:cNvSpPr txBox="1"/>
           <p:nvPr/>
         </p:nvSpPr>
@@ -4139,7 +4167,7 @@
       </p:sp>
       <p:sp>
         <p:nvSpPr>
-          <p:cNvPr id="28" name="Shape 26"/>
+          <p:cNvPr id="28" name="Shape 25"/>
           <p:cNvSpPr/>
           <p:nvPr/>
         </p:nvSpPr>
@@ -4159,7 +4187,7 @@
       </p:sp>
       <p:sp>
         <p:nvSpPr>
-          <p:cNvPr id="29" name="Text 27"/>
+          <p:cNvPr id="29" name="Text 26"/>
           <p:cNvSpPr txBox="1"/>
           <p:nvPr/>
         </p:nvSpPr>
@@ -4198,7 +4226,7 @@
       </p:sp>
       <p:sp>
         <p:nvSpPr>
-          <p:cNvPr id="30" name="Text 28"/>
+          <p:cNvPr id="30" name="Text 27"/>
           <p:cNvSpPr txBox="1"/>
           <p:nvPr/>
         </p:nvSpPr>
@@ -4240,7 +4268,7 @@
       </p:sp>
       <p:sp>
         <p:nvSpPr>
-          <p:cNvPr id="31" name="Shape 29"/>
+          <p:cNvPr id="31" name="Shape 28"/>
           <p:cNvSpPr/>
           <p:nvPr/>
         </p:nvSpPr>
@@ -4260,7 +4288,7 @@
       </p:sp>
       <p:sp>
         <p:nvSpPr>
-          <p:cNvPr id="32" name="Text 30"/>
+          <p:cNvPr id="32" name="Text 29"/>
           <p:cNvSpPr txBox="1"/>
           <p:nvPr/>
         </p:nvSpPr>
@@ -4299,7 +4327,7 @@
       </p:sp>
       <p:sp>
         <p:nvSpPr>
-          <p:cNvPr id="33" name="Text 31"/>
+          <p:cNvPr id="33" name="Text 30"/>
           <p:cNvSpPr txBox="1"/>
           <p:nvPr/>
         </p:nvSpPr>
@@ -4371,9 +4399,33 @@
           <a:chExt cx="0" cy="0"/>
         </a:xfrm>
       </p:grpSpPr>
-      <p:sp>
-        <p:nvSpPr>
-          <p:cNvPr id="2" name="Text 0"/>
+      <p:pic>
+        <p:nvPicPr>
+          <p:cNvPr id="2" name="Image 0" descr="정석항공과학고등학교 교표">    </p:cNvPr>
+          <p:cNvPicPr>
+            <a:picLocks noChangeAspect="1"/>
+          </p:cNvPicPr>
+          <p:nvPr/>
+        </p:nvPicPr>
+        <p:blipFill>
+          <a:blip r:embed="rId1"/>
+          <a:stretch>
+            <a:fillRect/>
+          </a:stretch>
+        </p:blipFill>
+        <p:spPr>
+          <a:xfrm>
+            <a:off x="10753344" y="384048"/>
+            <a:ext cx="841248" cy="360274"/>
+          </a:xfrm>
+          <a:prstGeom prst="rect">
+            <a:avLst/>
+          </a:prstGeom>
+        </p:spPr>
+      </p:pic>
+      <p:sp>
+        <p:nvSpPr>
+          <p:cNvPr id="3" name="Text 0"/>
           <p:cNvSpPr txBox="1"/>
           <p:nvPr/>
         </p:nvSpPr>
@@ -4412,7 +4464,7 @@
       </p:sp>
       <p:sp>
         <p:nvSpPr>
-          <p:cNvPr id="3" name="Text 1"/>
+          <p:cNvPr id="4" name="Text 1"/>
           <p:cNvSpPr txBox="1"/>
           <p:nvPr/>
         </p:nvSpPr>
@@ -4451,7 +4503,7 @@
       </p:sp>
       <p:sp>
         <p:nvSpPr>
-          <p:cNvPr id="4" name="Shape 2"/>
+          <p:cNvPr id="5" name="Shape 2"/>
           <p:cNvSpPr/>
           <p:nvPr/>
         </p:nvSpPr>
@@ -4485,7 +4537,7 @@
       </p:sp>
       <p:sp>
         <p:nvSpPr>
-          <p:cNvPr id="5" name="Text 3"/>
+          <p:cNvPr id="6" name="Text 3"/>
           <p:cNvSpPr txBox="1"/>
           <p:nvPr/>
         </p:nvSpPr>
@@ -4524,7 +4576,7 @@
       </p:sp>
       <p:sp>
         <p:nvSpPr>
-          <p:cNvPr id="6" name="Text 4"/>
+          <p:cNvPr id="7" name="Text 4"/>
           <p:cNvSpPr txBox="1"/>
           <p:nvPr/>
         </p:nvSpPr>
@@ -4563,7 +4615,7 @@
       </p:sp>
       <p:sp>
         <p:nvSpPr>
-          <p:cNvPr id="7" name="Shape 5"/>
+          <p:cNvPr id="8" name="Shape 5"/>
           <p:cNvSpPr/>
           <p:nvPr/>
         </p:nvSpPr>
@@ -4597,7 +4649,7 @@
       </p:sp>
       <p:sp>
         <p:nvSpPr>
-          <p:cNvPr id="8" name="Text 6"/>
+          <p:cNvPr id="9" name="Text 6"/>
           <p:cNvSpPr txBox="1"/>
           <p:nvPr/>
         </p:nvSpPr>
@@ -4636,7 +4688,7 @@
       </p:sp>
       <p:sp>
         <p:nvSpPr>
-          <p:cNvPr id="9" name="Text 7"/>
+          <p:cNvPr id="10" name="Text 7"/>
           <p:cNvSpPr txBox="1"/>
           <p:nvPr/>
         </p:nvSpPr>
@@ -4675,7 +4727,7 @@
       </p:sp>
       <p:sp>
         <p:nvSpPr>
-          <p:cNvPr id="10" name="Shape 8"/>
+          <p:cNvPr id="11" name="Shape 8"/>
           <p:cNvSpPr/>
           <p:nvPr/>
         </p:nvSpPr>
@@ -4709,7 +4761,7 @@
       </p:sp>
       <p:sp>
         <p:nvSpPr>
-          <p:cNvPr id="11" name="Text 9"/>
+          <p:cNvPr id="12" name="Text 9"/>
           <p:cNvSpPr txBox="1"/>
           <p:nvPr/>
         </p:nvSpPr>
@@ -4748,7 +4800,7 @@
       </p:sp>
       <p:sp>
         <p:nvSpPr>
-          <p:cNvPr id="12" name="Text 10"/>
+          <p:cNvPr id="13" name="Text 10"/>
           <p:cNvSpPr txBox="1"/>
           <p:nvPr/>
         </p:nvSpPr>
@@ -4787,7 +4839,7 @@
       </p:sp>
       <p:sp>
         <p:nvSpPr>
-          <p:cNvPr id="13" name="Shape 11"/>
+          <p:cNvPr id="14" name="Shape 11"/>
           <p:cNvSpPr/>
           <p:nvPr/>
         </p:nvSpPr>
@@ -4821,7 +4873,7 @@
       </p:sp>
       <p:sp>
         <p:nvSpPr>
-          <p:cNvPr id="14" name="Text 12"/>
+          <p:cNvPr id="15" name="Text 12"/>
           <p:cNvSpPr txBox="1"/>
           <p:nvPr/>
         </p:nvSpPr>
@@ -4860,7 +4912,7 @@
       </p:sp>
       <p:sp>
         <p:nvSpPr>
-          <p:cNvPr id="15" name="Text 13"/>
+          <p:cNvPr id="16" name="Text 13"/>
           <p:cNvSpPr txBox="1"/>
           <p:nvPr/>
         </p:nvSpPr>
@@ -4899,7 +4951,7 @@
       </p:sp>
       <p:sp>
         <p:nvSpPr>
-          <p:cNvPr id="16" name="Text 14"/>
+          <p:cNvPr id="17" name="Text 14"/>
           <p:cNvSpPr txBox="1"/>
           <p:nvPr/>
         </p:nvSpPr>
@@ -4961,7 +5013,7 @@
       </p:sp>
       <p:sp>
         <p:nvSpPr>
-          <p:cNvPr id="17" name="Shape 15"/>
+          <p:cNvPr id="18" name="Shape 15"/>
           <p:cNvSpPr/>
           <p:nvPr/>
         </p:nvSpPr>
@@ -4995,7 +5047,7 @@
       </p:sp>
       <p:sp>
         <p:nvSpPr>
-          <p:cNvPr id="18" name="Text 16"/>
+          <p:cNvPr id="19" name="Text 16"/>
           <p:cNvSpPr txBox="1"/>
           <p:nvPr/>
         </p:nvSpPr>
@@ -5034,7 +5086,7 @@
       </p:sp>
       <p:sp>
         <p:nvSpPr>
-          <p:cNvPr id="19" name="Text 17"/>
+          <p:cNvPr id="20" name="Text 17"/>
           <p:cNvSpPr txBox="1"/>
           <p:nvPr/>
         </p:nvSpPr>
@@ -5073,7 +5125,7 @@
       </p:sp>
       <p:sp>
         <p:nvSpPr>
-          <p:cNvPr id="20" name="Shape 18"/>
+          <p:cNvPr id="21" name="Shape 18"/>
           <p:cNvSpPr/>
           <p:nvPr/>
         </p:nvSpPr>
@@ -5107,7 +5159,7 @@
       </p:sp>
       <p:sp>
         <p:nvSpPr>
-          <p:cNvPr id="21" name="Text 19"/>
+          <p:cNvPr id="22" name="Text 19"/>
           <p:cNvSpPr txBox="1"/>
           <p:nvPr/>
         </p:nvSpPr>
@@ -5146,7 +5198,7 @@
       </p:sp>
       <p:sp>
         <p:nvSpPr>
-          <p:cNvPr id="22" name="Shape 20"/>
+          <p:cNvPr id="23" name="Shape 20"/>
           <p:cNvSpPr/>
           <p:nvPr/>
         </p:nvSpPr>
@@ -5166,7 +5218,7 @@
       </p:sp>
       <p:sp>
         <p:nvSpPr>
-          <p:cNvPr id="23" name="Text 21"/>
+          <p:cNvPr id="24" name="Text 21"/>
           <p:cNvSpPr txBox="1"/>
           <p:nvPr/>
         </p:nvSpPr>
@@ -5205,7 +5257,7 @@
       </p:sp>
       <p:sp>
         <p:nvSpPr>
-          <p:cNvPr id="24" name="Text 22"/>
+          <p:cNvPr id="25" name="Text 22"/>
           <p:cNvSpPr txBox="1"/>
           <p:nvPr/>
         </p:nvSpPr>
@@ -5247,7 +5299,7 @@
       </p:sp>
       <p:sp>
         <p:nvSpPr>
-          <p:cNvPr id="25" name="Shape 23"/>
+          <p:cNvPr id="26" name="Shape 23"/>
           <p:cNvSpPr/>
           <p:nvPr/>
         </p:nvSpPr>
@@ -5267,7 +5319,7 @@
       </p:sp>
       <p:sp>
         <p:nvSpPr>
-          <p:cNvPr id="26" name="Text 24"/>
+          <p:cNvPr id="27" name="Text 24"/>
           <p:cNvSpPr txBox="1"/>
           <p:nvPr/>
         </p:nvSpPr>
@@ -5306,7 +5358,7 @@
       </p:sp>
       <p:sp>
         <p:nvSpPr>
-          <p:cNvPr id="27" name="Text 25"/>
+          <p:cNvPr id="28" name="Text 25"/>
           <p:cNvSpPr txBox="1"/>
           <p:nvPr/>
         </p:nvSpPr>
@@ -5348,7 +5400,7 @@
       </p:sp>
       <p:sp>
         <p:nvSpPr>
-          <p:cNvPr id="28" name="Text 26"/>
+          <p:cNvPr id="29" name="Text 26"/>
           <p:cNvSpPr txBox="1"/>
           <p:nvPr/>
         </p:nvSpPr>
@@ -5417,9 +5469,33 @@
           <a:chExt cx="0" cy="0"/>
         </a:xfrm>
       </p:grpSpPr>
-      <p:sp>
-        <p:nvSpPr>
-          <p:cNvPr id="2" name="Text 0"/>
+      <p:pic>
+        <p:nvPicPr>
+          <p:cNvPr id="2" name="Image 0" descr="정석항공과학고등학교 교표">    </p:cNvPr>
+          <p:cNvPicPr>
+            <a:picLocks noChangeAspect="1"/>
+          </p:cNvPicPr>
+          <p:nvPr/>
+        </p:nvPicPr>
+        <p:blipFill>
+          <a:blip r:embed="rId1"/>
+          <a:stretch>
+            <a:fillRect/>
+          </a:stretch>
+        </p:blipFill>
+        <p:spPr>
+          <a:xfrm>
+            <a:off x="10753344" y="384048"/>
+            <a:ext cx="841248" cy="360274"/>
+          </a:xfrm>
+          <a:prstGeom prst="rect">
+            <a:avLst/>
+          </a:prstGeom>
+        </p:spPr>
+      </p:pic>
+      <p:sp>
+        <p:nvSpPr>
+          <p:cNvPr id="3" name="Text 0"/>
           <p:cNvSpPr txBox="1"/>
           <p:nvPr/>
         </p:nvSpPr>
@@ -5458,7 +5534,7 @@
       </p:sp>
       <p:sp>
         <p:nvSpPr>
-          <p:cNvPr id="3" name="Text 1"/>
+          <p:cNvPr id="4" name="Text 1"/>
           <p:cNvSpPr txBox="1"/>
           <p:nvPr/>
         </p:nvSpPr>
@@ -5497,7 +5573,7 @@
       </p:sp>
       <p:sp>
         <p:nvSpPr>
-          <p:cNvPr id="4" name="Text 2"/>
+          <p:cNvPr id="5" name="Text 2"/>
           <p:cNvSpPr txBox="1"/>
           <p:nvPr/>
         </p:nvSpPr>
@@ -8144,7 +8220,7 @@
       </p:graphicFrame>
       <p:sp>
         <p:nvSpPr>
-          <p:cNvPr id="6" name="Text 3"/>
+          <p:cNvPr id="7" name="Text 3"/>
           <p:cNvSpPr txBox="1"/>
           <p:nvPr/>
         </p:nvSpPr>
@@ -8183,7 +8259,7 @@
       </p:sp>
       <p:sp>
         <p:nvSpPr>
-          <p:cNvPr id="7" name="Shape 4"/>
+          <p:cNvPr id="8" name="Shape 4"/>
           <p:cNvSpPr/>
           <p:nvPr/>
         </p:nvSpPr>
@@ -8217,7 +8293,7 @@
       </p:sp>
       <p:sp>
         <p:nvSpPr>
-          <p:cNvPr id="8" name="Text 5"/>
+          <p:cNvPr id="9" name="Text 5"/>
           <p:cNvSpPr txBox="1"/>
           <p:nvPr/>
         </p:nvSpPr>
@@ -8256,7 +8332,7 @@
       </p:sp>
       <p:sp>
         <p:nvSpPr>
-          <p:cNvPr id="9" name="Text 6"/>
+          <p:cNvPr id="10" name="Text 6"/>
           <p:cNvSpPr txBox="1"/>
           <p:nvPr/>
         </p:nvSpPr>
@@ -8295,7 +8371,7 @@
       </p:sp>
       <p:sp>
         <p:nvSpPr>
-          <p:cNvPr id="10" name="Shape 7"/>
+          <p:cNvPr id="11" name="Shape 7"/>
           <p:cNvSpPr/>
           <p:nvPr/>
         </p:nvSpPr>
@@ -8329,7 +8405,7 @@
       </p:sp>
       <p:sp>
         <p:nvSpPr>
-          <p:cNvPr id="11" name="Text 8"/>
+          <p:cNvPr id="12" name="Text 8"/>
           <p:cNvSpPr txBox="1"/>
           <p:nvPr/>
         </p:nvSpPr>
@@ -8368,7 +8444,7 @@
       </p:sp>
       <p:sp>
         <p:nvSpPr>
-          <p:cNvPr id="12" name="Text 9"/>
+          <p:cNvPr id="13" name="Text 9"/>
           <p:cNvSpPr txBox="1"/>
           <p:nvPr/>
         </p:nvSpPr>
@@ -8407,7 +8483,7 @@
       </p:sp>
       <p:sp>
         <p:nvSpPr>
-          <p:cNvPr id="13" name="Shape 10"/>
+          <p:cNvPr id="14" name="Shape 10"/>
           <p:cNvSpPr/>
           <p:nvPr/>
         </p:nvSpPr>
@@ -8441,7 +8517,7 @@
       </p:sp>
       <p:sp>
         <p:nvSpPr>
-          <p:cNvPr id="14" name="Text 11"/>
+          <p:cNvPr id="15" name="Text 11"/>
           <p:cNvSpPr txBox="1"/>
           <p:nvPr/>
         </p:nvSpPr>
@@ -8480,7 +8556,7 @@
       </p:sp>
       <p:sp>
         <p:nvSpPr>
-          <p:cNvPr id="15" name="Text 12"/>
+          <p:cNvPr id="16" name="Text 12"/>
           <p:cNvSpPr txBox="1"/>
           <p:nvPr/>
         </p:nvSpPr>
@@ -8519,7 +8595,7 @@
       </p:sp>
       <p:sp>
         <p:nvSpPr>
-          <p:cNvPr id="16" name="Shape 13"/>
+          <p:cNvPr id="17" name="Shape 13"/>
           <p:cNvSpPr/>
           <p:nvPr/>
         </p:nvSpPr>
@@ -8553,7 +8629,7 @@
       </p:sp>
       <p:sp>
         <p:nvSpPr>
-          <p:cNvPr id="17" name="Text 14"/>
+          <p:cNvPr id="18" name="Text 14"/>
           <p:cNvSpPr txBox="1"/>
           <p:nvPr/>
         </p:nvSpPr>
@@ -8592,7 +8668,7 @@
       </p:sp>
       <p:sp>
         <p:nvSpPr>
-          <p:cNvPr id="18" name="Text 15"/>
+          <p:cNvPr id="19" name="Text 15"/>
           <p:cNvSpPr txBox="1"/>
           <p:nvPr/>
         </p:nvSpPr>
@@ -8631,7 +8707,7 @@
       </p:sp>
       <p:sp>
         <p:nvSpPr>
-          <p:cNvPr id="19" name="Shape 16"/>
+          <p:cNvPr id="20" name="Shape 16"/>
           <p:cNvSpPr/>
           <p:nvPr/>
         </p:nvSpPr>
@@ -8665,7 +8741,7 @@
       </p:sp>
       <p:sp>
         <p:nvSpPr>
-          <p:cNvPr id="20" name="Text 17"/>
+          <p:cNvPr id="21" name="Text 17"/>
           <p:cNvSpPr txBox="1"/>
           <p:nvPr/>
         </p:nvSpPr>
@@ -8704,7 +8780,7 @@
       </p:sp>
       <p:sp>
         <p:nvSpPr>
-          <p:cNvPr id="21" name="Text 18"/>
+          <p:cNvPr id="22" name="Text 18"/>
           <p:cNvSpPr txBox="1"/>
           <p:nvPr/>
         </p:nvSpPr>
@@ -8773,9 +8849,33 @@
           <a:chExt cx="0" cy="0"/>
         </a:xfrm>
       </p:grpSpPr>
-      <p:sp>
-        <p:nvSpPr>
-          <p:cNvPr id="2" name="Text 0"/>
+      <p:pic>
+        <p:nvPicPr>
+          <p:cNvPr id="2" name="Image 0" descr="정석항공과학고등학교 교표">    </p:cNvPr>
+          <p:cNvPicPr>
+            <a:picLocks noChangeAspect="1"/>
+          </p:cNvPicPr>
+          <p:nvPr/>
+        </p:nvPicPr>
+        <p:blipFill>
+          <a:blip r:embed="rId1"/>
+          <a:stretch>
+            <a:fillRect/>
+          </a:stretch>
+        </p:blipFill>
+        <p:spPr>
+          <a:xfrm>
+            <a:off x="10753344" y="384048"/>
+            <a:ext cx="841248" cy="360274"/>
+          </a:xfrm>
+          <a:prstGeom prst="rect">
+            <a:avLst/>
+          </a:prstGeom>
+        </p:spPr>
+      </p:pic>
+      <p:sp>
+        <p:nvSpPr>
+          <p:cNvPr id="3" name="Text 0"/>
           <p:cNvSpPr txBox="1"/>
           <p:nvPr/>
         </p:nvSpPr>
@@ -8814,7 +8914,7 @@
       </p:sp>
       <p:sp>
         <p:nvSpPr>
-          <p:cNvPr id="3" name="Text 1"/>
+          <p:cNvPr id="4" name="Text 1"/>
           <p:cNvSpPr txBox="1"/>
           <p:nvPr/>
         </p:nvSpPr>
@@ -8853,7 +8953,7 @@
       </p:sp>
       <p:sp>
         <p:nvSpPr>
-          <p:cNvPr id="4" name="Shape 2"/>
+          <p:cNvPr id="5" name="Shape 2"/>
           <p:cNvSpPr/>
           <p:nvPr/>
         </p:nvSpPr>
@@ -8887,7 +8987,7 @@
       </p:sp>
       <p:sp>
         <p:nvSpPr>
-          <p:cNvPr id="5" name="Shape 3"/>
+          <p:cNvPr id="6" name="Shape 3"/>
           <p:cNvSpPr/>
           <p:nvPr/>
         </p:nvSpPr>
@@ -8907,7 +9007,7 @@
       </p:sp>
       <p:sp>
         <p:nvSpPr>
-          <p:cNvPr id="6" name="Text 4"/>
+          <p:cNvPr id="7" name="Text 4"/>
           <p:cNvSpPr txBox="1"/>
           <p:nvPr/>
         </p:nvSpPr>
@@ -8946,7 +9046,7 @@
       </p:sp>
       <p:sp>
         <p:nvSpPr>
-          <p:cNvPr id="7" name="Text 5"/>
+          <p:cNvPr id="8" name="Text 5"/>
           <p:cNvSpPr txBox="1"/>
           <p:nvPr/>
         </p:nvSpPr>
@@ -9008,7 +9108,7 @@
       </p:sp>
       <p:sp>
         <p:nvSpPr>
-          <p:cNvPr id="8" name="Text 6"/>
+          <p:cNvPr id="9" name="Text 6"/>
           <p:cNvSpPr txBox="1"/>
           <p:nvPr/>
         </p:nvSpPr>
@@ -9047,7 +9147,7 @@
       </p:sp>
       <p:sp>
         <p:nvSpPr>
-          <p:cNvPr id="9" name="Shape 7"/>
+          <p:cNvPr id="10" name="Shape 7"/>
           <p:cNvSpPr/>
           <p:nvPr/>
         </p:nvSpPr>
@@ -9067,7 +9167,7 @@
       </p:sp>
       <p:sp>
         <p:nvSpPr>
-          <p:cNvPr id="10" name="Shape 8"/>
+          <p:cNvPr id="11" name="Shape 8"/>
           <p:cNvSpPr/>
           <p:nvPr/>
         </p:nvSpPr>
@@ -9101,7 +9201,7 @@
       </p:sp>
       <p:sp>
         <p:nvSpPr>
-          <p:cNvPr id="11" name="Shape 9"/>
+          <p:cNvPr id="12" name="Shape 9"/>
           <p:cNvSpPr/>
           <p:nvPr/>
         </p:nvSpPr>
@@ -9121,7 +9221,7 @@
       </p:sp>
       <p:sp>
         <p:nvSpPr>
-          <p:cNvPr id="12" name="Text 10"/>
+          <p:cNvPr id="13" name="Text 10"/>
           <p:cNvSpPr txBox="1"/>
           <p:nvPr/>
         </p:nvSpPr>
@@ -9160,7 +9260,7 @@
       </p:sp>
       <p:sp>
         <p:nvSpPr>
-          <p:cNvPr id="13" name="Text 11"/>
+          <p:cNvPr id="14" name="Text 11"/>
           <p:cNvSpPr txBox="1"/>
           <p:nvPr/>
         </p:nvSpPr>
@@ -9222,7 +9322,7 @@
       </p:sp>
       <p:sp>
         <p:nvSpPr>
-          <p:cNvPr id="14" name="Text 12"/>
+          <p:cNvPr id="15" name="Text 12"/>
           <p:cNvSpPr txBox="1"/>
           <p:nvPr/>
         </p:nvSpPr>
@@ -9261,7 +9361,7 @@
       </p:sp>
       <p:sp>
         <p:nvSpPr>
-          <p:cNvPr id="15" name="Shape 13"/>
+          <p:cNvPr id="16" name="Shape 13"/>
           <p:cNvSpPr/>
           <p:nvPr/>
         </p:nvSpPr>
@@ -9281,7 +9381,7 @@
       </p:sp>
       <p:sp>
         <p:nvSpPr>
-          <p:cNvPr id="16" name="Shape 14"/>
+          <p:cNvPr id="17" name="Shape 14"/>
           <p:cNvSpPr/>
           <p:nvPr/>
         </p:nvSpPr>
@@ -9315,7 +9415,7 @@
       </p:sp>
       <p:sp>
         <p:nvSpPr>
-          <p:cNvPr id="17" name="Shape 15"/>
+          <p:cNvPr id="18" name="Shape 15"/>
           <p:cNvSpPr/>
           <p:nvPr/>
         </p:nvSpPr>
@@ -9335,7 +9435,7 @@
       </p:sp>
       <p:sp>
         <p:nvSpPr>
-          <p:cNvPr id="18" name="Text 16"/>
+          <p:cNvPr id="19" name="Text 16"/>
           <p:cNvSpPr txBox="1"/>
           <p:nvPr/>
         </p:nvSpPr>
@@ -9374,7 +9474,7 @@
       </p:sp>
       <p:sp>
         <p:nvSpPr>
-          <p:cNvPr id="19" name="Text 17"/>
+          <p:cNvPr id="20" name="Text 17"/>
           <p:cNvSpPr txBox="1"/>
           <p:nvPr/>
         </p:nvSpPr>
@@ -9456,7 +9556,7 @@
       </p:sp>
       <p:sp>
         <p:nvSpPr>
-          <p:cNvPr id="20" name="Text 18"/>
+          <p:cNvPr id="21" name="Text 18"/>
           <p:cNvSpPr txBox="1"/>
           <p:nvPr/>
         </p:nvSpPr>
@@ -9495,7 +9595,7 @@
       </p:sp>
       <p:sp>
         <p:nvSpPr>
-          <p:cNvPr id="21" name="Shape 19"/>
+          <p:cNvPr id="22" name="Shape 19"/>
           <p:cNvSpPr/>
           <p:nvPr/>
         </p:nvSpPr>
@@ -9515,7 +9615,7 @@
       </p:sp>
       <p:sp>
         <p:nvSpPr>
-          <p:cNvPr id="22" name="Shape 20"/>
+          <p:cNvPr id="23" name="Shape 20"/>
           <p:cNvSpPr/>
           <p:nvPr/>
         </p:nvSpPr>
@@ -9549,7 +9649,7 @@
       </p:sp>
       <p:sp>
         <p:nvSpPr>
-          <p:cNvPr id="23" name="Shape 21"/>
+          <p:cNvPr id="24" name="Shape 21"/>
           <p:cNvSpPr/>
           <p:nvPr/>
         </p:nvSpPr>
@@ -9569,7 +9669,7 @@
       </p:sp>
       <p:sp>
         <p:nvSpPr>
-          <p:cNvPr id="24" name="Text 22"/>
+          <p:cNvPr id="25" name="Text 22"/>
           <p:cNvSpPr txBox="1"/>
           <p:nvPr/>
         </p:nvSpPr>
@@ -9608,7 +9708,7 @@
       </p:sp>
       <p:sp>
         <p:nvSpPr>
-          <p:cNvPr id="25" name="Text 23"/>
+          <p:cNvPr id="26" name="Text 23"/>
           <p:cNvSpPr txBox="1"/>
           <p:nvPr/>
         </p:nvSpPr>
@@ -9670,7 +9770,7 @@
       </p:sp>
       <p:sp>
         <p:nvSpPr>
-          <p:cNvPr id="26" name="Text 24"/>
+          <p:cNvPr id="27" name="Text 24"/>
           <p:cNvSpPr txBox="1"/>
           <p:nvPr/>
         </p:nvSpPr>
@@ -9709,7 +9809,7 @@
       </p:sp>
       <p:sp>
         <p:nvSpPr>
-          <p:cNvPr id="27" name="Shape 25"/>
+          <p:cNvPr id="28" name="Shape 25"/>
           <p:cNvSpPr/>
           <p:nvPr/>
         </p:nvSpPr>
@@ -9729,7 +9829,7 @@
       </p:sp>
       <p:sp>
         <p:nvSpPr>
-          <p:cNvPr id="28" name="Shape 26"/>
+          <p:cNvPr id="29" name="Shape 26"/>
           <p:cNvSpPr/>
           <p:nvPr/>
         </p:nvSpPr>
@@ -9763,7 +9863,7 @@
       </p:sp>
       <p:sp>
         <p:nvSpPr>
-          <p:cNvPr id="29" name="Shape 27"/>
+          <p:cNvPr id="30" name="Shape 27"/>
           <p:cNvSpPr/>
           <p:nvPr/>
         </p:nvSpPr>
@@ -9783,7 +9883,7 @@
       </p:sp>
       <p:sp>
         <p:nvSpPr>
-          <p:cNvPr id="30" name="Text 28"/>
+          <p:cNvPr id="31" name="Text 28"/>
           <p:cNvSpPr txBox="1"/>
           <p:nvPr/>
         </p:nvSpPr>
@@ -9822,7 +9922,7 @@
       </p:sp>
       <p:sp>
         <p:nvSpPr>
-          <p:cNvPr id="31" name="Text 29"/>
+          <p:cNvPr id="32" name="Text 29"/>
           <p:cNvSpPr txBox="1"/>
           <p:nvPr/>
         </p:nvSpPr>
@@ -9864,7 +9964,7 @@
       </p:sp>
       <p:sp>
         <p:nvSpPr>
-          <p:cNvPr id="32" name="Text 30"/>
+          <p:cNvPr id="33" name="Text 30"/>
           <p:cNvSpPr txBox="1"/>
           <p:nvPr/>
         </p:nvSpPr>
@@ -9903,7 +10003,7 @@
       </p:sp>
       <p:sp>
         <p:nvSpPr>
-          <p:cNvPr id="33" name="Shape 31"/>
+          <p:cNvPr id="34" name="Shape 31"/>
           <p:cNvSpPr/>
           <p:nvPr/>
         </p:nvSpPr>
@@ -9937,7 +10037,7 @@
       </p:sp>
       <p:sp>
         <p:nvSpPr>
-          <p:cNvPr id="34" name="Text 32"/>
+          <p:cNvPr id="35" name="Text 32"/>
           <p:cNvSpPr txBox="1"/>
           <p:nvPr/>
         </p:nvSpPr>
@@ -10006,9 +10106,33 @@
           <a:chExt cx="0" cy="0"/>
         </a:xfrm>
       </p:grpSpPr>
-      <p:sp>
-        <p:nvSpPr>
-          <p:cNvPr id="2" name="Text 0"/>
+      <p:pic>
+        <p:nvPicPr>
+          <p:cNvPr id="2" name="Image 0" descr="정석항공과학고등학교 교표">    </p:cNvPr>
+          <p:cNvPicPr>
+            <a:picLocks noChangeAspect="1"/>
+          </p:cNvPicPr>
+          <p:nvPr/>
+        </p:nvPicPr>
+        <p:blipFill>
+          <a:blip r:embed="rId1"/>
+          <a:stretch>
+            <a:fillRect/>
+          </a:stretch>
+        </p:blipFill>
+        <p:spPr>
+          <a:xfrm>
+            <a:off x="10753344" y="384048"/>
+            <a:ext cx="841248" cy="360274"/>
+          </a:xfrm>
+          <a:prstGeom prst="rect">
+            <a:avLst/>
+          </a:prstGeom>
+        </p:spPr>
+      </p:pic>
+      <p:sp>
+        <p:nvSpPr>
+          <p:cNvPr id="3" name="Text 0"/>
           <p:cNvSpPr txBox="1"/>
           <p:nvPr/>
         </p:nvSpPr>
@@ -10047,7 +10171,7 @@
       </p:sp>
       <p:sp>
         <p:nvSpPr>
-          <p:cNvPr id="3" name="Text 1"/>
+          <p:cNvPr id="4" name="Text 1"/>
           <p:cNvSpPr txBox="1"/>
           <p:nvPr/>
         </p:nvSpPr>
@@ -10086,7 +10210,7 @@
       </p:sp>
       <p:sp>
         <p:nvSpPr>
-          <p:cNvPr id="4" name="Shape 2"/>
+          <p:cNvPr id="5" name="Shape 2"/>
           <p:cNvSpPr/>
           <p:nvPr/>
         </p:nvSpPr>
@@ -10120,7 +10244,7 @@
       </p:sp>
       <p:sp>
         <p:nvSpPr>
-          <p:cNvPr id="5" name="Shape 3"/>
+          <p:cNvPr id="6" name="Shape 3"/>
           <p:cNvSpPr/>
           <p:nvPr/>
         </p:nvSpPr>
@@ -10140,7 +10264,7 @@
       </p:sp>
       <p:sp>
         <p:nvSpPr>
-          <p:cNvPr id="6" name="Text 4"/>
+          <p:cNvPr id="7" name="Text 4"/>
           <p:cNvSpPr txBox="1"/>
           <p:nvPr/>
         </p:nvSpPr>
@@ -10179,7 +10303,7 @@
       </p:sp>
       <p:sp>
         <p:nvSpPr>
-          <p:cNvPr id="7" name="Text 5"/>
+          <p:cNvPr id="8" name="Text 5"/>
           <p:cNvSpPr txBox="1"/>
           <p:nvPr/>
         </p:nvSpPr>
@@ -10221,7 +10345,7 @@
       </p:sp>
       <p:sp>
         <p:nvSpPr>
-          <p:cNvPr id="8" name="Shape 6"/>
+          <p:cNvPr id="9" name="Shape 6"/>
           <p:cNvSpPr/>
           <p:nvPr/>
         </p:nvSpPr>
@@ -10241,7 +10365,7 @@
       </p:sp>
       <p:sp>
         <p:nvSpPr>
-          <p:cNvPr id="9" name="Shape 7"/>
+          <p:cNvPr id="10" name="Shape 7"/>
           <p:cNvSpPr/>
           <p:nvPr/>
         </p:nvSpPr>
@@ -10275,7 +10399,7 @@
       </p:sp>
       <p:sp>
         <p:nvSpPr>
-          <p:cNvPr id="10" name="Shape 8"/>
+          <p:cNvPr id="11" name="Shape 8"/>
           <p:cNvSpPr/>
           <p:nvPr/>
         </p:nvSpPr>
@@ -10295,7 +10419,7 @@
       </p:sp>
       <p:sp>
         <p:nvSpPr>
-          <p:cNvPr id="11" name="Text 9"/>
+          <p:cNvPr id="12" name="Text 9"/>
           <p:cNvSpPr txBox="1"/>
           <p:nvPr/>
         </p:nvSpPr>
@@ -10334,7 +10458,7 @@
       </p:sp>
       <p:sp>
         <p:nvSpPr>
-          <p:cNvPr id="12" name="Text 10"/>
+          <p:cNvPr id="13" name="Text 10"/>
           <p:cNvSpPr txBox="1"/>
           <p:nvPr/>
         </p:nvSpPr>
@@ -10376,7 +10500,7 @@
       </p:sp>
       <p:sp>
         <p:nvSpPr>
-          <p:cNvPr id="13" name="Text 11"/>
+          <p:cNvPr id="14" name="Text 11"/>
           <p:cNvSpPr txBox="1"/>
           <p:nvPr/>
         </p:nvSpPr>
@@ -10418,7 +10542,7 @@
       </p:sp>
       <p:sp>
         <p:nvSpPr>
-          <p:cNvPr id="14" name="Shape 12"/>
+          <p:cNvPr id="15" name="Shape 12"/>
           <p:cNvSpPr/>
           <p:nvPr/>
         </p:nvSpPr>
@@ -10438,7 +10562,7 @@
       </p:sp>
       <p:sp>
         <p:nvSpPr>
-          <p:cNvPr id="15" name="Shape 13"/>
+          <p:cNvPr id="16" name="Shape 13"/>
           <p:cNvSpPr/>
           <p:nvPr/>
         </p:nvSpPr>
@@ -10472,7 +10596,7 @@
       </p:sp>
       <p:sp>
         <p:nvSpPr>
-          <p:cNvPr id="16" name="Shape 14"/>
+          <p:cNvPr id="17" name="Shape 14"/>
           <p:cNvSpPr/>
           <p:nvPr/>
         </p:nvSpPr>
@@ -10492,7 +10616,7 @@
       </p:sp>
       <p:sp>
         <p:nvSpPr>
-          <p:cNvPr id="17" name="Text 15"/>
+          <p:cNvPr id="18" name="Text 15"/>
           <p:cNvSpPr txBox="1"/>
           <p:nvPr/>
         </p:nvSpPr>
@@ -10531,7 +10655,7 @@
       </p:sp>
       <p:sp>
         <p:nvSpPr>
-          <p:cNvPr id="18" name="Text 16"/>
+          <p:cNvPr id="19" name="Text 16"/>
           <p:cNvSpPr txBox="1"/>
           <p:nvPr/>
         </p:nvSpPr>
@@ -10593,7 +10717,7 @@
       </p:sp>
       <p:sp>
         <p:nvSpPr>
-          <p:cNvPr id="19" name="Text 17"/>
+          <p:cNvPr id="20" name="Text 17"/>
           <p:cNvSpPr txBox="1"/>
           <p:nvPr/>
         </p:nvSpPr>
@@ -10655,7 +10779,7 @@
       </p:sp>
       <p:sp>
         <p:nvSpPr>
-          <p:cNvPr id="20" name="Shape 18"/>
+          <p:cNvPr id="21" name="Shape 18"/>
           <p:cNvSpPr/>
           <p:nvPr/>
         </p:nvSpPr>
@@ -10675,7 +10799,7 @@
       </p:sp>
       <p:sp>
         <p:nvSpPr>
-          <p:cNvPr id="21" name="Shape 19"/>
+          <p:cNvPr id="22" name="Shape 19"/>
           <p:cNvSpPr/>
           <p:nvPr/>
         </p:nvSpPr>
@@ -10709,7 +10833,7 @@
       </p:sp>
       <p:sp>
         <p:nvSpPr>
-          <p:cNvPr id="22" name="Shape 20"/>
+          <p:cNvPr id="23" name="Shape 20"/>
           <p:cNvSpPr/>
           <p:nvPr/>
         </p:nvSpPr>
@@ -10729,7 +10853,7 @@
       </p:sp>
       <p:sp>
         <p:nvSpPr>
-          <p:cNvPr id="23" name="Text 21"/>
+          <p:cNvPr id="24" name="Text 21"/>
           <p:cNvSpPr txBox="1"/>
           <p:nvPr/>
         </p:nvSpPr>
@@ -10768,7 +10892,7 @@
       </p:sp>
       <p:sp>
         <p:nvSpPr>
-          <p:cNvPr id="24" name="Text 22"/>
+          <p:cNvPr id="25" name="Text 22"/>
           <p:cNvSpPr txBox="1"/>
           <p:nvPr/>
         </p:nvSpPr>
@@ -10830,7 +10954,7 @@
       </p:sp>
       <p:sp>
         <p:nvSpPr>
-          <p:cNvPr id="25" name="Text 23"/>
+          <p:cNvPr id="26" name="Text 23"/>
           <p:cNvSpPr txBox="1"/>
           <p:nvPr/>
         </p:nvSpPr>
@@ -10915,7 +11039,7 @@
       </p:sp>
       <p:sp>
         <p:nvSpPr>
-          <p:cNvPr id="26" name="Shape 24"/>
+          <p:cNvPr id="27" name="Shape 24"/>
           <p:cNvSpPr/>
           <p:nvPr/>
         </p:nvSpPr>
@@ -10935,7 +11059,7 @@
       </p:sp>
       <p:sp>
         <p:nvSpPr>
-          <p:cNvPr id="27" name="Shape 25"/>
+          <p:cNvPr id="28" name="Shape 25"/>
           <p:cNvSpPr/>
           <p:nvPr/>
         </p:nvSpPr>
@@ -10969,7 +11093,7 @@
       </p:sp>
       <p:sp>
         <p:nvSpPr>
-          <p:cNvPr id="28" name="Shape 26"/>
+          <p:cNvPr id="29" name="Shape 26"/>
           <p:cNvSpPr/>
           <p:nvPr/>
         </p:nvSpPr>
@@ -10989,7 +11113,7 @@
       </p:sp>
       <p:sp>
         <p:nvSpPr>
-          <p:cNvPr id="29" name="Text 27"/>
+          <p:cNvPr id="30" name="Text 27"/>
           <p:cNvSpPr txBox="1"/>
           <p:nvPr/>
         </p:nvSpPr>
@@ -11028,7 +11152,7 @@
       </p:sp>
       <p:sp>
         <p:nvSpPr>
-          <p:cNvPr id="30" name="Text 28"/>
+          <p:cNvPr id="31" name="Text 28"/>
           <p:cNvSpPr txBox="1"/>
           <p:nvPr/>
         </p:nvSpPr>
@@ -11090,7 +11214,7 @@
       </p:sp>
       <p:sp>
         <p:nvSpPr>
-          <p:cNvPr id="31" name="Text 29"/>
+          <p:cNvPr id="32" name="Text 29"/>
           <p:cNvSpPr txBox="1"/>
           <p:nvPr/>
         </p:nvSpPr>
@@ -11132,7 +11256,7 @@
       </p:sp>
       <p:sp>
         <p:nvSpPr>
-          <p:cNvPr id="32" name="Shape 30"/>
+          <p:cNvPr id="33" name="Shape 30"/>
           <p:cNvSpPr/>
           <p:nvPr/>
         </p:nvSpPr>
@@ -11166,7 +11290,7 @@
       </p:sp>
       <p:sp>
         <p:nvSpPr>
-          <p:cNvPr id="33" name="Text 31"/>
+          <p:cNvPr id="34" name="Text 31"/>
           <p:cNvSpPr txBox="1"/>
           <p:nvPr/>
         </p:nvSpPr>
@@ -11205,7 +11329,7 @@
       </p:sp>
       <p:sp>
         <p:nvSpPr>
-          <p:cNvPr id="34" name="Text 32"/>
+          <p:cNvPr id="35" name="Text 32"/>
           <p:cNvSpPr txBox="1"/>
           <p:nvPr/>
         </p:nvSpPr>
@@ -11247,7 +11371,7 @@
       </p:sp>
       <p:sp>
         <p:nvSpPr>
-          <p:cNvPr id="35" name="Shape 33"/>
+          <p:cNvPr id="36" name="Shape 33"/>
           <p:cNvSpPr/>
           <p:nvPr/>
         </p:nvSpPr>
@@ -11281,7 +11405,7 @@
       </p:sp>
       <p:sp>
         <p:nvSpPr>
-          <p:cNvPr id="36" name="Text 34"/>
+          <p:cNvPr id="37" name="Text 34"/>
           <p:cNvSpPr txBox="1"/>
           <p:nvPr/>
         </p:nvSpPr>
@@ -11320,7 +11444,7 @@
       </p:sp>
       <p:sp>
         <p:nvSpPr>
-          <p:cNvPr id="37" name="Text 35"/>
+          <p:cNvPr id="38" name="Text 35"/>
           <p:cNvSpPr txBox="1"/>
           <p:nvPr/>
         </p:nvSpPr>
@@ -11392,9 +11516,33 @@
           <a:chExt cx="0" cy="0"/>
         </a:xfrm>
       </p:grpSpPr>
-      <p:sp>
-        <p:nvSpPr>
-          <p:cNvPr id="2" name="Text 0"/>
+      <p:pic>
+        <p:nvPicPr>
+          <p:cNvPr id="2" name="Image 0" descr="정석항공과학고등학교 교표">    </p:cNvPr>
+          <p:cNvPicPr>
+            <a:picLocks noChangeAspect="1"/>
+          </p:cNvPicPr>
+          <p:nvPr/>
+        </p:nvPicPr>
+        <p:blipFill>
+          <a:blip r:embed="rId1"/>
+          <a:stretch>
+            <a:fillRect/>
+          </a:stretch>
+        </p:blipFill>
+        <p:spPr>
+          <a:xfrm>
+            <a:off x="10753344" y="384048"/>
+            <a:ext cx="841248" cy="360274"/>
+          </a:xfrm>
+          <a:prstGeom prst="rect">
+            <a:avLst/>
+          </a:prstGeom>
+        </p:spPr>
+      </p:pic>
+      <p:sp>
+        <p:nvSpPr>
+          <p:cNvPr id="3" name="Text 0"/>
           <p:cNvSpPr txBox="1"/>
           <p:nvPr/>
         </p:nvSpPr>
@@ -11433,7 +11581,7 @@
       </p:sp>
       <p:sp>
         <p:nvSpPr>
-          <p:cNvPr id="3" name="Text 1"/>
+          <p:cNvPr id="4" name="Text 1"/>
           <p:cNvSpPr txBox="1"/>
           <p:nvPr/>
         </p:nvSpPr>
@@ -11472,66 +11620,7 @@
       </p:sp>
       <p:sp>
         <p:nvSpPr>
-          <p:cNvPr id="4" name="Shape 2"/>
-          <p:cNvSpPr/>
-          <p:nvPr/>
-        </p:nvSpPr>
-        <p:spPr>
-          <a:xfrm>
-            <a:off x="11119104" y="512064"/>
-            <a:ext cx="475488" cy="475488"/>
-          </a:xfrm>
-          <a:prstGeom prst="ellipse">
-            <a:avLst/>
-          </a:prstGeom>
-          <a:solidFill>
-            <a:srgbClr val="1E2761"/>
-          </a:solidFill>
-          <a:ln/>
-        </p:spPr>
-      </p:sp>
-      <p:sp>
-        <p:nvSpPr>
-          <p:cNvPr id="5" name="Text 3"/>
-          <p:cNvSpPr txBox="1"/>
-          <p:nvPr/>
-        </p:nvSpPr>
-        <p:spPr>
-          <a:xfrm>
-            <a:off x="11119104" y="512064"/>
-            <a:ext cx="475488" cy="475488"/>
-          </a:xfrm>
-          <a:prstGeom prst="rect">
-            <a:avLst/>
-          </a:prstGeom>
-          <a:noFill/>
-          <a:ln/>
-        </p:spPr>
-        <p:txBody>
-          <a:bodyPr wrap="square" lIns="0" tIns="0" rIns="0" bIns="0" rtlCol="0" anchor="ctr"/>
-          <a:lstStyle/>
-          <a:p>
-            <a:pPr algn="ctr" indent="0" marL="0">
-              <a:buNone/>
-            </a:pPr>
-            <a:r>
-              <a:rPr lang="en-US" sz="1500" b="1" dirty="0">
-                <a:solidFill>
-                  <a:srgbClr val="FFFFFF"/>
-                </a:solidFill>
-                <a:latin typeface="맑은 고딕" pitchFamily="34" charset="0"/>
-                <a:ea typeface="맑은 고딕" pitchFamily="34" charset="-122"/>
-                <a:cs typeface="맑은 고딕" pitchFamily="34" charset="-120"/>
-              </a:rPr>
-              <a:t>1</a:t>
-            </a:r>
-            <a:endParaRPr lang="en-US" sz="1500" dirty="0"/>
-          </a:p>
-        </p:txBody>
-      </p:sp>
-      <p:sp>
-        <p:nvSpPr>
-          <p:cNvPr id="6" name="Shape 4"/>
+          <p:cNvPr id="5" name="Shape 2"/>
           <p:cNvSpPr/>
           <p:nvPr/>
         </p:nvSpPr>
@@ -11565,7 +11654,7 @@
       </p:sp>
       <p:sp>
         <p:nvSpPr>
-          <p:cNvPr id="7" name="Text 5"/>
+          <p:cNvPr id="6" name="Text 3"/>
           <p:cNvSpPr txBox="1"/>
           <p:nvPr/>
         </p:nvSpPr>
@@ -11604,7 +11693,7 @@
       </p:sp>
       <p:sp>
         <p:nvSpPr>
-          <p:cNvPr id="8" name="Shape 6"/>
+          <p:cNvPr id="7" name="Shape 4"/>
           <p:cNvSpPr/>
           <p:nvPr/>
         </p:nvSpPr>
@@ -11624,7 +11713,7 @@
       </p:sp>
       <p:sp>
         <p:nvSpPr>
-          <p:cNvPr id="9" name="Text 7"/>
+          <p:cNvPr id="8" name="Text 5"/>
           <p:cNvSpPr txBox="1"/>
           <p:nvPr/>
         </p:nvSpPr>
@@ -11666,7 +11755,7 @@
       </p:sp>
       <p:sp>
         <p:nvSpPr>
-          <p:cNvPr id="10" name="Shape 8"/>
+          <p:cNvPr id="9" name="Shape 6"/>
           <p:cNvSpPr/>
           <p:nvPr/>
         </p:nvSpPr>
@@ -11686,7 +11775,7 @@
       </p:sp>
       <p:sp>
         <p:nvSpPr>
-          <p:cNvPr id="11" name="Text 9"/>
+          <p:cNvPr id="10" name="Text 7"/>
           <p:cNvSpPr txBox="1"/>
           <p:nvPr/>
         </p:nvSpPr>
@@ -11728,7 +11817,7 @@
       </p:sp>
       <p:sp>
         <p:nvSpPr>
-          <p:cNvPr id="12" name="Shape 10"/>
+          <p:cNvPr id="11" name="Shape 8"/>
           <p:cNvSpPr/>
           <p:nvPr/>
         </p:nvSpPr>
@@ -11762,7 +11851,7 @@
       </p:sp>
       <p:sp>
         <p:nvSpPr>
-          <p:cNvPr id="13" name="Text 11"/>
+          <p:cNvPr id="12" name="Text 9"/>
           <p:cNvSpPr txBox="1"/>
           <p:nvPr/>
         </p:nvSpPr>
@@ -11801,7 +11890,7 @@
       </p:sp>
       <p:sp>
         <p:nvSpPr>
-          <p:cNvPr id="14" name="Text 12"/>
+          <p:cNvPr id="13" name="Text 10"/>
           <p:cNvSpPr txBox="1"/>
           <p:nvPr/>
         </p:nvSpPr>
@@ -11840,7 +11929,7 @@
       </p:sp>
       <p:sp>
         <p:nvSpPr>
-          <p:cNvPr id="15" name="Text 13"/>
+          <p:cNvPr id="14" name="Text 11"/>
           <p:cNvSpPr txBox="1"/>
           <p:nvPr/>
         </p:nvSpPr>
@@ -11879,7 +11968,7 @@
       </p:sp>
       <p:sp>
         <p:nvSpPr>
-          <p:cNvPr id="16" name="Shape 14"/>
+          <p:cNvPr id="15" name="Shape 12"/>
           <p:cNvSpPr/>
           <p:nvPr/>
         </p:nvSpPr>
@@ -11913,7 +12002,7 @@
       </p:sp>
       <p:sp>
         <p:nvSpPr>
-          <p:cNvPr id="17" name="Shape 15"/>
+          <p:cNvPr id="16" name="Shape 13"/>
           <p:cNvSpPr/>
           <p:nvPr/>
         </p:nvSpPr>
@@ -11933,7 +12022,7 @@
       </p:sp>
       <p:sp>
         <p:nvSpPr>
-          <p:cNvPr id="18" name="Text 16"/>
+          <p:cNvPr id="17" name="Text 14"/>
           <p:cNvSpPr txBox="1"/>
           <p:nvPr/>
         </p:nvSpPr>
@@ -11972,7 +12061,7 @@
       </p:sp>
       <p:sp>
         <p:nvSpPr>
-          <p:cNvPr id="19" name="Text 17"/>
+          <p:cNvPr id="18" name="Text 15"/>
           <p:cNvSpPr txBox="1"/>
           <p:nvPr/>
         </p:nvSpPr>
@@ -12014,7 +12103,7 @@
       </p:sp>
       <p:sp>
         <p:nvSpPr>
-          <p:cNvPr id="20" name="Shape 18"/>
+          <p:cNvPr id="19" name="Shape 16"/>
           <p:cNvSpPr/>
           <p:nvPr/>
         </p:nvSpPr>
@@ -12048,7 +12137,7 @@
       </p:sp>
       <p:sp>
         <p:nvSpPr>
-          <p:cNvPr id="21" name="Shape 19"/>
+          <p:cNvPr id="20" name="Shape 17"/>
           <p:cNvSpPr/>
           <p:nvPr/>
         </p:nvSpPr>
@@ -12068,7 +12157,7 @@
       </p:sp>
       <p:sp>
         <p:nvSpPr>
-          <p:cNvPr id="22" name="Text 20"/>
+          <p:cNvPr id="21" name="Text 18"/>
           <p:cNvSpPr txBox="1"/>
           <p:nvPr/>
         </p:nvSpPr>
@@ -12107,7 +12196,7 @@
       </p:sp>
       <p:sp>
         <p:nvSpPr>
-          <p:cNvPr id="23" name="Text 21"/>
+          <p:cNvPr id="22" name="Text 19"/>
           <p:cNvSpPr txBox="1"/>
           <p:nvPr/>
         </p:nvSpPr>
@@ -12149,7 +12238,7 @@
       </p:sp>
       <p:sp>
         <p:nvSpPr>
-          <p:cNvPr id="24" name="Shape 22"/>
+          <p:cNvPr id="23" name="Shape 20"/>
           <p:cNvSpPr/>
           <p:nvPr/>
         </p:nvSpPr>
@@ -12183,7 +12272,7 @@
       </p:sp>
       <p:sp>
         <p:nvSpPr>
-          <p:cNvPr id="25" name="Shape 23"/>
+          <p:cNvPr id="24" name="Shape 21"/>
           <p:cNvSpPr/>
           <p:nvPr/>
         </p:nvSpPr>
@@ -12203,7 +12292,7 @@
       </p:sp>
       <p:sp>
         <p:nvSpPr>
-          <p:cNvPr id="26" name="Text 24"/>
+          <p:cNvPr id="25" name="Text 22"/>
           <p:cNvSpPr txBox="1"/>
           <p:nvPr/>
         </p:nvSpPr>
@@ -12242,7 +12331,7 @@
       </p:sp>
       <p:sp>
         <p:nvSpPr>
-          <p:cNvPr id="27" name="Text 25"/>
+          <p:cNvPr id="26" name="Text 23"/>
           <p:cNvSpPr txBox="1"/>
           <p:nvPr/>
         </p:nvSpPr>
@@ -12284,7 +12373,7 @@
       </p:sp>
       <p:sp>
         <p:nvSpPr>
-          <p:cNvPr id="28" name="Shape 26"/>
+          <p:cNvPr id="27" name="Shape 24"/>
           <p:cNvSpPr/>
           <p:nvPr/>
         </p:nvSpPr>
@@ -12318,7 +12407,7 @@
       </p:sp>
       <p:sp>
         <p:nvSpPr>
-          <p:cNvPr id="29" name="Shape 27"/>
+          <p:cNvPr id="28" name="Shape 25"/>
           <p:cNvSpPr/>
           <p:nvPr/>
         </p:nvSpPr>
@@ -12338,7 +12427,7 @@
       </p:sp>
       <p:sp>
         <p:nvSpPr>
-          <p:cNvPr id="30" name="Text 28"/>
+          <p:cNvPr id="29" name="Text 26"/>
           <p:cNvSpPr txBox="1"/>
           <p:nvPr/>
         </p:nvSpPr>
@@ -12377,7 +12466,7 @@
       </p:sp>
       <p:sp>
         <p:nvSpPr>
-          <p:cNvPr id="31" name="Text 29"/>
+          <p:cNvPr id="30" name="Text 27"/>
           <p:cNvSpPr txBox="1"/>
           <p:nvPr/>
         </p:nvSpPr>
@@ -12449,9 +12538,33 @@
           <a:chExt cx="0" cy="0"/>
         </a:xfrm>
       </p:grpSpPr>
-      <p:sp>
-        <p:nvSpPr>
-          <p:cNvPr id="2" name="Text 0"/>
+      <p:pic>
+        <p:nvPicPr>
+          <p:cNvPr id="2" name="Image 0" descr="정석항공과학고등학교 교표">    </p:cNvPr>
+          <p:cNvPicPr>
+            <a:picLocks noChangeAspect="1"/>
+          </p:cNvPicPr>
+          <p:nvPr/>
+        </p:nvPicPr>
+        <p:blipFill>
+          <a:blip r:embed="rId1"/>
+          <a:stretch>
+            <a:fillRect/>
+          </a:stretch>
+        </p:blipFill>
+        <p:spPr>
+          <a:xfrm>
+            <a:off x="10753344" y="384048"/>
+            <a:ext cx="841248" cy="360274"/>
+          </a:xfrm>
+          <a:prstGeom prst="rect">
+            <a:avLst/>
+          </a:prstGeom>
+        </p:spPr>
+      </p:pic>
+      <p:sp>
+        <p:nvSpPr>
+          <p:cNvPr id="3" name="Text 0"/>
           <p:cNvSpPr txBox="1"/>
           <p:nvPr/>
         </p:nvSpPr>
@@ -12490,7 +12603,7 @@
       </p:sp>
       <p:sp>
         <p:nvSpPr>
-          <p:cNvPr id="3" name="Text 1"/>
+          <p:cNvPr id="4" name="Text 1"/>
           <p:cNvSpPr txBox="1"/>
           <p:nvPr/>
         </p:nvSpPr>
@@ -12529,66 +12642,7 @@
       </p:sp>
       <p:sp>
         <p:nvSpPr>
-          <p:cNvPr id="4" name="Shape 2"/>
-          <p:cNvSpPr/>
-          <p:nvPr/>
-        </p:nvSpPr>
-        <p:spPr>
-          <a:xfrm>
-            <a:off x="11119104" y="512064"/>
-            <a:ext cx="475488" cy="475488"/>
-          </a:xfrm>
-          <a:prstGeom prst="ellipse">
-            <a:avLst/>
-          </a:prstGeom>
-          <a:solidFill>
-            <a:srgbClr val="1E2761"/>
-          </a:solidFill>
-          <a:ln/>
-        </p:spPr>
-      </p:sp>
-      <p:sp>
-        <p:nvSpPr>
-          <p:cNvPr id="5" name="Text 3"/>
-          <p:cNvSpPr txBox="1"/>
-          <p:nvPr/>
-        </p:nvSpPr>
-        <p:spPr>
-          <a:xfrm>
-            <a:off x="11119104" y="512064"/>
-            <a:ext cx="475488" cy="475488"/>
-          </a:xfrm>
-          <a:prstGeom prst="rect">
-            <a:avLst/>
-          </a:prstGeom>
-          <a:noFill/>
-          <a:ln/>
-        </p:spPr>
-        <p:txBody>
-          <a:bodyPr wrap="square" lIns="0" tIns="0" rIns="0" bIns="0" rtlCol="0" anchor="ctr"/>
-          <a:lstStyle/>
-          <a:p>
-            <a:pPr algn="ctr" indent="0" marL="0">
-              <a:buNone/>
-            </a:pPr>
-            <a:r>
-              <a:rPr lang="en-US" sz="1500" b="1" dirty="0">
-                <a:solidFill>
-                  <a:srgbClr val="FFFFFF"/>
-                </a:solidFill>
-                <a:latin typeface="맑은 고딕" pitchFamily="34" charset="0"/>
-                <a:ea typeface="맑은 고딕" pitchFamily="34" charset="-122"/>
-                <a:cs typeface="맑은 고딕" pitchFamily="34" charset="-120"/>
-              </a:rPr>
-              <a:t>2</a:t>
-            </a:r>
-            <a:endParaRPr lang="en-US" sz="1500" dirty="0"/>
-          </a:p>
-        </p:txBody>
-      </p:sp>
-      <p:sp>
-        <p:nvSpPr>
-          <p:cNvPr id="6" name="Text 4"/>
+          <p:cNvPr id="5" name="Text 2"/>
           <p:cNvSpPr txBox="1"/>
           <p:nvPr/>
         </p:nvSpPr>
@@ -12641,7 +12695,7 @@
       </p:sp>
       <p:sp>
         <p:nvSpPr>
-          <p:cNvPr id="7" name="Text 5"/>
+          <p:cNvPr id="6" name="Text 3"/>
           <p:cNvSpPr txBox="1"/>
           <p:nvPr/>
         </p:nvSpPr>
@@ -13698,7 +13752,7 @@
       </p:graphicFrame>
       <p:sp>
         <p:nvSpPr>
-          <p:cNvPr id="9" name="Shape 6"/>
+          <p:cNvPr id="8" name="Shape 4"/>
           <p:cNvSpPr/>
           <p:nvPr/>
         </p:nvSpPr>
@@ -13732,7 +13786,7 @@
       </p:sp>
       <p:sp>
         <p:nvSpPr>
-          <p:cNvPr id="10" name="Text 7"/>
+          <p:cNvPr id="9" name="Text 5"/>
           <p:cNvSpPr txBox="1"/>
           <p:nvPr/>
         </p:nvSpPr>
@@ -13794,7 +13848,7 @@
       </p:sp>
       <p:sp>
         <p:nvSpPr>
-          <p:cNvPr id="11" name="Shape 8"/>
+          <p:cNvPr id="10" name="Shape 6"/>
           <p:cNvSpPr/>
           <p:nvPr/>
         </p:nvSpPr>
@@ -13814,7 +13868,7 @@
       </p:sp>
       <p:sp>
         <p:nvSpPr>
-          <p:cNvPr id="12" name="Text 9"/>
+          <p:cNvPr id="11" name="Text 7"/>
           <p:cNvSpPr txBox="1"/>
           <p:nvPr/>
         </p:nvSpPr>
@@ -13856,7 +13910,7 @@
       </p:sp>
       <p:sp>
         <p:nvSpPr>
-          <p:cNvPr id="13" name="Shape 10"/>
+          <p:cNvPr id="12" name="Shape 8"/>
           <p:cNvSpPr/>
           <p:nvPr/>
         </p:nvSpPr>
@@ -13876,7 +13930,7 @@
       </p:sp>
       <p:sp>
         <p:nvSpPr>
-          <p:cNvPr id="14" name="Text 11"/>
+          <p:cNvPr id="13" name="Text 9"/>
           <p:cNvSpPr txBox="1"/>
           <p:nvPr/>
         </p:nvSpPr>
@@ -13918,7 +13972,7 @@
       </p:sp>
       <p:sp>
         <p:nvSpPr>
-          <p:cNvPr id="15" name="Shape 12"/>
+          <p:cNvPr id="14" name="Shape 10"/>
           <p:cNvSpPr/>
           <p:nvPr/>
         </p:nvSpPr>
@@ -13938,7 +13992,7 @@
       </p:sp>
       <p:sp>
         <p:nvSpPr>
-          <p:cNvPr id="16" name="Text 13"/>
+          <p:cNvPr id="15" name="Text 11"/>
           <p:cNvSpPr txBox="1"/>
           <p:nvPr/>
         </p:nvSpPr>
@@ -13980,7 +14034,7 @@
       </p:sp>
       <p:sp>
         <p:nvSpPr>
-          <p:cNvPr id="17" name="Shape 14"/>
+          <p:cNvPr id="16" name="Shape 12"/>
           <p:cNvSpPr/>
           <p:nvPr/>
         </p:nvSpPr>
@@ -14014,7 +14068,7 @@
       </p:sp>
       <p:sp>
         <p:nvSpPr>
-          <p:cNvPr id="18" name="Text 15"/>
+          <p:cNvPr id="17" name="Text 13"/>
           <p:cNvSpPr txBox="1"/>
           <p:nvPr/>
         </p:nvSpPr>
@@ -14083,9 +14137,33 @@
           <a:chExt cx="0" cy="0"/>
         </a:xfrm>
       </p:grpSpPr>
-      <p:sp>
-        <p:nvSpPr>
-          <p:cNvPr id="2" name="Text 0"/>
+      <p:pic>
+        <p:nvPicPr>
+          <p:cNvPr id="2" name="Image 0" descr="정석항공과학고등학교 교표">    </p:cNvPr>
+          <p:cNvPicPr>
+            <a:picLocks noChangeAspect="1"/>
+          </p:cNvPicPr>
+          <p:nvPr/>
+        </p:nvPicPr>
+        <p:blipFill>
+          <a:blip r:embed="rId1"/>
+          <a:stretch>
+            <a:fillRect/>
+          </a:stretch>
+        </p:blipFill>
+        <p:spPr>
+          <a:xfrm>
+            <a:off x="10753344" y="384048"/>
+            <a:ext cx="841248" cy="360274"/>
+          </a:xfrm>
+          <a:prstGeom prst="rect">
+            <a:avLst/>
+          </a:prstGeom>
+        </p:spPr>
+      </p:pic>
+      <p:sp>
+        <p:nvSpPr>
+          <p:cNvPr id="3" name="Text 0"/>
           <p:cNvSpPr txBox="1"/>
           <p:nvPr/>
         </p:nvSpPr>
@@ -14124,7 +14202,7 @@
       </p:sp>
       <p:sp>
         <p:nvSpPr>
-          <p:cNvPr id="3" name="Text 1"/>
+          <p:cNvPr id="4" name="Text 1"/>
           <p:cNvSpPr txBox="1"/>
           <p:nvPr/>
         </p:nvSpPr>
@@ -14163,66 +14241,7 @@
       </p:sp>
       <p:sp>
         <p:nvSpPr>
-          <p:cNvPr id="4" name="Shape 2"/>
-          <p:cNvSpPr/>
-          <p:nvPr/>
-        </p:nvSpPr>
-        <p:spPr>
-          <a:xfrm>
-            <a:off x="11119104" y="512064"/>
-            <a:ext cx="475488" cy="475488"/>
-          </a:xfrm>
-          <a:prstGeom prst="ellipse">
-            <a:avLst/>
-          </a:prstGeom>
-          <a:solidFill>
-            <a:srgbClr val="1E2761"/>
-          </a:solidFill>
-          <a:ln/>
-        </p:spPr>
-      </p:sp>
-      <p:sp>
-        <p:nvSpPr>
-          <p:cNvPr id="5" name="Text 3"/>
-          <p:cNvSpPr txBox="1"/>
-          <p:nvPr/>
-        </p:nvSpPr>
-        <p:spPr>
-          <a:xfrm>
-            <a:off x="11119104" y="512064"/>
-            <a:ext cx="475488" cy="475488"/>
-          </a:xfrm>
-          <a:prstGeom prst="rect">
-            <a:avLst/>
-          </a:prstGeom>
-          <a:noFill/>
-          <a:ln/>
-        </p:spPr>
-        <p:txBody>
-          <a:bodyPr wrap="square" lIns="0" tIns="0" rIns="0" bIns="0" rtlCol="0" anchor="ctr"/>
-          <a:lstStyle/>
-          <a:p>
-            <a:pPr algn="ctr" indent="0" marL="0">
-              <a:buNone/>
-            </a:pPr>
-            <a:r>
-              <a:rPr lang="en-US" sz="1500" b="1" dirty="0">
-                <a:solidFill>
-                  <a:srgbClr val="FFFFFF"/>
-                </a:solidFill>
-                <a:latin typeface="맑은 고딕" pitchFamily="34" charset="0"/>
-                <a:ea typeface="맑은 고딕" pitchFamily="34" charset="-122"/>
-                <a:cs typeface="맑은 고딕" pitchFamily="34" charset="-120"/>
-              </a:rPr>
-              <a:t>3</a:t>
-            </a:r>
-            <a:endParaRPr lang="en-US" sz="1500" dirty="0"/>
-          </a:p>
-        </p:txBody>
-      </p:sp>
-      <p:sp>
-        <p:nvSpPr>
-          <p:cNvPr id="6" name="Text 4"/>
+          <p:cNvPr id="5" name="Text 2"/>
           <p:cNvSpPr txBox="1"/>
           <p:nvPr/>
         </p:nvSpPr>
@@ -14275,7 +14294,7 @@
       </p:sp>
       <p:sp>
         <p:nvSpPr>
-          <p:cNvPr id="7" name="Text 5"/>
+          <p:cNvPr id="6" name="Text 3"/>
           <p:cNvSpPr txBox="1"/>
           <p:nvPr/>
         </p:nvSpPr>
@@ -15332,7 +15351,7 @@
       </p:graphicFrame>
       <p:sp>
         <p:nvSpPr>
-          <p:cNvPr id="9" name="Shape 6"/>
+          <p:cNvPr id="8" name="Shape 4"/>
           <p:cNvSpPr/>
           <p:nvPr/>
         </p:nvSpPr>
@@ -15366,7 +15385,7 @@
       </p:sp>
       <p:sp>
         <p:nvSpPr>
-          <p:cNvPr id="10" name="Text 7"/>
+          <p:cNvPr id="9" name="Text 5"/>
           <p:cNvSpPr txBox="1"/>
           <p:nvPr/>
         </p:nvSpPr>
@@ -15405,7 +15424,7 @@
       </p:sp>
       <p:graphicFrame>
         <p:nvGraphicFramePr>
-          <p:cNvPr id="11" name="Chart 0" descr=""/>
+          <p:cNvPr id="10" name="Chart 0" descr=""/>
           <p:cNvGraphicFramePr/>
           <p:nvPr/>
         </p:nvGraphicFramePr>
@@ -15415,13 +15434,13 @@
         </p:xfrm>
         <a:graphic xmlns:a="http://schemas.openxmlformats.org/drawingml/2006/main">
           <a:graphicData uri="http://schemas.openxmlformats.org/drawingml/2006/chart">
-            <c:chart xmlns:c="http://schemas.openxmlformats.org/drawingml/2006/chart" r:id="rId1"/>
+            <c:chart xmlns:c="http://schemas.openxmlformats.org/drawingml/2006/chart" r:id="rId2"/>
           </a:graphicData>
         </a:graphic>
       </p:graphicFrame>
       <p:sp>
         <p:nvSpPr>
-          <p:cNvPr id="12" name="Shape 8"/>
+          <p:cNvPr id="11" name="Shape 6"/>
           <p:cNvSpPr/>
           <p:nvPr/>
         </p:nvSpPr>
@@ -15443,7 +15462,7 @@
       </p:sp>
       <p:sp>
         <p:nvSpPr>
-          <p:cNvPr id="13" name="Text 9"/>
+          <p:cNvPr id="12" name="Text 7"/>
           <p:cNvSpPr txBox="1"/>
           <p:nvPr/>
         </p:nvSpPr>
@@ -15482,7 +15501,7 @@
       </p:sp>
       <p:sp>
         <p:nvSpPr>
-          <p:cNvPr id="14" name="Text 10"/>
+          <p:cNvPr id="13" name="Text 8"/>
           <p:cNvSpPr txBox="1"/>
           <p:nvPr/>
         </p:nvSpPr>
@@ -15521,7 +15540,7 @@
       </p:sp>
       <p:sp>
         <p:nvSpPr>
-          <p:cNvPr id="15" name="Shape 11"/>
+          <p:cNvPr id="14" name="Shape 9"/>
           <p:cNvSpPr/>
           <p:nvPr/>
         </p:nvSpPr>
@@ -15543,7 +15562,7 @@
       </p:sp>
       <p:sp>
         <p:nvSpPr>
-          <p:cNvPr id="16" name="Text 12"/>
+          <p:cNvPr id="15" name="Text 10"/>
           <p:cNvSpPr txBox="1"/>
           <p:nvPr/>
         </p:nvSpPr>
@@ -15582,7 +15601,7 @@
       </p:sp>
       <p:sp>
         <p:nvSpPr>
-          <p:cNvPr id="17" name="Text 13"/>
+          <p:cNvPr id="16" name="Text 11"/>
           <p:cNvSpPr txBox="1"/>
           <p:nvPr/>
         </p:nvSpPr>
@@ -15621,7 +15640,7 @@
       </p:sp>
       <p:sp>
         <p:nvSpPr>
-          <p:cNvPr id="18" name="Text 14"/>
+          <p:cNvPr id="17" name="Text 12"/>
           <p:cNvSpPr txBox="1"/>
           <p:nvPr/>
         </p:nvSpPr>
@@ -15660,7 +15679,7 @@
       </p:sp>
       <p:sp>
         <p:nvSpPr>
-          <p:cNvPr id="19" name="Text 15"/>
+          <p:cNvPr id="18" name="Text 13"/>
           <p:cNvSpPr txBox="1"/>
           <p:nvPr/>
         </p:nvSpPr>
@@ -15729,9 +15748,33 @@
           <a:chExt cx="0" cy="0"/>
         </a:xfrm>
       </p:grpSpPr>
-      <p:sp>
-        <p:nvSpPr>
-          <p:cNvPr id="2" name="Text 0"/>
+      <p:pic>
+        <p:nvPicPr>
+          <p:cNvPr id="2" name="Image 0" descr="정석항공과학고등학교 교표">    </p:cNvPr>
+          <p:cNvPicPr>
+            <a:picLocks noChangeAspect="1"/>
+          </p:cNvPicPr>
+          <p:nvPr/>
+        </p:nvPicPr>
+        <p:blipFill>
+          <a:blip r:embed="rId1"/>
+          <a:stretch>
+            <a:fillRect/>
+          </a:stretch>
+        </p:blipFill>
+        <p:spPr>
+          <a:xfrm>
+            <a:off x="10753344" y="384048"/>
+            <a:ext cx="841248" cy="360274"/>
+          </a:xfrm>
+          <a:prstGeom prst="rect">
+            <a:avLst/>
+          </a:prstGeom>
+        </p:spPr>
+      </p:pic>
+      <p:sp>
+        <p:nvSpPr>
+          <p:cNvPr id="3" name="Text 0"/>
           <p:cNvSpPr txBox="1"/>
           <p:nvPr/>
         </p:nvSpPr>
@@ -15770,7 +15813,7 @@
       </p:sp>
       <p:sp>
         <p:nvSpPr>
-          <p:cNvPr id="3" name="Text 1"/>
+          <p:cNvPr id="4" name="Text 1"/>
           <p:cNvSpPr txBox="1"/>
           <p:nvPr/>
         </p:nvSpPr>
@@ -15809,66 +15852,7 @@
       </p:sp>
       <p:sp>
         <p:nvSpPr>
-          <p:cNvPr id="4" name="Shape 2"/>
-          <p:cNvSpPr/>
-          <p:nvPr/>
-        </p:nvSpPr>
-        <p:spPr>
-          <a:xfrm>
-            <a:off x="11119104" y="512064"/>
-            <a:ext cx="475488" cy="475488"/>
-          </a:xfrm>
-          <a:prstGeom prst="ellipse">
-            <a:avLst/>
-          </a:prstGeom>
-          <a:solidFill>
-            <a:srgbClr val="1E2761"/>
-          </a:solidFill>
-          <a:ln/>
-        </p:spPr>
-      </p:sp>
-      <p:sp>
-        <p:nvSpPr>
-          <p:cNvPr id="5" name="Text 3"/>
-          <p:cNvSpPr txBox="1"/>
-          <p:nvPr/>
-        </p:nvSpPr>
-        <p:spPr>
-          <a:xfrm>
-            <a:off x="11119104" y="512064"/>
-            <a:ext cx="475488" cy="475488"/>
-          </a:xfrm>
-          <a:prstGeom prst="rect">
-            <a:avLst/>
-          </a:prstGeom>
-          <a:noFill/>
-          <a:ln/>
-        </p:spPr>
-        <p:txBody>
-          <a:bodyPr wrap="square" lIns="0" tIns="0" rIns="0" bIns="0" rtlCol="0" anchor="ctr"/>
-          <a:lstStyle/>
-          <a:p>
-            <a:pPr algn="ctr" indent="0" marL="0">
-              <a:buNone/>
-            </a:pPr>
-            <a:r>
-              <a:rPr lang="en-US" sz="1500" b="1" dirty="0">
-                <a:solidFill>
-                  <a:srgbClr val="FFFFFF"/>
-                </a:solidFill>
-                <a:latin typeface="맑은 고딕" pitchFamily="34" charset="0"/>
-                <a:ea typeface="맑은 고딕" pitchFamily="34" charset="-122"/>
-                <a:cs typeface="맑은 고딕" pitchFamily="34" charset="-120"/>
-              </a:rPr>
-              <a:t>4</a:t>
-            </a:r>
-            <a:endParaRPr lang="en-US" sz="1500" dirty="0"/>
-          </a:p>
-        </p:txBody>
-      </p:sp>
-      <p:sp>
-        <p:nvSpPr>
-          <p:cNvPr id="6" name="Text 4"/>
+          <p:cNvPr id="5" name="Text 2"/>
           <p:cNvSpPr txBox="1"/>
           <p:nvPr/>
         </p:nvSpPr>
@@ -15949,7 +15933,7 @@
       </p:sp>
       <p:sp>
         <p:nvSpPr>
-          <p:cNvPr id="7" name="Shape 5"/>
+          <p:cNvPr id="6" name="Shape 3"/>
           <p:cNvSpPr/>
           <p:nvPr/>
         </p:nvSpPr>
@@ -15983,7 +15967,7 @@
       </p:sp>
       <p:sp>
         <p:nvSpPr>
-          <p:cNvPr id="8" name="Text 6"/>
+          <p:cNvPr id="7" name="Text 4"/>
           <p:cNvSpPr txBox="1"/>
           <p:nvPr/>
         </p:nvSpPr>
@@ -16022,7 +16006,7 @@
       </p:sp>
       <p:sp>
         <p:nvSpPr>
-          <p:cNvPr id="9" name="Text 7"/>
+          <p:cNvPr id="8" name="Text 5"/>
           <p:cNvSpPr txBox="1"/>
           <p:nvPr/>
         </p:nvSpPr>
@@ -16061,7 +16045,7 @@
       </p:sp>
       <p:sp>
         <p:nvSpPr>
-          <p:cNvPr id="10" name="Text 8"/>
+          <p:cNvPr id="9" name="Text 6"/>
           <p:cNvSpPr txBox="1"/>
           <p:nvPr/>
         </p:nvSpPr>
@@ -16123,7 +16107,7 @@
       </p:sp>
       <p:sp>
         <p:nvSpPr>
-          <p:cNvPr id="11" name="Text 9"/>
+          <p:cNvPr id="10" name="Text 7"/>
           <p:cNvSpPr txBox="1"/>
           <p:nvPr/>
         </p:nvSpPr>
@@ -16162,7 +16146,7 @@
       </p:sp>
       <p:sp>
         <p:nvSpPr>
-          <p:cNvPr id="12" name="Text 10"/>
+          <p:cNvPr id="11" name="Text 8"/>
           <p:cNvSpPr txBox="1"/>
           <p:nvPr/>
         </p:nvSpPr>
@@ -16224,7 +16208,7 @@
       </p:sp>
       <p:sp>
         <p:nvSpPr>
-          <p:cNvPr id="13" name="Text 11"/>
+          <p:cNvPr id="12" name="Text 9"/>
           <p:cNvSpPr txBox="1"/>
           <p:nvPr/>
         </p:nvSpPr>
@@ -16940,7 +16924,7 @@
       </p:graphicFrame>
       <p:sp>
         <p:nvSpPr>
-          <p:cNvPr id="15" name="Shape 12"/>
+          <p:cNvPr id="14" name="Shape 10"/>
           <p:cNvSpPr/>
           <p:nvPr/>
         </p:nvSpPr>
@@ -16974,7 +16958,7 @@
       </p:sp>
       <p:sp>
         <p:nvSpPr>
-          <p:cNvPr id="16" name="Text 13"/>
+          <p:cNvPr id="15" name="Text 11"/>
           <p:cNvSpPr txBox="1"/>
           <p:nvPr/>
         </p:nvSpPr>
@@ -17013,7 +16997,7 @@
       </p:sp>
       <p:sp>
         <p:nvSpPr>
-          <p:cNvPr id="17" name="Shape 14"/>
+          <p:cNvPr id="16" name="Shape 12"/>
           <p:cNvSpPr/>
           <p:nvPr/>
         </p:nvSpPr>
@@ -17035,7 +17019,7 @@
       </p:sp>
       <p:sp>
         <p:nvSpPr>
-          <p:cNvPr id="18" name="Text 15"/>
+          <p:cNvPr id="17" name="Text 13"/>
           <p:cNvSpPr txBox="1"/>
           <p:nvPr/>
         </p:nvSpPr>
@@ -17074,7 +17058,7 @@
       </p:sp>
       <p:sp>
         <p:nvSpPr>
-          <p:cNvPr id="19" name="Shape 16"/>
+          <p:cNvPr id="18" name="Shape 14"/>
           <p:cNvSpPr/>
           <p:nvPr/>
         </p:nvSpPr>
@@ -17096,7 +17080,7 @@
       </p:sp>
       <p:sp>
         <p:nvSpPr>
-          <p:cNvPr id="20" name="Text 17"/>
+          <p:cNvPr id="19" name="Text 15"/>
           <p:cNvSpPr txBox="1"/>
           <p:nvPr/>
         </p:nvSpPr>
@@ -17135,7 +17119,7 @@
       </p:sp>
       <p:sp>
         <p:nvSpPr>
-          <p:cNvPr id="21" name="Shape 18"/>
+          <p:cNvPr id="20" name="Shape 16"/>
           <p:cNvSpPr/>
           <p:nvPr/>
         </p:nvSpPr>
@@ -17157,7 +17141,7 @@
       </p:sp>
       <p:sp>
         <p:nvSpPr>
-          <p:cNvPr id="22" name="Text 19"/>
+          <p:cNvPr id="21" name="Text 17"/>
           <p:cNvSpPr txBox="1"/>
           <p:nvPr/>
         </p:nvSpPr>

</xml_diff>

<commit_message>
Add a screening-step tracker, page numbers and a grey badge
- Desaturate the 교표 and use the grey version everywhere, cover included
- Slides 6-9 carry a four-chip tracker (1 접수 / 2 서류 / 3 면접 /
  4 검증) with the current step filled, and the eyebrow now reads
  "전형 절차  N단계 / 4단계" instead of the English STEP label
- Number every slide after the cover as "- 1 -" through "- 10 -",
  centred at the foot of the page

Only the A variant is rebuilt; the B file is left at its previous build.

Co-Authored-By: Claude Opus 5 <noreply@anthropic.com>
Claude-Session: https://claude.ai/code/session_01GZfitk2JEKppZ4fGSDdghv
</commit_message>
<xml_diff>
--- a/docs/2027년_사무직원_채용계획안_A_우측엠블럼.pptx
+++ b/docs/2027년_사무직원_채용계획안_A_우측엠블럼.pptx
@@ -2501,6 +2501,45 @@
         </p:nvSpPr>
         <p:spPr>
           <a:xfrm>
+            <a:off x="5166360" y="6309360"/>
+            <a:ext cx="1828800" cy="292608"/>
+          </a:xfrm>
+          <a:prstGeom prst="rect">
+            <a:avLst/>
+          </a:prstGeom>
+          <a:noFill/>
+          <a:ln/>
+        </p:spPr>
+        <p:txBody>
+          <a:bodyPr wrap="square" lIns="0" tIns="0" rIns="0" bIns="0" rtlCol="0" anchor="ctr"/>
+          <a:lstStyle/>
+          <a:p>
+            <a:pPr algn="ctr" indent="0" marL="0">
+              <a:buNone/>
+            </a:pPr>
+            <a:r>
+              <a:rPr lang="en-US" sz="1100" dirty="0">
+                <a:solidFill>
+                  <a:srgbClr val="6B7186"/>
+                </a:solidFill>
+                <a:latin typeface="맑은 고딕" pitchFamily="34" charset="0"/>
+                <a:ea typeface="맑은 고딕" pitchFamily="34" charset="-122"/>
+                <a:cs typeface="맑은 고딕" pitchFamily="34" charset="-120"/>
+              </a:rPr>
+              <a:t>- 9 -</a:t>
+            </a:r>
+            <a:endParaRPr lang="en-US" sz="1100" dirty="0"/>
+          </a:p>
+        </p:txBody>
+      </p:sp>
+      <p:sp>
+        <p:nvSpPr>
+          <p:cNvPr id="4" name="Text 1"/>
+          <p:cNvSpPr txBox="1"/>
+          <p:nvPr/>
+        </p:nvSpPr>
+        <p:spPr>
+          <a:xfrm>
             <a:off x="566928" y="329184"/>
             <a:ext cx="11027664" cy="237744"/>
           </a:xfrm>
@@ -2534,7 +2573,7 @@
       </p:sp>
       <p:sp>
         <p:nvSpPr>
-          <p:cNvPr id="4" name="Text 1"/>
+          <p:cNvPr id="5" name="Text 2"/>
           <p:cNvSpPr txBox="1"/>
           <p:nvPr/>
         </p:nvSpPr>
@@ -2573,7 +2612,7 @@
       </p:sp>
       <p:sp>
         <p:nvSpPr>
-          <p:cNvPr id="5" name="Shape 2"/>
+          <p:cNvPr id="6" name="Shape 3"/>
           <p:cNvSpPr/>
           <p:nvPr/>
         </p:nvSpPr>
@@ -2607,7 +2646,7 @@
       </p:sp>
       <p:sp>
         <p:nvSpPr>
-          <p:cNvPr id="6" name="Shape 3"/>
+          <p:cNvPr id="7" name="Shape 4"/>
           <p:cNvSpPr/>
           <p:nvPr/>
         </p:nvSpPr>
@@ -2627,7 +2666,7 @@
       </p:sp>
       <p:sp>
         <p:nvSpPr>
-          <p:cNvPr id="7" name="Text 4"/>
+          <p:cNvPr id="8" name="Text 5"/>
           <p:cNvSpPr txBox="1"/>
           <p:nvPr/>
         </p:nvSpPr>
@@ -2666,7 +2705,7 @@
       </p:sp>
       <p:sp>
         <p:nvSpPr>
-          <p:cNvPr id="8" name="Text 5"/>
+          <p:cNvPr id="9" name="Text 6"/>
           <p:cNvSpPr txBox="1"/>
           <p:nvPr/>
         </p:nvSpPr>
@@ -2705,7 +2744,7 @@
       </p:sp>
       <p:sp>
         <p:nvSpPr>
-          <p:cNvPr id="9" name="Text 6"/>
+          <p:cNvPr id="10" name="Text 7"/>
           <p:cNvSpPr txBox="1"/>
           <p:nvPr/>
         </p:nvSpPr>
@@ -2775,7 +2814,7 @@
       </p:sp>
       <p:sp>
         <p:nvSpPr>
-          <p:cNvPr id="10" name="Shape 7"/>
+          <p:cNvPr id="11" name="Shape 8"/>
           <p:cNvSpPr/>
           <p:nvPr/>
         </p:nvSpPr>
@@ -2809,7 +2848,7 @@
       </p:sp>
       <p:sp>
         <p:nvSpPr>
-          <p:cNvPr id="11" name="Shape 8"/>
+          <p:cNvPr id="12" name="Shape 9"/>
           <p:cNvSpPr/>
           <p:nvPr/>
         </p:nvSpPr>
@@ -2829,7 +2868,7 @@
       </p:sp>
       <p:sp>
         <p:nvSpPr>
-          <p:cNvPr id="12" name="Text 9"/>
+          <p:cNvPr id="13" name="Text 10"/>
           <p:cNvSpPr txBox="1"/>
           <p:nvPr/>
         </p:nvSpPr>
@@ -2868,7 +2907,7 @@
       </p:sp>
       <p:sp>
         <p:nvSpPr>
-          <p:cNvPr id="13" name="Text 10"/>
+          <p:cNvPr id="14" name="Text 11"/>
           <p:cNvSpPr txBox="1"/>
           <p:nvPr/>
         </p:nvSpPr>
@@ -2907,7 +2946,7 @@
       </p:sp>
       <p:sp>
         <p:nvSpPr>
-          <p:cNvPr id="14" name="Text 11"/>
+          <p:cNvPr id="15" name="Text 12"/>
           <p:cNvSpPr txBox="1"/>
           <p:nvPr/>
         </p:nvSpPr>
@@ -2953,7 +2992,7 @@
       </p:sp>
       <p:sp>
         <p:nvSpPr>
-          <p:cNvPr id="15" name="Shape 12"/>
+          <p:cNvPr id="16" name="Shape 13"/>
           <p:cNvSpPr/>
           <p:nvPr/>
         </p:nvSpPr>
@@ -2987,7 +3026,7 @@
       </p:sp>
       <p:sp>
         <p:nvSpPr>
-          <p:cNvPr id="16" name="Shape 13"/>
+          <p:cNvPr id="17" name="Shape 14"/>
           <p:cNvSpPr/>
           <p:nvPr/>
         </p:nvSpPr>
@@ -3007,7 +3046,7 @@
       </p:sp>
       <p:sp>
         <p:nvSpPr>
-          <p:cNvPr id="17" name="Text 14"/>
+          <p:cNvPr id="18" name="Text 15"/>
           <p:cNvSpPr txBox="1"/>
           <p:nvPr/>
         </p:nvSpPr>
@@ -3046,7 +3085,7 @@
       </p:sp>
       <p:sp>
         <p:nvSpPr>
-          <p:cNvPr id="18" name="Text 15"/>
+          <p:cNvPr id="19" name="Text 16"/>
           <p:cNvSpPr txBox="1"/>
           <p:nvPr/>
         </p:nvSpPr>
@@ -3085,7 +3124,7 @@
       </p:sp>
       <p:sp>
         <p:nvSpPr>
-          <p:cNvPr id="19" name="Text 16"/>
+          <p:cNvPr id="20" name="Text 17"/>
           <p:cNvSpPr txBox="1"/>
           <p:nvPr/>
         </p:nvSpPr>
@@ -3131,7 +3170,7 @@
       </p:sp>
       <p:sp>
         <p:nvSpPr>
-          <p:cNvPr id="20" name="Shape 17"/>
+          <p:cNvPr id="21" name="Shape 18"/>
           <p:cNvSpPr/>
           <p:nvPr/>
         </p:nvSpPr>
@@ -3165,7 +3204,7 @@
       </p:sp>
       <p:sp>
         <p:nvSpPr>
-          <p:cNvPr id="21" name="Text 18"/>
+          <p:cNvPr id="22" name="Text 19"/>
           <p:cNvSpPr txBox="1"/>
           <p:nvPr/>
         </p:nvSpPr>
@@ -3266,6 +3305,45 @@
         </p:nvSpPr>
         <p:spPr>
           <a:xfrm>
+            <a:off x="5166360" y="6309360"/>
+            <a:ext cx="1828800" cy="292608"/>
+          </a:xfrm>
+          <a:prstGeom prst="rect">
+            <a:avLst/>
+          </a:prstGeom>
+          <a:noFill/>
+          <a:ln/>
+        </p:spPr>
+        <p:txBody>
+          <a:bodyPr wrap="square" lIns="0" tIns="0" rIns="0" bIns="0" rtlCol="0" anchor="ctr"/>
+          <a:lstStyle/>
+          <a:p>
+            <a:pPr algn="ctr" indent="0" marL="0">
+              <a:buNone/>
+            </a:pPr>
+            <a:r>
+              <a:rPr lang="en-US" sz="1100" dirty="0">
+                <a:solidFill>
+                  <a:srgbClr val="8E9AC0"/>
+                </a:solidFill>
+                <a:latin typeface="맑은 고딕" pitchFamily="34" charset="0"/>
+                <a:ea typeface="맑은 고딕" pitchFamily="34" charset="-122"/>
+                <a:cs typeface="맑은 고딕" pitchFamily="34" charset="-120"/>
+              </a:rPr>
+              <a:t>- 10 -</a:t>
+            </a:r>
+            <a:endParaRPr lang="en-US" sz="1100" dirty="0"/>
+          </a:p>
+        </p:txBody>
+      </p:sp>
+      <p:sp>
+        <p:nvSpPr>
+          <p:cNvPr id="4" name="Text 1"/>
+          <p:cNvSpPr txBox="1"/>
+          <p:nvPr/>
+        </p:nvSpPr>
+        <p:spPr>
+          <a:xfrm>
             <a:off x="932688" y="786384"/>
             <a:ext cx="11027664" cy="548640"/>
           </a:xfrm>
@@ -3299,7 +3377,7 @@
       </p:sp>
       <p:sp>
         <p:nvSpPr>
-          <p:cNvPr id="4" name="Text 1"/>
+          <p:cNvPr id="5" name="Text 2"/>
           <p:cNvSpPr txBox="1"/>
           <p:nvPr/>
         </p:nvSpPr>
@@ -3338,7 +3416,7 @@
       </p:sp>
       <p:sp>
         <p:nvSpPr>
-          <p:cNvPr id="5" name="Shape 2"/>
+          <p:cNvPr id="6" name="Shape 3"/>
           <p:cNvSpPr/>
           <p:nvPr/>
         </p:nvSpPr>
@@ -3365,7 +3443,7 @@
       </p:sp>
       <p:sp>
         <p:nvSpPr>
-          <p:cNvPr id="6" name="Text 3"/>
+          <p:cNvPr id="7" name="Text 4"/>
           <p:cNvSpPr txBox="1"/>
           <p:nvPr/>
         </p:nvSpPr>
@@ -3404,7 +3482,7 @@
       </p:sp>
       <p:sp>
         <p:nvSpPr>
-          <p:cNvPr id="7" name="Text 4"/>
+          <p:cNvPr id="8" name="Text 5"/>
           <p:cNvSpPr txBox="1"/>
           <p:nvPr/>
         </p:nvSpPr>
@@ -3443,7 +3521,7 @@
       </p:sp>
       <p:sp>
         <p:nvSpPr>
-          <p:cNvPr id="8" name="Text 5"/>
+          <p:cNvPr id="9" name="Text 6"/>
           <p:cNvSpPr txBox="1"/>
           <p:nvPr/>
         </p:nvSpPr>
@@ -3485,7 +3563,7 @@
       </p:sp>
       <p:sp>
         <p:nvSpPr>
-          <p:cNvPr id="9" name="Shape 6"/>
+          <p:cNvPr id="10" name="Shape 7"/>
           <p:cNvSpPr/>
           <p:nvPr/>
         </p:nvSpPr>
@@ -3512,7 +3590,7 @@
       </p:sp>
       <p:sp>
         <p:nvSpPr>
-          <p:cNvPr id="10" name="Text 7"/>
+          <p:cNvPr id="11" name="Text 8"/>
           <p:cNvSpPr txBox="1"/>
           <p:nvPr/>
         </p:nvSpPr>
@@ -3551,7 +3629,7 @@
       </p:sp>
       <p:sp>
         <p:nvSpPr>
-          <p:cNvPr id="11" name="Text 8"/>
+          <p:cNvPr id="12" name="Text 9"/>
           <p:cNvSpPr txBox="1"/>
           <p:nvPr/>
         </p:nvSpPr>
@@ -3590,7 +3668,7 @@
       </p:sp>
       <p:sp>
         <p:nvSpPr>
-          <p:cNvPr id="12" name="Text 9"/>
+          <p:cNvPr id="13" name="Text 10"/>
           <p:cNvSpPr txBox="1"/>
           <p:nvPr/>
         </p:nvSpPr>
@@ -3632,7 +3710,7 @@
       </p:sp>
       <p:sp>
         <p:nvSpPr>
-          <p:cNvPr id="13" name="Shape 10"/>
+          <p:cNvPr id="14" name="Shape 11"/>
           <p:cNvSpPr/>
           <p:nvPr/>
         </p:nvSpPr>
@@ -3659,7 +3737,7 @@
       </p:sp>
       <p:sp>
         <p:nvSpPr>
-          <p:cNvPr id="14" name="Text 11"/>
+          <p:cNvPr id="15" name="Text 12"/>
           <p:cNvSpPr txBox="1"/>
           <p:nvPr/>
         </p:nvSpPr>
@@ -3698,7 +3776,7 @@
       </p:sp>
       <p:sp>
         <p:nvSpPr>
-          <p:cNvPr id="15" name="Text 12"/>
+          <p:cNvPr id="16" name="Text 13"/>
           <p:cNvSpPr txBox="1"/>
           <p:nvPr/>
         </p:nvSpPr>
@@ -3737,7 +3815,7 @@
       </p:sp>
       <p:sp>
         <p:nvSpPr>
-          <p:cNvPr id="16" name="Text 13"/>
+          <p:cNvPr id="17" name="Text 14"/>
           <p:cNvSpPr txBox="1"/>
           <p:nvPr/>
         </p:nvSpPr>
@@ -3779,7 +3857,7 @@
       </p:sp>
       <p:sp>
         <p:nvSpPr>
-          <p:cNvPr id="17" name="Shape 14"/>
+          <p:cNvPr id="18" name="Shape 15"/>
           <p:cNvSpPr/>
           <p:nvPr/>
         </p:nvSpPr>
@@ -3806,7 +3884,7 @@
       </p:sp>
       <p:sp>
         <p:nvSpPr>
-          <p:cNvPr id="18" name="Text 15"/>
+          <p:cNvPr id="19" name="Text 16"/>
           <p:cNvSpPr txBox="1"/>
           <p:nvPr/>
         </p:nvSpPr>
@@ -3845,7 +3923,7 @@
       </p:sp>
       <p:sp>
         <p:nvSpPr>
-          <p:cNvPr id="19" name="Text 16"/>
+          <p:cNvPr id="20" name="Text 17"/>
           <p:cNvSpPr txBox="1"/>
           <p:nvPr/>
         </p:nvSpPr>
@@ -3884,7 +3962,7 @@
       </p:sp>
       <p:sp>
         <p:nvSpPr>
-          <p:cNvPr id="20" name="Text 17"/>
+          <p:cNvPr id="21" name="Text 18"/>
           <p:cNvSpPr txBox="1"/>
           <p:nvPr/>
         </p:nvSpPr>
@@ -3926,7 +4004,7 @@
       </p:sp>
       <p:sp>
         <p:nvSpPr>
-          <p:cNvPr id="21" name="Text 18"/>
+          <p:cNvPr id="22" name="Text 19"/>
           <p:cNvSpPr txBox="1"/>
           <p:nvPr/>
         </p:nvSpPr>
@@ -3965,7 +4043,7 @@
       </p:sp>
       <p:sp>
         <p:nvSpPr>
-          <p:cNvPr id="22" name="Shape 19"/>
+          <p:cNvPr id="23" name="Shape 20"/>
           <p:cNvSpPr/>
           <p:nvPr/>
         </p:nvSpPr>
@@ -3985,7 +4063,7 @@
       </p:sp>
       <p:sp>
         <p:nvSpPr>
-          <p:cNvPr id="23" name="Text 20"/>
+          <p:cNvPr id="24" name="Text 21"/>
           <p:cNvSpPr txBox="1"/>
           <p:nvPr/>
         </p:nvSpPr>
@@ -4024,7 +4102,7 @@
       </p:sp>
       <p:sp>
         <p:nvSpPr>
-          <p:cNvPr id="24" name="Text 21"/>
+          <p:cNvPr id="25" name="Text 22"/>
           <p:cNvSpPr txBox="1"/>
           <p:nvPr/>
         </p:nvSpPr>
@@ -4066,7 +4144,7 @@
       </p:sp>
       <p:sp>
         <p:nvSpPr>
-          <p:cNvPr id="25" name="Shape 22"/>
+          <p:cNvPr id="26" name="Shape 23"/>
           <p:cNvSpPr/>
           <p:nvPr/>
         </p:nvSpPr>
@@ -4086,7 +4164,7 @@
       </p:sp>
       <p:sp>
         <p:nvSpPr>
-          <p:cNvPr id="26" name="Text 23"/>
+          <p:cNvPr id="27" name="Text 24"/>
           <p:cNvSpPr txBox="1"/>
           <p:nvPr/>
         </p:nvSpPr>
@@ -4125,7 +4203,7 @@
       </p:sp>
       <p:sp>
         <p:nvSpPr>
-          <p:cNvPr id="27" name="Text 24"/>
+          <p:cNvPr id="28" name="Text 25"/>
           <p:cNvSpPr txBox="1"/>
           <p:nvPr/>
         </p:nvSpPr>
@@ -4167,7 +4245,7 @@
       </p:sp>
       <p:sp>
         <p:nvSpPr>
-          <p:cNvPr id="28" name="Shape 25"/>
+          <p:cNvPr id="29" name="Shape 26"/>
           <p:cNvSpPr/>
           <p:nvPr/>
         </p:nvSpPr>
@@ -4187,7 +4265,7 @@
       </p:sp>
       <p:sp>
         <p:nvSpPr>
-          <p:cNvPr id="29" name="Text 26"/>
+          <p:cNvPr id="30" name="Text 27"/>
           <p:cNvSpPr txBox="1"/>
           <p:nvPr/>
         </p:nvSpPr>
@@ -4226,7 +4304,7 @@
       </p:sp>
       <p:sp>
         <p:nvSpPr>
-          <p:cNvPr id="30" name="Text 27"/>
+          <p:cNvPr id="31" name="Text 28"/>
           <p:cNvSpPr txBox="1"/>
           <p:nvPr/>
         </p:nvSpPr>
@@ -4268,7 +4346,7 @@
       </p:sp>
       <p:sp>
         <p:nvSpPr>
-          <p:cNvPr id="31" name="Shape 28"/>
+          <p:cNvPr id="32" name="Shape 29"/>
           <p:cNvSpPr/>
           <p:nvPr/>
         </p:nvSpPr>
@@ -4288,7 +4366,7 @@
       </p:sp>
       <p:sp>
         <p:nvSpPr>
-          <p:cNvPr id="32" name="Text 29"/>
+          <p:cNvPr id="33" name="Text 30"/>
           <p:cNvSpPr txBox="1"/>
           <p:nvPr/>
         </p:nvSpPr>
@@ -4327,7 +4405,7 @@
       </p:sp>
       <p:sp>
         <p:nvSpPr>
-          <p:cNvPr id="33" name="Text 30"/>
+          <p:cNvPr id="34" name="Text 31"/>
           <p:cNvSpPr txBox="1"/>
           <p:nvPr/>
         </p:nvSpPr>
@@ -4431,6 +4509,45 @@
         </p:nvSpPr>
         <p:spPr>
           <a:xfrm>
+            <a:off x="5166360" y="6309360"/>
+            <a:ext cx="1828800" cy="292608"/>
+          </a:xfrm>
+          <a:prstGeom prst="rect">
+            <a:avLst/>
+          </a:prstGeom>
+          <a:noFill/>
+          <a:ln/>
+        </p:spPr>
+        <p:txBody>
+          <a:bodyPr wrap="square" lIns="0" tIns="0" rIns="0" bIns="0" rtlCol="0" anchor="ctr"/>
+          <a:lstStyle/>
+          <a:p>
+            <a:pPr algn="ctr" indent="0" marL="0">
+              <a:buNone/>
+            </a:pPr>
+            <a:r>
+              <a:rPr lang="en-US" sz="1100" dirty="0">
+                <a:solidFill>
+                  <a:srgbClr val="6B7186"/>
+                </a:solidFill>
+                <a:latin typeface="맑은 고딕" pitchFamily="34" charset="0"/>
+                <a:ea typeface="맑은 고딕" pitchFamily="34" charset="-122"/>
+                <a:cs typeface="맑은 고딕" pitchFamily="34" charset="-120"/>
+              </a:rPr>
+              <a:t>- 1 -</a:t>
+            </a:r>
+            <a:endParaRPr lang="en-US" sz="1100" dirty="0"/>
+          </a:p>
+        </p:txBody>
+      </p:sp>
+      <p:sp>
+        <p:nvSpPr>
+          <p:cNvPr id="4" name="Text 1"/>
+          <p:cNvSpPr txBox="1"/>
+          <p:nvPr/>
+        </p:nvSpPr>
+        <p:spPr>
+          <a:xfrm>
             <a:off x="566928" y="329184"/>
             <a:ext cx="11027664" cy="237744"/>
           </a:xfrm>
@@ -4464,7 +4581,7 @@
       </p:sp>
       <p:sp>
         <p:nvSpPr>
-          <p:cNvPr id="4" name="Text 1"/>
+          <p:cNvPr id="5" name="Text 2"/>
           <p:cNvSpPr txBox="1"/>
           <p:nvPr/>
         </p:nvSpPr>
@@ -4503,7 +4620,7 @@
       </p:sp>
       <p:sp>
         <p:nvSpPr>
-          <p:cNvPr id="5" name="Shape 2"/>
+          <p:cNvPr id="6" name="Shape 3"/>
           <p:cNvSpPr/>
           <p:nvPr/>
         </p:nvSpPr>
@@ -4537,7 +4654,7 @@
       </p:sp>
       <p:sp>
         <p:nvSpPr>
-          <p:cNvPr id="6" name="Text 3"/>
+          <p:cNvPr id="7" name="Text 4"/>
           <p:cNvSpPr txBox="1"/>
           <p:nvPr/>
         </p:nvSpPr>
@@ -4576,7 +4693,7 @@
       </p:sp>
       <p:sp>
         <p:nvSpPr>
-          <p:cNvPr id="7" name="Text 4"/>
+          <p:cNvPr id="8" name="Text 5"/>
           <p:cNvSpPr txBox="1"/>
           <p:nvPr/>
         </p:nvSpPr>
@@ -4615,7 +4732,7 @@
       </p:sp>
       <p:sp>
         <p:nvSpPr>
-          <p:cNvPr id="8" name="Shape 5"/>
+          <p:cNvPr id="9" name="Shape 6"/>
           <p:cNvSpPr/>
           <p:nvPr/>
         </p:nvSpPr>
@@ -4649,7 +4766,7 @@
       </p:sp>
       <p:sp>
         <p:nvSpPr>
-          <p:cNvPr id="9" name="Text 6"/>
+          <p:cNvPr id="10" name="Text 7"/>
           <p:cNvSpPr txBox="1"/>
           <p:nvPr/>
         </p:nvSpPr>
@@ -4688,7 +4805,7 @@
       </p:sp>
       <p:sp>
         <p:nvSpPr>
-          <p:cNvPr id="10" name="Text 7"/>
+          <p:cNvPr id="11" name="Text 8"/>
           <p:cNvSpPr txBox="1"/>
           <p:nvPr/>
         </p:nvSpPr>
@@ -4727,7 +4844,7 @@
       </p:sp>
       <p:sp>
         <p:nvSpPr>
-          <p:cNvPr id="11" name="Shape 8"/>
+          <p:cNvPr id="12" name="Shape 9"/>
           <p:cNvSpPr/>
           <p:nvPr/>
         </p:nvSpPr>
@@ -4761,7 +4878,7 @@
       </p:sp>
       <p:sp>
         <p:nvSpPr>
-          <p:cNvPr id="12" name="Text 9"/>
+          <p:cNvPr id="13" name="Text 10"/>
           <p:cNvSpPr txBox="1"/>
           <p:nvPr/>
         </p:nvSpPr>
@@ -4800,7 +4917,7 @@
       </p:sp>
       <p:sp>
         <p:nvSpPr>
-          <p:cNvPr id="13" name="Text 10"/>
+          <p:cNvPr id="14" name="Text 11"/>
           <p:cNvSpPr txBox="1"/>
           <p:nvPr/>
         </p:nvSpPr>
@@ -4839,7 +4956,7 @@
       </p:sp>
       <p:sp>
         <p:nvSpPr>
-          <p:cNvPr id="14" name="Shape 11"/>
+          <p:cNvPr id="15" name="Shape 12"/>
           <p:cNvSpPr/>
           <p:nvPr/>
         </p:nvSpPr>
@@ -4873,7 +4990,7 @@
       </p:sp>
       <p:sp>
         <p:nvSpPr>
-          <p:cNvPr id="15" name="Text 12"/>
+          <p:cNvPr id="16" name="Text 13"/>
           <p:cNvSpPr txBox="1"/>
           <p:nvPr/>
         </p:nvSpPr>
@@ -4912,7 +5029,7 @@
       </p:sp>
       <p:sp>
         <p:nvSpPr>
-          <p:cNvPr id="16" name="Text 13"/>
+          <p:cNvPr id="17" name="Text 14"/>
           <p:cNvSpPr txBox="1"/>
           <p:nvPr/>
         </p:nvSpPr>
@@ -4951,7 +5068,7 @@
       </p:sp>
       <p:sp>
         <p:nvSpPr>
-          <p:cNvPr id="17" name="Text 14"/>
+          <p:cNvPr id="18" name="Text 15"/>
           <p:cNvSpPr txBox="1"/>
           <p:nvPr/>
         </p:nvSpPr>
@@ -5013,7 +5130,7 @@
       </p:sp>
       <p:sp>
         <p:nvSpPr>
-          <p:cNvPr id="18" name="Shape 15"/>
+          <p:cNvPr id="19" name="Shape 16"/>
           <p:cNvSpPr/>
           <p:nvPr/>
         </p:nvSpPr>
@@ -5047,7 +5164,7 @@
       </p:sp>
       <p:sp>
         <p:nvSpPr>
-          <p:cNvPr id="19" name="Text 16"/>
+          <p:cNvPr id="20" name="Text 17"/>
           <p:cNvSpPr txBox="1"/>
           <p:nvPr/>
         </p:nvSpPr>
@@ -5086,7 +5203,7 @@
       </p:sp>
       <p:sp>
         <p:nvSpPr>
-          <p:cNvPr id="20" name="Text 17"/>
+          <p:cNvPr id="21" name="Text 18"/>
           <p:cNvSpPr txBox="1"/>
           <p:nvPr/>
         </p:nvSpPr>
@@ -5125,7 +5242,7 @@
       </p:sp>
       <p:sp>
         <p:nvSpPr>
-          <p:cNvPr id="21" name="Shape 18"/>
+          <p:cNvPr id="22" name="Shape 19"/>
           <p:cNvSpPr/>
           <p:nvPr/>
         </p:nvSpPr>
@@ -5159,7 +5276,7 @@
       </p:sp>
       <p:sp>
         <p:nvSpPr>
-          <p:cNvPr id="22" name="Text 19"/>
+          <p:cNvPr id="23" name="Text 20"/>
           <p:cNvSpPr txBox="1"/>
           <p:nvPr/>
         </p:nvSpPr>
@@ -5198,7 +5315,7 @@
       </p:sp>
       <p:sp>
         <p:nvSpPr>
-          <p:cNvPr id="23" name="Shape 20"/>
+          <p:cNvPr id="24" name="Shape 21"/>
           <p:cNvSpPr/>
           <p:nvPr/>
         </p:nvSpPr>
@@ -5218,7 +5335,7 @@
       </p:sp>
       <p:sp>
         <p:nvSpPr>
-          <p:cNvPr id="24" name="Text 21"/>
+          <p:cNvPr id="25" name="Text 22"/>
           <p:cNvSpPr txBox="1"/>
           <p:nvPr/>
         </p:nvSpPr>
@@ -5257,7 +5374,7 @@
       </p:sp>
       <p:sp>
         <p:nvSpPr>
-          <p:cNvPr id="25" name="Text 22"/>
+          <p:cNvPr id="26" name="Text 23"/>
           <p:cNvSpPr txBox="1"/>
           <p:nvPr/>
         </p:nvSpPr>
@@ -5299,7 +5416,7 @@
       </p:sp>
       <p:sp>
         <p:nvSpPr>
-          <p:cNvPr id="26" name="Shape 23"/>
+          <p:cNvPr id="27" name="Shape 24"/>
           <p:cNvSpPr/>
           <p:nvPr/>
         </p:nvSpPr>
@@ -5319,7 +5436,7 @@
       </p:sp>
       <p:sp>
         <p:nvSpPr>
-          <p:cNvPr id="27" name="Text 24"/>
+          <p:cNvPr id="28" name="Text 25"/>
           <p:cNvSpPr txBox="1"/>
           <p:nvPr/>
         </p:nvSpPr>
@@ -5358,7 +5475,7 @@
       </p:sp>
       <p:sp>
         <p:nvSpPr>
-          <p:cNvPr id="28" name="Text 25"/>
+          <p:cNvPr id="29" name="Text 26"/>
           <p:cNvSpPr txBox="1"/>
           <p:nvPr/>
         </p:nvSpPr>
@@ -5400,7 +5517,7 @@
       </p:sp>
       <p:sp>
         <p:nvSpPr>
-          <p:cNvPr id="29" name="Text 26"/>
+          <p:cNvPr id="30" name="Text 27"/>
           <p:cNvSpPr txBox="1"/>
           <p:nvPr/>
         </p:nvSpPr>
@@ -5501,6 +5618,45 @@
         </p:nvSpPr>
         <p:spPr>
           <a:xfrm>
+            <a:off x="5166360" y="6309360"/>
+            <a:ext cx="1828800" cy="292608"/>
+          </a:xfrm>
+          <a:prstGeom prst="rect">
+            <a:avLst/>
+          </a:prstGeom>
+          <a:noFill/>
+          <a:ln/>
+        </p:spPr>
+        <p:txBody>
+          <a:bodyPr wrap="square" lIns="0" tIns="0" rIns="0" bIns="0" rtlCol="0" anchor="ctr"/>
+          <a:lstStyle/>
+          <a:p>
+            <a:pPr algn="ctr" indent="0" marL="0">
+              <a:buNone/>
+            </a:pPr>
+            <a:r>
+              <a:rPr lang="en-US" sz="1100" dirty="0">
+                <a:solidFill>
+                  <a:srgbClr val="6B7186"/>
+                </a:solidFill>
+                <a:latin typeface="맑은 고딕" pitchFamily="34" charset="0"/>
+                <a:ea typeface="맑은 고딕" pitchFamily="34" charset="-122"/>
+                <a:cs typeface="맑은 고딕" pitchFamily="34" charset="-120"/>
+              </a:rPr>
+              <a:t>- 2 -</a:t>
+            </a:r>
+            <a:endParaRPr lang="en-US" sz="1100" dirty="0"/>
+          </a:p>
+        </p:txBody>
+      </p:sp>
+      <p:sp>
+        <p:nvSpPr>
+          <p:cNvPr id="4" name="Text 1"/>
+          <p:cNvSpPr txBox="1"/>
+          <p:nvPr/>
+        </p:nvSpPr>
+        <p:spPr>
+          <a:xfrm>
             <a:off x="566928" y="329184"/>
             <a:ext cx="11027664" cy="237744"/>
           </a:xfrm>
@@ -5534,7 +5690,7 @@
       </p:sp>
       <p:sp>
         <p:nvSpPr>
-          <p:cNvPr id="4" name="Text 1"/>
+          <p:cNvPr id="5" name="Text 2"/>
           <p:cNvSpPr txBox="1"/>
           <p:nvPr/>
         </p:nvSpPr>
@@ -5573,7 +5729,7 @@
       </p:sp>
       <p:sp>
         <p:nvSpPr>
-          <p:cNvPr id="5" name="Text 2"/>
+          <p:cNvPr id="6" name="Text 3"/>
           <p:cNvSpPr txBox="1"/>
           <p:nvPr/>
         </p:nvSpPr>
@@ -8220,7 +8376,7 @@
       </p:graphicFrame>
       <p:sp>
         <p:nvSpPr>
-          <p:cNvPr id="7" name="Text 3"/>
+          <p:cNvPr id="8" name="Text 4"/>
           <p:cNvSpPr txBox="1"/>
           <p:nvPr/>
         </p:nvSpPr>
@@ -8259,7 +8415,7 @@
       </p:sp>
       <p:sp>
         <p:nvSpPr>
-          <p:cNvPr id="8" name="Shape 4"/>
+          <p:cNvPr id="9" name="Shape 5"/>
           <p:cNvSpPr/>
           <p:nvPr/>
         </p:nvSpPr>
@@ -8293,7 +8449,7 @@
       </p:sp>
       <p:sp>
         <p:nvSpPr>
-          <p:cNvPr id="9" name="Text 5"/>
+          <p:cNvPr id="10" name="Text 6"/>
           <p:cNvSpPr txBox="1"/>
           <p:nvPr/>
         </p:nvSpPr>
@@ -8332,7 +8488,7 @@
       </p:sp>
       <p:sp>
         <p:nvSpPr>
-          <p:cNvPr id="10" name="Text 6"/>
+          <p:cNvPr id="11" name="Text 7"/>
           <p:cNvSpPr txBox="1"/>
           <p:nvPr/>
         </p:nvSpPr>
@@ -8371,7 +8527,7 @@
       </p:sp>
       <p:sp>
         <p:nvSpPr>
-          <p:cNvPr id="11" name="Shape 7"/>
+          <p:cNvPr id="12" name="Shape 8"/>
           <p:cNvSpPr/>
           <p:nvPr/>
         </p:nvSpPr>
@@ -8405,7 +8561,7 @@
       </p:sp>
       <p:sp>
         <p:nvSpPr>
-          <p:cNvPr id="12" name="Text 8"/>
+          <p:cNvPr id="13" name="Text 9"/>
           <p:cNvSpPr txBox="1"/>
           <p:nvPr/>
         </p:nvSpPr>
@@ -8444,7 +8600,7 @@
       </p:sp>
       <p:sp>
         <p:nvSpPr>
-          <p:cNvPr id="13" name="Text 9"/>
+          <p:cNvPr id="14" name="Text 10"/>
           <p:cNvSpPr txBox="1"/>
           <p:nvPr/>
         </p:nvSpPr>
@@ -8483,7 +8639,7 @@
       </p:sp>
       <p:sp>
         <p:nvSpPr>
-          <p:cNvPr id="14" name="Shape 10"/>
+          <p:cNvPr id="15" name="Shape 11"/>
           <p:cNvSpPr/>
           <p:nvPr/>
         </p:nvSpPr>
@@ -8517,7 +8673,7 @@
       </p:sp>
       <p:sp>
         <p:nvSpPr>
-          <p:cNvPr id="15" name="Text 11"/>
+          <p:cNvPr id="16" name="Text 12"/>
           <p:cNvSpPr txBox="1"/>
           <p:nvPr/>
         </p:nvSpPr>
@@ -8556,7 +8712,7 @@
       </p:sp>
       <p:sp>
         <p:nvSpPr>
-          <p:cNvPr id="16" name="Text 12"/>
+          <p:cNvPr id="17" name="Text 13"/>
           <p:cNvSpPr txBox="1"/>
           <p:nvPr/>
         </p:nvSpPr>
@@ -8595,7 +8751,7 @@
       </p:sp>
       <p:sp>
         <p:nvSpPr>
-          <p:cNvPr id="17" name="Shape 13"/>
+          <p:cNvPr id="18" name="Shape 14"/>
           <p:cNvSpPr/>
           <p:nvPr/>
         </p:nvSpPr>
@@ -8629,7 +8785,7 @@
       </p:sp>
       <p:sp>
         <p:nvSpPr>
-          <p:cNvPr id="18" name="Text 14"/>
+          <p:cNvPr id="19" name="Text 15"/>
           <p:cNvSpPr txBox="1"/>
           <p:nvPr/>
         </p:nvSpPr>
@@ -8668,7 +8824,7 @@
       </p:sp>
       <p:sp>
         <p:nvSpPr>
-          <p:cNvPr id="19" name="Text 15"/>
+          <p:cNvPr id="20" name="Text 16"/>
           <p:cNvSpPr txBox="1"/>
           <p:nvPr/>
         </p:nvSpPr>
@@ -8707,7 +8863,7 @@
       </p:sp>
       <p:sp>
         <p:nvSpPr>
-          <p:cNvPr id="20" name="Shape 16"/>
+          <p:cNvPr id="21" name="Shape 17"/>
           <p:cNvSpPr/>
           <p:nvPr/>
         </p:nvSpPr>
@@ -8741,7 +8897,7 @@
       </p:sp>
       <p:sp>
         <p:nvSpPr>
-          <p:cNvPr id="21" name="Text 17"/>
+          <p:cNvPr id="22" name="Text 18"/>
           <p:cNvSpPr txBox="1"/>
           <p:nvPr/>
         </p:nvSpPr>
@@ -8780,7 +8936,7 @@
       </p:sp>
       <p:sp>
         <p:nvSpPr>
-          <p:cNvPr id="22" name="Text 18"/>
+          <p:cNvPr id="23" name="Text 19"/>
           <p:cNvSpPr txBox="1"/>
           <p:nvPr/>
         </p:nvSpPr>
@@ -8881,6 +9037,45 @@
         </p:nvSpPr>
         <p:spPr>
           <a:xfrm>
+            <a:off x="5166360" y="6309360"/>
+            <a:ext cx="1828800" cy="292608"/>
+          </a:xfrm>
+          <a:prstGeom prst="rect">
+            <a:avLst/>
+          </a:prstGeom>
+          <a:noFill/>
+          <a:ln/>
+        </p:spPr>
+        <p:txBody>
+          <a:bodyPr wrap="square" lIns="0" tIns="0" rIns="0" bIns="0" rtlCol="0" anchor="ctr"/>
+          <a:lstStyle/>
+          <a:p>
+            <a:pPr algn="ctr" indent="0" marL="0">
+              <a:buNone/>
+            </a:pPr>
+            <a:r>
+              <a:rPr lang="en-US" sz="1100" dirty="0">
+                <a:solidFill>
+                  <a:srgbClr val="6B7186"/>
+                </a:solidFill>
+                <a:latin typeface="맑은 고딕" pitchFamily="34" charset="0"/>
+                <a:ea typeface="맑은 고딕" pitchFamily="34" charset="-122"/>
+                <a:cs typeface="맑은 고딕" pitchFamily="34" charset="-120"/>
+              </a:rPr>
+              <a:t>- 3 -</a:t>
+            </a:r>
+            <a:endParaRPr lang="en-US" sz="1100" dirty="0"/>
+          </a:p>
+        </p:txBody>
+      </p:sp>
+      <p:sp>
+        <p:nvSpPr>
+          <p:cNvPr id="4" name="Text 1"/>
+          <p:cNvSpPr txBox="1"/>
+          <p:nvPr/>
+        </p:nvSpPr>
+        <p:spPr>
+          <a:xfrm>
             <a:off x="566928" y="329184"/>
             <a:ext cx="11027664" cy="237744"/>
           </a:xfrm>
@@ -8914,7 +9109,7 @@
       </p:sp>
       <p:sp>
         <p:nvSpPr>
-          <p:cNvPr id="4" name="Text 1"/>
+          <p:cNvPr id="5" name="Text 2"/>
           <p:cNvSpPr txBox="1"/>
           <p:nvPr/>
         </p:nvSpPr>
@@ -8953,7 +9148,7 @@
       </p:sp>
       <p:sp>
         <p:nvSpPr>
-          <p:cNvPr id="5" name="Shape 2"/>
+          <p:cNvPr id="6" name="Shape 3"/>
           <p:cNvSpPr/>
           <p:nvPr/>
         </p:nvSpPr>
@@ -8987,7 +9182,7 @@
       </p:sp>
       <p:sp>
         <p:nvSpPr>
-          <p:cNvPr id="6" name="Shape 3"/>
+          <p:cNvPr id="7" name="Shape 4"/>
           <p:cNvSpPr/>
           <p:nvPr/>
         </p:nvSpPr>
@@ -9007,7 +9202,7 @@
       </p:sp>
       <p:sp>
         <p:nvSpPr>
-          <p:cNvPr id="7" name="Text 4"/>
+          <p:cNvPr id="8" name="Text 5"/>
           <p:cNvSpPr txBox="1"/>
           <p:nvPr/>
         </p:nvSpPr>
@@ -9046,7 +9241,7 @@
       </p:sp>
       <p:sp>
         <p:nvSpPr>
-          <p:cNvPr id="8" name="Text 5"/>
+          <p:cNvPr id="9" name="Text 6"/>
           <p:cNvSpPr txBox="1"/>
           <p:nvPr/>
         </p:nvSpPr>
@@ -9108,7 +9303,7 @@
       </p:sp>
       <p:sp>
         <p:nvSpPr>
-          <p:cNvPr id="9" name="Text 6"/>
+          <p:cNvPr id="10" name="Text 7"/>
           <p:cNvSpPr txBox="1"/>
           <p:nvPr/>
         </p:nvSpPr>
@@ -9147,7 +9342,7 @@
       </p:sp>
       <p:sp>
         <p:nvSpPr>
-          <p:cNvPr id="10" name="Shape 7"/>
+          <p:cNvPr id="11" name="Shape 8"/>
           <p:cNvSpPr/>
           <p:nvPr/>
         </p:nvSpPr>
@@ -9167,7 +9362,7 @@
       </p:sp>
       <p:sp>
         <p:nvSpPr>
-          <p:cNvPr id="11" name="Shape 8"/>
+          <p:cNvPr id="12" name="Shape 9"/>
           <p:cNvSpPr/>
           <p:nvPr/>
         </p:nvSpPr>
@@ -9201,7 +9396,7 @@
       </p:sp>
       <p:sp>
         <p:nvSpPr>
-          <p:cNvPr id="12" name="Shape 9"/>
+          <p:cNvPr id="13" name="Shape 10"/>
           <p:cNvSpPr/>
           <p:nvPr/>
         </p:nvSpPr>
@@ -9221,7 +9416,7 @@
       </p:sp>
       <p:sp>
         <p:nvSpPr>
-          <p:cNvPr id="13" name="Text 10"/>
+          <p:cNvPr id="14" name="Text 11"/>
           <p:cNvSpPr txBox="1"/>
           <p:nvPr/>
         </p:nvSpPr>
@@ -9260,7 +9455,7 @@
       </p:sp>
       <p:sp>
         <p:nvSpPr>
-          <p:cNvPr id="14" name="Text 11"/>
+          <p:cNvPr id="15" name="Text 12"/>
           <p:cNvSpPr txBox="1"/>
           <p:nvPr/>
         </p:nvSpPr>
@@ -9322,7 +9517,7 @@
       </p:sp>
       <p:sp>
         <p:nvSpPr>
-          <p:cNvPr id="15" name="Text 12"/>
+          <p:cNvPr id="16" name="Text 13"/>
           <p:cNvSpPr txBox="1"/>
           <p:nvPr/>
         </p:nvSpPr>
@@ -9361,7 +9556,7 @@
       </p:sp>
       <p:sp>
         <p:nvSpPr>
-          <p:cNvPr id="16" name="Shape 13"/>
+          <p:cNvPr id="17" name="Shape 14"/>
           <p:cNvSpPr/>
           <p:nvPr/>
         </p:nvSpPr>
@@ -9381,7 +9576,7 @@
       </p:sp>
       <p:sp>
         <p:nvSpPr>
-          <p:cNvPr id="17" name="Shape 14"/>
+          <p:cNvPr id="18" name="Shape 15"/>
           <p:cNvSpPr/>
           <p:nvPr/>
         </p:nvSpPr>
@@ -9415,7 +9610,7 @@
       </p:sp>
       <p:sp>
         <p:nvSpPr>
-          <p:cNvPr id="18" name="Shape 15"/>
+          <p:cNvPr id="19" name="Shape 16"/>
           <p:cNvSpPr/>
           <p:nvPr/>
         </p:nvSpPr>
@@ -9435,7 +9630,7 @@
       </p:sp>
       <p:sp>
         <p:nvSpPr>
-          <p:cNvPr id="19" name="Text 16"/>
+          <p:cNvPr id="20" name="Text 17"/>
           <p:cNvSpPr txBox="1"/>
           <p:nvPr/>
         </p:nvSpPr>
@@ -9474,7 +9669,7 @@
       </p:sp>
       <p:sp>
         <p:nvSpPr>
-          <p:cNvPr id="20" name="Text 17"/>
+          <p:cNvPr id="21" name="Text 18"/>
           <p:cNvSpPr txBox="1"/>
           <p:nvPr/>
         </p:nvSpPr>
@@ -9556,7 +9751,7 @@
       </p:sp>
       <p:sp>
         <p:nvSpPr>
-          <p:cNvPr id="21" name="Text 18"/>
+          <p:cNvPr id="22" name="Text 19"/>
           <p:cNvSpPr txBox="1"/>
           <p:nvPr/>
         </p:nvSpPr>
@@ -9595,7 +9790,7 @@
       </p:sp>
       <p:sp>
         <p:nvSpPr>
-          <p:cNvPr id="22" name="Shape 19"/>
+          <p:cNvPr id="23" name="Shape 20"/>
           <p:cNvSpPr/>
           <p:nvPr/>
         </p:nvSpPr>
@@ -9615,7 +9810,7 @@
       </p:sp>
       <p:sp>
         <p:nvSpPr>
-          <p:cNvPr id="23" name="Shape 20"/>
+          <p:cNvPr id="24" name="Shape 21"/>
           <p:cNvSpPr/>
           <p:nvPr/>
         </p:nvSpPr>
@@ -9649,7 +9844,7 @@
       </p:sp>
       <p:sp>
         <p:nvSpPr>
-          <p:cNvPr id="24" name="Shape 21"/>
+          <p:cNvPr id="25" name="Shape 22"/>
           <p:cNvSpPr/>
           <p:nvPr/>
         </p:nvSpPr>
@@ -9669,7 +9864,7 @@
       </p:sp>
       <p:sp>
         <p:nvSpPr>
-          <p:cNvPr id="25" name="Text 22"/>
+          <p:cNvPr id="26" name="Text 23"/>
           <p:cNvSpPr txBox="1"/>
           <p:nvPr/>
         </p:nvSpPr>
@@ -9708,7 +9903,7 @@
       </p:sp>
       <p:sp>
         <p:nvSpPr>
-          <p:cNvPr id="26" name="Text 23"/>
+          <p:cNvPr id="27" name="Text 24"/>
           <p:cNvSpPr txBox="1"/>
           <p:nvPr/>
         </p:nvSpPr>
@@ -9770,7 +9965,7 @@
       </p:sp>
       <p:sp>
         <p:nvSpPr>
-          <p:cNvPr id="27" name="Text 24"/>
+          <p:cNvPr id="28" name="Text 25"/>
           <p:cNvSpPr txBox="1"/>
           <p:nvPr/>
         </p:nvSpPr>
@@ -9809,7 +10004,7 @@
       </p:sp>
       <p:sp>
         <p:nvSpPr>
-          <p:cNvPr id="28" name="Shape 25"/>
+          <p:cNvPr id="29" name="Shape 26"/>
           <p:cNvSpPr/>
           <p:nvPr/>
         </p:nvSpPr>
@@ -9829,7 +10024,7 @@
       </p:sp>
       <p:sp>
         <p:nvSpPr>
-          <p:cNvPr id="29" name="Shape 26"/>
+          <p:cNvPr id="30" name="Shape 27"/>
           <p:cNvSpPr/>
           <p:nvPr/>
         </p:nvSpPr>
@@ -9863,7 +10058,7 @@
       </p:sp>
       <p:sp>
         <p:nvSpPr>
-          <p:cNvPr id="30" name="Shape 27"/>
+          <p:cNvPr id="31" name="Shape 28"/>
           <p:cNvSpPr/>
           <p:nvPr/>
         </p:nvSpPr>
@@ -9883,7 +10078,7 @@
       </p:sp>
       <p:sp>
         <p:nvSpPr>
-          <p:cNvPr id="31" name="Text 28"/>
+          <p:cNvPr id="32" name="Text 29"/>
           <p:cNvSpPr txBox="1"/>
           <p:nvPr/>
         </p:nvSpPr>
@@ -9922,7 +10117,7 @@
       </p:sp>
       <p:sp>
         <p:nvSpPr>
-          <p:cNvPr id="32" name="Text 29"/>
+          <p:cNvPr id="33" name="Text 30"/>
           <p:cNvSpPr txBox="1"/>
           <p:nvPr/>
         </p:nvSpPr>
@@ -9964,7 +10159,7 @@
       </p:sp>
       <p:sp>
         <p:nvSpPr>
-          <p:cNvPr id="33" name="Text 30"/>
+          <p:cNvPr id="34" name="Text 31"/>
           <p:cNvSpPr txBox="1"/>
           <p:nvPr/>
         </p:nvSpPr>
@@ -10003,7 +10198,7 @@
       </p:sp>
       <p:sp>
         <p:nvSpPr>
-          <p:cNvPr id="34" name="Shape 31"/>
+          <p:cNvPr id="35" name="Shape 32"/>
           <p:cNvSpPr/>
           <p:nvPr/>
         </p:nvSpPr>
@@ -10037,7 +10232,7 @@
       </p:sp>
       <p:sp>
         <p:nvSpPr>
-          <p:cNvPr id="35" name="Text 32"/>
+          <p:cNvPr id="36" name="Text 33"/>
           <p:cNvSpPr txBox="1"/>
           <p:nvPr/>
         </p:nvSpPr>
@@ -10138,6 +10333,45 @@
         </p:nvSpPr>
         <p:spPr>
           <a:xfrm>
+            <a:off x="5166360" y="6309360"/>
+            <a:ext cx="1828800" cy="292608"/>
+          </a:xfrm>
+          <a:prstGeom prst="rect">
+            <a:avLst/>
+          </a:prstGeom>
+          <a:noFill/>
+          <a:ln/>
+        </p:spPr>
+        <p:txBody>
+          <a:bodyPr wrap="square" lIns="0" tIns="0" rIns="0" bIns="0" rtlCol="0" anchor="ctr"/>
+          <a:lstStyle/>
+          <a:p>
+            <a:pPr algn="ctr" indent="0" marL="0">
+              <a:buNone/>
+            </a:pPr>
+            <a:r>
+              <a:rPr lang="en-US" sz="1100" dirty="0">
+                <a:solidFill>
+                  <a:srgbClr val="6B7186"/>
+                </a:solidFill>
+                <a:latin typeface="맑은 고딕" pitchFamily="34" charset="0"/>
+                <a:ea typeface="맑은 고딕" pitchFamily="34" charset="-122"/>
+                <a:cs typeface="맑은 고딕" pitchFamily="34" charset="-120"/>
+              </a:rPr>
+              <a:t>- 4 -</a:t>
+            </a:r>
+            <a:endParaRPr lang="en-US" sz="1100" dirty="0"/>
+          </a:p>
+        </p:txBody>
+      </p:sp>
+      <p:sp>
+        <p:nvSpPr>
+          <p:cNvPr id="4" name="Text 1"/>
+          <p:cNvSpPr txBox="1"/>
+          <p:nvPr/>
+        </p:nvSpPr>
+        <p:spPr>
+          <a:xfrm>
             <a:off x="566928" y="329184"/>
             <a:ext cx="11027664" cy="237744"/>
           </a:xfrm>
@@ -10171,7 +10405,7 @@
       </p:sp>
       <p:sp>
         <p:nvSpPr>
-          <p:cNvPr id="4" name="Text 1"/>
+          <p:cNvPr id="5" name="Text 2"/>
           <p:cNvSpPr txBox="1"/>
           <p:nvPr/>
         </p:nvSpPr>
@@ -10210,7 +10444,7 @@
       </p:sp>
       <p:sp>
         <p:nvSpPr>
-          <p:cNvPr id="5" name="Shape 2"/>
+          <p:cNvPr id="6" name="Shape 3"/>
           <p:cNvSpPr/>
           <p:nvPr/>
         </p:nvSpPr>
@@ -10244,7 +10478,7 @@
       </p:sp>
       <p:sp>
         <p:nvSpPr>
-          <p:cNvPr id="6" name="Shape 3"/>
+          <p:cNvPr id="7" name="Shape 4"/>
           <p:cNvSpPr/>
           <p:nvPr/>
         </p:nvSpPr>
@@ -10264,7 +10498,7 @@
       </p:sp>
       <p:sp>
         <p:nvSpPr>
-          <p:cNvPr id="7" name="Text 4"/>
+          <p:cNvPr id="8" name="Text 5"/>
           <p:cNvSpPr txBox="1"/>
           <p:nvPr/>
         </p:nvSpPr>
@@ -10303,7 +10537,7 @@
       </p:sp>
       <p:sp>
         <p:nvSpPr>
-          <p:cNvPr id="8" name="Text 5"/>
+          <p:cNvPr id="9" name="Text 6"/>
           <p:cNvSpPr txBox="1"/>
           <p:nvPr/>
         </p:nvSpPr>
@@ -10345,7 +10579,7 @@
       </p:sp>
       <p:sp>
         <p:nvSpPr>
-          <p:cNvPr id="9" name="Shape 6"/>
+          <p:cNvPr id="10" name="Shape 7"/>
           <p:cNvSpPr/>
           <p:nvPr/>
         </p:nvSpPr>
@@ -10365,7 +10599,7 @@
       </p:sp>
       <p:sp>
         <p:nvSpPr>
-          <p:cNvPr id="10" name="Shape 7"/>
+          <p:cNvPr id="11" name="Shape 8"/>
           <p:cNvSpPr/>
           <p:nvPr/>
         </p:nvSpPr>
@@ -10399,7 +10633,7 @@
       </p:sp>
       <p:sp>
         <p:nvSpPr>
-          <p:cNvPr id="11" name="Shape 8"/>
+          <p:cNvPr id="12" name="Shape 9"/>
           <p:cNvSpPr/>
           <p:nvPr/>
         </p:nvSpPr>
@@ -10419,7 +10653,7 @@
       </p:sp>
       <p:sp>
         <p:nvSpPr>
-          <p:cNvPr id="12" name="Text 9"/>
+          <p:cNvPr id="13" name="Text 10"/>
           <p:cNvSpPr txBox="1"/>
           <p:nvPr/>
         </p:nvSpPr>
@@ -10458,7 +10692,7 @@
       </p:sp>
       <p:sp>
         <p:nvSpPr>
-          <p:cNvPr id="13" name="Text 10"/>
+          <p:cNvPr id="14" name="Text 11"/>
           <p:cNvSpPr txBox="1"/>
           <p:nvPr/>
         </p:nvSpPr>
@@ -10500,7 +10734,7 @@
       </p:sp>
       <p:sp>
         <p:nvSpPr>
-          <p:cNvPr id="14" name="Text 11"/>
+          <p:cNvPr id="15" name="Text 12"/>
           <p:cNvSpPr txBox="1"/>
           <p:nvPr/>
         </p:nvSpPr>
@@ -10542,7 +10776,7 @@
       </p:sp>
       <p:sp>
         <p:nvSpPr>
-          <p:cNvPr id="15" name="Shape 12"/>
+          <p:cNvPr id="16" name="Shape 13"/>
           <p:cNvSpPr/>
           <p:nvPr/>
         </p:nvSpPr>
@@ -10562,7 +10796,7 @@
       </p:sp>
       <p:sp>
         <p:nvSpPr>
-          <p:cNvPr id="16" name="Shape 13"/>
+          <p:cNvPr id="17" name="Shape 14"/>
           <p:cNvSpPr/>
           <p:nvPr/>
         </p:nvSpPr>
@@ -10596,7 +10830,7 @@
       </p:sp>
       <p:sp>
         <p:nvSpPr>
-          <p:cNvPr id="17" name="Shape 14"/>
+          <p:cNvPr id="18" name="Shape 15"/>
           <p:cNvSpPr/>
           <p:nvPr/>
         </p:nvSpPr>
@@ -10616,7 +10850,7 @@
       </p:sp>
       <p:sp>
         <p:nvSpPr>
-          <p:cNvPr id="18" name="Text 15"/>
+          <p:cNvPr id="19" name="Text 16"/>
           <p:cNvSpPr txBox="1"/>
           <p:nvPr/>
         </p:nvSpPr>
@@ -10655,7 +10889,7 @@
       </p:sp>
       <p:sp>
         <p:nvSpPr>
-          <p:cNvPr id="19" name="Text 16"/>
+          <p:cNvPr id="20" name="Text 17"/>
           <p:cNvSpPr txBox="1"/>
           <p:nvPr/>
         </p:nvSpPr>
@@ -10717,7 +10951,7 @@
       </p:sp>
       <p:sp>
         <p:nvSpPr>
-          <p:cNvPr id="20" name="Text 17"/>
+          <p:cNvPr id="21" name="Text 18"/>
           <p:cNvSpPr txBox="1"/>
           <p:nvPr/>
         </p:nvSpPr>
@@ -10779,7 +11013,7 @@
       </p:sp>
       <p:sp>
         <p:nvSpPr>
-          <p:cNvPr id="21" name="Shape 18"/>
+          <p:cNvPr id="22" name="Shape 19"/>
           <p:cNvSpPr/>
           <p:nvPr/>
         </p:nvSpPr>
@@ -10799,7 +11033,7 @@
       </p:sp>
       <p:sp>
         <p:nvSpPr>
-          <p:cNvPr id="22" name="Shape 19"/>
+          <p:cNvPr id="23" name="Shape 20"/>
           <p:cNvSpPr/>
           <p:nvPr/>
         </p:nvSpPr>
@@ -10833,7 +11067,7 @@
       </p:sp>
       <p:sp>
         <p:nvSpPr>
-          <p:cNvPr id="23" name="Shape 20"/>
+          <p:cNvPr id="24" name="Shape 21"/>
           <p:cNvSpPr/>
           <p:nvPr/>
         </p:nvSpPr>
@@ -10853,7 +11087,7 @@
       </p:sp>
       <p:sp>
         <p:nvSpPr>
-          <p:cNvPr id="24" name="Text 21"/>
+          <p:cNvPr id="25" name="Text 22"/>
           <p:cNvSpPr txBox="1"/>
           <p:nvPr/>
         </p:nvSpPr>
@@ -10892,7 +11126,7 @@
       </p:sp>
       <p:sp>
         <p:nvSpPr>
-          <p:cNvPr id="25" name="Text 22"/>
+          <p:cNvPr id="26" name="Text 23"/>
           <p:cNvSpPr txBox="1"/>
           <p:nvPr/>
         </p:nvSpPr>
@@ -10954,7 +11188,7 @@
       </p:sp>
       <p:sp>
         <p:nvSpPr>
-          <p:cNvPr id="26" name="Text 23"/>
+          <p:cNvPr id="27" name="Text 24"/>
           <p:cNvSpPr txBox="1"/>
           <p:nvPr/>
         </p:nvSpPr>
@@ -11039,7 +11273,7 @@
       </p:sp>
       <p:sp>
         <p:nvSpPr>
-          <p:cNvPr id="27" name="Shape 24"/>
+          <p:cNvPr id="28" name="Shape 25"/>
           <p:cNvSpPr/>
           <p:nvPr/>
         </p:nvSpPr>
@@ -11059,7 +11293,7 @@
       </p:sp>
       <p:sp>
         <p:nvSpPr>
-          <p:cNvPr id="28" name="Shape 25"/>
+          <p:cNvPr id="29" name="Shape 26"/>
           <p:cNvSpPr/>
           <p:nvPr/>
         </p:nvSpPr>
@@ -11093,7 +11327,7 @@
       </p:sp>
       <p:sp>
         <p:nvSpPr>
-          <p:cNvPr id="29" name="Shape 26"/>
+          <p:cNvPr id="30" name="Shape 27"/>
           <p:cNvSpPr/>
           <p:nvPr/>
         </p:nvSpPr>
@@ -11113,7 +11347,7 @@
       </p:sp>
       <p:sp>
         <p:nvSpPr>
-          <p:cNvPr id="30" name="Text 27"/>
+          <p:cNvPr id="31" name="Text 28"/>
           <p:cNvSpPr txBox="1"/>
           <p:nvPr/>
         </p:nvSpPr>
@@ -11152,7 +11386,7 @@
       </p:sp>
       <p:sp>
         <p:nvSpPr>
-          <p:cNvPr id="31" name="Text 28"/>
+          <p:cNvPr id="32" name="Text 29"/>
           <p:cNvSpPr txBox="1"/>
           <p:nvPr/>
         </p:nvSpPr>
@@ -11214,7 +11448,7 @@
       </p:sp>
       <p:sp>
         <p:nvSpPr>
-          <p:cNvPr id="32" name="Text 29"/>
+          <p:cNvPr id="33" name="Text 30"/>
           <p:cNvSpPr txBox="1"/>
           <p:nvPr/>
         </p:nvSpPr>
@@ -11256,7 +11490,7 @@
       </p:sp>
       <p:sp>
         <p:nvSpPr>
-          <p:cNvPr id="33" name="Shape 30"/>
+          <p:cNvPr id="34" name="Shape 31"/>
           <p:cNvSpPr/>
           <p:nvPr/>
         </p:nvSpPr>
@@ -11290,7 +11524,7 @@
       </p:sp>
       <p:sp>
         <p:nvSpPr>
-          <p:cNvPr id="34" name="Text 31"/>
+          <p:cNvPr id="35" name="Text 32"/>
           <p:cNvSpPr txBox="1"/>
           <p:nvPr/>
         </p:nvSpPr>
@@ -11329,7 +11563,7 @@
       </p:sp>
       <p:sp>
         <p:nvSpPr>
-          <p:cNvPr id="35" name="Text 32"/>
+          <p:cNvPr id="36" name="Text 33"/>
           <p:cNvSpPr txBox="1"/>
           <p:nvPr/>
         </p:nvSpPr>
@@ -11371,7 +11605,7 @@
       </p:sp>
       <p:sp>
         <p:nvSpPr>
-          <p:cNvPr id="36" name="Shape 33"/>
+          <p:cNvPr id="37" name="Shape 34"/>
           <p:cNvSpPr/>
           <p:nvPr/>
         </p:nvSpPr>
@@ -11405,7 +11639,7 @@
       </p:sp>
       <p:sp>
         <p:nvSpPr>
-          <p:cNvPr id="37" name="Text 34"/>
+          <p:cNvPr id="38" name="Text 35"/>
           <p:cNvSpPr txBox="1"/>
           <p:nvPr/>
         </p:nvSpPr>
@@ -11444,7 +11678,7 @@
       </p:sp>
       <p:sp>
         <p:nvSpPr>
-          <p:cNvPr id="38" name="Text 35"/>
+          <p:cNvPr id="39" name="Text 36"/>
           <p:cNvSpPr txBox="1"/>
           <p:nvPr/>
         </p:nvSpPr>
@@ -11548,6 +11782,45 @@
         </p:nvSpPr>
         <p:spPr>
           <a:xfrm>
+            <a:off x="5166360" y="6309360"/>
+            <a:ext cx="1828800" cy="292608"/>
+          </a:xfrm>
+          <a:prstGeom prst="rect">
+            <a:avLst/>
+          </a:prstGeom>
+          <a:noFill/>
+          <a:ln/>
+        </p:spPr>
+        <p:txBody>
+          <a:bodyPr wrap="square" lIns="0" tIns="0" rIns="0" bIns="0" rtlCol="0" anchor="ctr"/>
+          <a:lstStyle/>
+          <a:p>
+            <a:pPr algn="ctr" indent="0" marL="0">
+              <a:buNone/>
+            </a:pPr>
+            <a:r>
+              <a:rPr lang="en-US" sz="1100" dirty="0">
+                <a:solidFill>
+                  <a:srgbClr val="6B7186"/>
+                </a:solidFill>
+                <a:latin typeface="맑은 고딕" pitchFamily="34" charset="0"/>
+                <a:ea typeface="맑은 고딕" pitchFamily="34" charset="-122"/>
+                <a:cs typeface="맑은 고딕" pitchFamily="34" charset="-120"/>
+              </a:rPr>
+              <a:t>- 5 -</a:t>
+            </a:r>
+            <a:endParaRPr lang="en-US" sz="1100" dirty="0"/>
+          </a:p>
+        </p:txBody>
+      </p:sp>
+      <p:sp>
+        <p:nvSpPr>
+          <p:cNvPr id="4" name="Text 1"/>
+          <p:cNvSpPr txBox="1"/>
+          <p:nvPr/>
+        </p:nvSpPr>
+        <p:spPr>
+          <a:xfrm>
             <a:off x="566928" y="329184"/>
             <a:ext cx="11027664" cy="237744"/>
           </a:xfrm>
@@ -11573,7 +11846,7 @@
                 <a:ea typeface="맑은 고딕" pitchFamily="34" charset="-122"/>
                 <a:cs typeface="맑은 고딕" pitchFamily="34" charset="-120"/>
               </a:rPr>
-              <a:t>STEP 01  APPLICATION</a:t>
+              <a:t>전형 절차   1단계 / 4단계</a:t>
             </a:r>
             <a:endParaRPr lang="en-US" sz="1200" dirty="0"/>
           </a:p>
@@ -11581,7 +11854,7 @@
       </p:sp>
       <p:sp>
         <p:nvSpPr>
-          <p:cNvPr id="4" name="Text 1"/>
+          <p:cNvPr id="5" name="Text 2"/>
           <p:cNvSpPr txBox="1"/>
           <p:nvPr/>
         </p:nvSpPr>
@@ -11620,7 +11893,251 @@
       </p:sp>
       <p:sp>
         <p:nvSpPr>
-          <p:cNvPr id="5" name="Shape 2"/>
+          <p:cNvPr id="6" name="Shape 3"/>
+          <p:cNvSpPr/>
+          <p:nvPr/>
+        </p:nvSpPr>
+        <p:spPr>
+          <a:xfrm>
+            <a:off x="6748272" y="566928"/>
+            <a:ext cx="868680" cy="402336"/>
+          </a:xfrm>
+          <a:prstGeom prst="roundRect">
+            <a:avLst>
+              <a:gd name="adj" fmla="val 50000"/>
+            </a:avLst>
+          </a:prstGeom>
+          <a:solidFill>
+            <a:srgbClr val="1E2761"/>
+          </a:solidFill>
+          <a:ln/>
+        </p:spPr>
+      </p:sp>
+      <p:sp>
+        <p:nvSpPr>
+          <p:cNvPr id="7" name="Text 4"/>
+          <p:cNvSpPr txBox="1"/>
+          <p:nvPr/>
+        </p:nvSpPr>
+        <p:spPr>
+          <a:xfrm>
+            <a:off x="6748272" y="566928"/>
+            <a:ext cx="868680" cy="402336"/>
+          </a:xfrm>
+          <a:prstGeom prst="rect">
+            <a:avLst/>
+          </a:prstGeom>
+          <a:noFill/>
+          <a:ln/>
+        </p:spPr>
+        <p:txBody>
+          <a:bodyPr wrap="square" lIns="0" tIns="0" rIns="0" bIns="0" rtlCol="0" anchor="ctr"/>
+          <a:lstStyle/>
+          <a:p>
+            <a:pPr algn="ctr" indent="0" marL="0">
+              <a:buNone/>
+            </a:pPr>
+            <a:r>
+              <a:rPr lang="en-US" sz="1150" b="1" dirty="0">
+                <a:solidFill>
+                  <a:srgbClr val="FFFFFF"/>
+                </a:solidFill>
+                <a:latin typeface="맑은 고딕" pitchFamily="34" charset="0"/>
+                <a:ea typeface="맑은 고딕" pitchFamily="34" charset="-122"/>
+                <a:cs typeface="맑은 고딕" pitchFamily="34" charset="-120"/>
+              </a:rPr>
+              <a:t>1 접수</a:t>
+            </a:r>
+            <a:endParaRPr lang="en-US" sz="1150" dirty="0"/>
+          </a:p>
+        </p:txBody>
+      </p:sp>
+      <p:sp>
+        <p:nvSpPr>
+          <p:cNvPr id="8" name="Shape 5"/>
+          <p:cNvSpPr/>
+          <p:nvPr/>
+        </p:nvSpPr>
+        <p:spPr>
+          <a:xfrm>
+            <a:off x="7690104" y="566928"/>
+            <a:ext cx="868680" cy="402336"/>
+          </a:xfrm>
+          <a:prstGeom prst="roundRect">
+            <a:avLst>
+              <a:gd name="adj" fmla="val 50000"/>
+            </a:avLst>
+          </a:prstGeom>
+          <a:solidFill>
+            <a:srgbClr val="E8EFFC"/>
+          </a:solidFill>
+          <a:ln/>
+        </p:spPr>
+      </p:sp>
+      <p:sp>
+        <p:nvSpPr>
+          <p:cNvPr id="9" name="Text 6"/>
+          <p:cNvSpPr txBox="1"/>
+          <p:nvPr/>
+        </p:nvSpPr>
+        <p:spPr>
+          <a:xfrm>
+            <a:off x="7690104" y="566928"/>
+            <a:ext cx="868680" cy="402336"/>
+          </a:xfrm>
+          <a:prstGeom prst="rect">
+            <a:avLst/>
+          </a:prstGeom>
+          <a:noFill/>
+          <a:ln/>
+        </p:spPr>
+        <p:txBody>
+          <a:bodyPr wrap="square" lIns="0" tIns="0" rIns="0" bIns="0" rtlCol="0" anchor="ctr"/>
+          <a:lstStyle/>
+          <a:p>
+            <a:pPr algn="ctr" indent="0" marL="0">
+              <a:buNone/>
+            </a:pPr>
+            <a:r>
+              <a:rPr lang="en-US" sz="1150" dirty="0">
+                <a:solidFill>
+                  <a:srgbClr val="8A93AD"/>
+                </a:solidFill>
+                <a:latin typeface="맑은 고딕" pitchFamily="34" charset="0"/>
+                <a:ea typeface="맑은 고딕" pitchFamily="34" charset="-122"/>
+                <a:cs typeface="맑은 고딕" pitchFamily="34" charset="-120"/>
+              </a:rPr>
+              <a:t>2 서류</a:t>
+            </a:r>
+            <a:endParaRPr lang="en-US" sz="1150" dirty="0"/>
+          </a:p>
+        </p:txBody>
+      </p:sp>
+      <p:sp>
+        <p:nvSpPr>
+          <p:cNvPr id="10" name="Shape 7"/>
+          <p:cNvSpPr/>
+          <p:nvPr/>
+        </p:nvSpPr>
+        <p:spPr>
+          <a:xfrm>
+            <a:off x="8631936" y="566928"/>
+            <a:ext cx="868680" cy="402336"/>
+          </a:xfrm>
+          <a:prstGeom prst="roundRect">
+            <a:avLst>
+              <a:gd name="adj" fmla="val 50000"/>
+            </a:avLst>
+          </a:prstGeom>
+          <a:solidFill>
+            <a:srgbClr val="E8EFFC"/>
+          </a:solidFill>
+          <a:ln/>
+        </p:spPr>
+      </p:sp>
+      <p:sp>
+        <p:nvSpPr>
+          <p:cNvPr id="11" name="Text 8"/>
+          <p:cNvSpPr txBox="1"/>
+          <p:nvPr/>
+        </p:nvSpPr>
+        <p:spPr>
+          <a:xfrm>
+            <a:off x="8631936" y="566928"/>
+            <a:ext cx="868680" cy="402336"/>
+          </a:xfrm>
+          <a:prstGeom prst="rect">
+            <a:avLst/>
+          </a:prstGeom>
+          <a:noFill/>
+          <a:ln/>
+        </p:spPr>
+        <p:txBody>
+          <a:bodyPr wrap="square" lIns="0" tIns="0" rIns="0" bIns="0" rtlCol="0" anchor="ctr"/>
+          <a:lstStyle/>
+          <a:p>
+            <a:pPr algn="ctr" indent="0" marL="0">
+              <a:buNone/>
+            </a:pPr>
+            <a:r>
+              <a:rPr lang="en-US" sz="1150" dirty="0">
+                <a:solidFill>
+                  <a:srgbClr val="8A93AD"/>
+                </a:solidFill>
+                <a:latin typeface="맑은 고딕" pitchFamily="34" charset="0"/>
+                <a:ea typeface="맑은 고딕" pitchFamily="34" charset="-122"/>
+                <a:cs typeface="맑은 고딕" pitchFamily="34" charset="-120"/>
+              </a:rPr>
+              <a:t>3 면접</a:t>
+            </a:r>
+            <a:endParaRPr lang="en-US" sz="1150" dirty="0"/>
+          </a:p>
+        </p:txBody>
+      </p:sp>
+      <p:sp>
+        <p:nvSpPr>
+          <p:cNvPr id="12" name="Shape 9"/>
+          <p:cNvSpPr/>
+          <p:nvPr/>
+        </p:nvSpPr>
+        <p:spPr>
+          <a:xfrm>
+            <a:off x="9573768" y="566928"/>
+            <a:ext cx="868680" cy="402336"/>
+          </a:xfrm>
+          <a:prstGeom prst="roundRect">
+            <a:avLst>
+              <a:gd name="adj" fmla="val 50000"/>
+            </a:avLst>
+          </a:prstGeom>
+          <a:solidFill>
+            <a:srgbClr val="E8EFFC"/>
+          </a:solidFill>
+          <a:ln/>
+        </p:spPr>
+      </p:sp>
+      <p:sp>
+        <p:nvSpPr>
+          <p:cNvPr id="13" name="Text 10"/>
+          <p:cNvSpPr txBox="1"/>
+          <p:nvPr/>
+        </p:nvSpPr>
+        <p:spPr>
+          <a:xfrm>
+            <a:off x="9573768" y="566928"/>
+            <a:ext cx="868680" cy="402336"/>
+          </a:xfrm>
+          <a:prstGeom prst="rect">
+            <a:avLst/>
+          </a:prstGeom>
+          <a:noFill/>
+          <a:ln/>
+        </p:spPr>
+        <p:txBody>
+          <a:bodyPr wrap="square" lIns="0" tIns="0" rIns="0" bIns="0" rtlCol="0" anchor="ctr"/>
+          <a:lstStyle/>
+          <a:p>
+            <a:pPr algn="ctr" indent="0" marL="0">
+              <a:buNone/>
+            </a:pPr>
+            <a:r>
+              <a:rPr lang="en-US" sz="1150" dirty="0">
+                <a:solidFill>
+                  <a:srgbClr val="8A93AD"/>
+                </a:solidFill>
+                <a:latin typeface="맑은 고딕" pitchFamily="34" charset="0"/>
+                <a:ea typeface="맑은 고딕" pitchFamily="34" charset="-122"/>
+                <a:cs typeface="맑은 고딕" pitchFamily="34" charset="-120"/>
+              </a:rPr>
+              <a:t>4 검증</a:t>
+            </a:r>
+            <a:endParaRPr lang="en-US" sz="1150" dirty="0"/>
+          </a:p>
+        </p:txBody>
+      </p:sp>
+      <p:sp>
+        <p:nvSpPr>
+          <p:cNvPr id="14" name="Shape 11"/>
           <p:cNvSpPr/>
           <p:nvPr/>
         </p:nvSpPr>
@@ -11654,7 +12171,7 @@
       </p:sp>
       <p:sp>
         <p:nvSpPr>
-          <p:cNvPr id="6" name="Text 3"/>
+          <p:cNvPr id="15" name="Text 12"/>
           <p:cNvSpPr txBox="1"/>
           <p:nvPr/>
         </p:nvSpPr>
@@ -11693,7 +12210,7 @@
       </p:sp>
       <p:sp>
         <p:nvSpPr>
-          <p:cNvPr id="7" name="Shape 4"/>
+          <p:cNvPr id="16" name="Shape 13"/>
           <p:cNvSpPr/>
           <p:nvPr/>
         </p:nvSpPr>
@@ -11713,7 +12230,7 @@
       </p:sp>
       <p:sp>
         <p:nvSpPr>
-          <p:cNvPr id="8" name="Text 5"/>
+          <p:cNvPr id="17" name="Text 14"/>
           <p:cNvSpPr txBox="1"/>
           <p:nvPr/>
         </p:nvSpPr>
@@ -11755,7 +12272,7 @@
       </p:sp>
       <p:sp>
         <p:nvSpPr>
-          <p:cNvPr id="9" name="Shape 6"/>
+          <p:cNvPr id="18" name="Shape 15"/>
           <p:cNvSpPr/>
           <p:nvPr/>
         </p:nvSpPr>
@@ -11775,7 +12292,7 @@
       </p:sp>
       <p:sp>
         <p:nvSpPr>
-          <p:cNvPr id="10" name="Text 7"/>
+          <p:cNvPr id="19" name="Text 16"/>
           <p:cNvSpPr txBox="1"/>
           <p:nvPr/>
         </p:nvSpPr>
@@ -11817,7 +12334,7 @@
       </p:sp>
       <p:sp>
         <p:nvSpPr>
-          <p:cNvPr id="11" name="Shape 8"/>
+          <p:cNvPr id="20" name="Shape 17"/>
           <p:cNvSpPr/>
           <p:nvPr/>
         </p:nvSpPr>
@@ -11851,7 +12368,7 @@
       </p:sp>
       <p:sp>
         <p:nvSpPr>
-          <p:cNvPr id="12" name="Text 9"/>
+          <p:cNvPr id="21" name="Text 18"/>
           <p:cNvSpPr txBox="1"/>
           <p:nvPr/>
         </p:nvSpPr>
@@ -11890,7 +12407,7 @@
       </p:sp>
       <p:sp>
         <p:nvSpPr>
-          <p:cNvPr id="13" name="Text 10"/>
+          <p:cNvPr id="22" name="Text 19"/>
           <p:cNvSpPr txBox="1"/>
           <p:nvPr/>
         </p:nvSpPr>
@@ -11929,7 +12446,7 @@
       </p:sp>
       <p:sp>
         <p:nvSpPr>
-          <p:cNvPr id="14" name="Text 11"/>
+          <p:cNvPr id="23" name="Text 20"/>
           <p:cNvSpPr txBox="1"/>
           <p:nvPr/>
         </p:nvSpPr>
@@ -11968,7 +12485,7 @@
       </p:sp>
       <p:sp>
         <p:nvSpPr>
-          <p:cNvPr id="15" name="Shape 12"/>
+          <p:cNvPr id="24" name="Shape 21"/>
           <p:cNvSpPr/>
           <p:nvPr/>
         </p:nvSpPr>
@@ -12002,7 +12519,7 @@
       </p:sp>
       <p:sp>
         <p:nvSpPr>
-          <p:cNvPr id="16" name="Shape 13"/>
+          <p:cNvPr id="25" name="Shape 22"/>
           <p:cNvSpPr/>
           <p:nvPr/>
         </p:nvSpPr>
@@ -12022,7 +12539,7 @@
       </p:sp>
       <p:sp>
         <p:nvSpPr>
-          <p:cNvPr id="17" name="Text 14"/>
+          <p:cNvPr id="26" name="Text 23"/>
           <p:cNvSpPr txBox="1"/>
           <p:nvPr/>
         </p:nvSpPr>
@@ -12061,7 +12578,7 @@
       </p:sp>
       <p:sp>
         <p:nvSpPr>
-          <p:cNvPr id="18" name="Text 15"/>
+          <p:cNvPr id="27" name="Text 24"/>
           <p:cNvSpPr txBox="1"/>
           <p:nvPr/>
         </p:nvSpPr>
@@ -12103,7 +12620,7 @@
       </p:sp>
       <p:sp>
         <p:nvSpPr>
-          <p:cNvPr id="19" name="Shape 16"/>
+          <p:cNvPr id="28" name="Shape 25"/>
           <p:cNvSpPr/>
           <p:nvPr/>
         </p:nvSpPr>
@@ -12137,7 +12654,7 @@
       </p:sp>
       <p:sp>
         <p:nvSpPr>
-          <p:cNvPr id="20" name="Shape 17"/>
+          <p:cNvPr id="29" name="Shape 26"/>
           <p:cNvSpPr/>
           <p:nvPr/>
         </p:nvSpPr>
@@ -12157,7 +12674,7 @@
       </p:sp>
       <p:sp>
         <p:nvSpPr>
-          <p:cNvPr id="21" name="Text 18"/>
+          <p:cNvPr id="30" name="Text 27"/>
           <p:cNvSpPr txBox="1"/>
           <p:nvPr/>
         </p:nvSpPr>
@@ -12196,7 +12713,7 @@
       </p:sp>
       <p:sp>
         <p:nvSpPr>
-          <p:cNvPr id="22" name="Text 19"/>
+          <p:cNvPr id="31" name="Text 28"/>
           <p:cNvSpPr txBox="1"/>
           <p:nvPr/>
         </p:nvSpPr>
@@ -12238,7 +12755,7 @@
       </p:sp>
       <p:sp>
         <p:nvSpPr>
-          <p:cNvPr id="23" name="Shape 20"/>
+          <p:cNvPr id="32" name="Shape 29"/>
           <p:cNvSpPr/>
           <p:nvPr/>
         </p:nvSpPr>
@@ -12272,7 +12789,7 @@
       </p:sp>
       <p:sp>
         <p:nvSpPr>
-          <p:cNvPr id="24" name="Shape 21"/>
+          <p:cNvPr id="33" name="Shape 30"/>
           <p:cNvSpPr/>
           <p:nvPr/>
         </p:nvSpPr>
@@ -12292,7 +12809,7 @@
       </p:sp>
       <p:sp>
         <p:nvSpPr>
-          <p:cNvPr id="25" name="Text 22"/>
+          <p:cNvPr id="34" name="Text 31"/>
           <p:cNvSpPr txBox="1"/>
           <p:nvPr/>
         </p:nvSpPr>
@@ -12331,7 +12848,7 @@
       </p:sp>
       <p:sp>
         <p:nvSpPr>
-          <p:cNvPr id="26" name="Text 23"/>
+          <p:cNvPr id="35" name="Text 32"/>
           <p:cNvSpPr txBox="1"/>
           <p:nvPr/>
         </p:nvSpPr>
@@ -12373,7 +12890,7 @@
       </p:sp>
       <p:sp>
         <p:nvSpPr>
-          <p:cNvPr id="27" name="Shape 24"/>
+          <p:cNvPr id="36" name="Shape 33"/>
           <p:cNvSpPr/>
           <p:nvPr/>
         </p:nvSpPr>
@@ -12407,7 +12924,7 @@
       </p:sp>
       <p:sp>
         <p:nvSpPr>
-          <p:cNvPr id="28" name="Shape 25"/>
+          <p:cNvPr id="37" name="Shape 34"/>
           <p:cNvSpPr/>
           <p:nvPr/>
         </p:nvSpPr>
@@ -12427,7 +12944,7 @@
       </p:sp>
       <p:sp>
         <p:nvSpPr>
-          <p:cNvPr id="29" name="Text 26"/>
+          <p:cNvPr id="38" name="Text 35"/>
           <p:cNvSpPr txBox="1"/>
           <p:nvPr/>
         </p:nvSpPr>
@@ -12466,7 +12983,7 @@
       </p:sp>
       <p:sp>
         <p:nvSpPr>
-          <p:cNvPr id="30" name="Text 27"/>
+          <p:cNvPr id="39" name="Text 36"/>
           <p:cNvSpPr txBox="1"/>
           <p:nvPr/>
         </p:nvSpPr>
@@ -12570,6 +13087,45 @@
         </p:nvSpPr>
         <p:spPr>
           <a:xfrm>
+            <a:off x="5166360" y="6309360"/>
+            <a:ext cx="1828800" cy="292608"/>
+          </a:xfrm>
+          <a:prstGeom prst="rect">
+            <a:avLst/>
+          </a:prstGeom>
+          <a:noFill/>
+          <a:ln/>
+        </p:spPr>
+        <p:txBody>
+          <a:bodyPr wrap="square" lIns="0" tIns="0" rIns="0" bIns="0" rtlCol="0" anchor="ctr"/>
+          <a:lstStyle/>
+          <a:p>
+            <a:pPr algn="ctr" indent="0" marL="0">
+              <a:buNone/>
+            </a:pPr>
+            <a:r>
+              <a:rPr lang="en-US" sz="1100" dirty="0">
+                <a:solidFill>
+                  <a:srgbClr val="6B7186"/>
+                </a:solidFill>
+                <a:latin typeface="맑은 고딕" pitchFamily="34" charset="0"/>
+                <a:ea typeface="맑은 고딕" pitchFamily="34" charset="-122"/>
+                <a:cs typeface="맑은 고딕" pitchFamily="34" charset="-120"/>
+              </a:rPr>
+              <a:t>- 6 -</a:t>
+            </a:r>
+            <a:endParaRPr lang="en-US" sz="1100" dirty="0"/>
+          </a:p>
+        </p:txBody>
+      </p:sp>
+      <p:sp>
+        <p:nvSpPr>
+          <p:cNvPr id="4" name="Text 1"/>
+          <p:cNvSpPr txBox="1"/>
+          <p:nvPr/>
+        </p:nvSpPr>
+        <p:spPr>
+          <a:xfrm>
             <a:off x="566928" y="329184"/>
             <a:ext cx="11027664" cy="237744"/>
           </a:xfrm>
@@ -12595,7 +13151,7 @@
                 <a:ea typeface="맑은 고딕" pitchFamily="34" charset="-122"/>
                 <a:cs typeface="맑은 고딕" pitchFamily="34" charset="-120"/>
               </a:rPr>
-              <a:t>STEP 02  DOCUMENT SCREENING</a:t>
+              <a:t>전형 절차   2단계 / 4단계</a:t>
             </a:r>
             <a:endParaRPr lang="en-US" sz="1200" dirty="0"/>
           </a:p>
@@ -12603,7 +13159,7 @@
       </p:sp>
       <p:sp>
         <p:nvSpPr>
-          <p:cNvPr id="4" name="Text 1"/>
+          <p:cNvPr id="5" name="Text 2"/>
           <p:cNvSpPr txBox="1"/>
           <p:nvPr/>
         </p:nvSpPr>
@@ -12642,7 +13198,251 @@
       </p:sp>
       <p:sp>
         <p:nvSpPr>
-          <p:cNvPr id="5" name="Text 2"/>
+          <p:cNvPr id="6" name="Shape 3"/>
+          <p:cNvSpPr/>
+          <p:nvPr/>
+        </p:nvSpPr>
+        <p:spPr>
+          <a:xfrm>
+            <a:off x="6748272" y="566928"/>
+            <a:ext cx="868680" cy="402336"/>
+          </a:xfrm>
+          <a:prstGeom prst="roundRect">
+            <a:avLst>
+              <a:gd name="adj" fmla="val 50000"/>
+            </a:avLst>
+          </a:prstGeom>
+          <a:solidFill>
+            <a:srgbClr val="E8EFFC"/>
+          </a:solidFill>
+          <a:ln/>
+        </p:spPr>
+      </p:sp>
+      <p:sp>
+        <p:nvSpPr>
+          <p:cNvPr id="7" name="Text 4"/>
+          <p:cNvSpPr txBox="1"/>
+          <p:nvPr/>
+        </p:nvSpPr>
+        <p:spPr>
+          <a:xfrm>
+            <a:off x="6748272" y="566928"/>
+            <a:ext cx="868680" cy="402336"/>
+          </a:xfrm>
+          <a:prstGeom prst="rect">
+            <a:avLst/>
+          </a:prstGeom>
+          <a:noFill/>
+          <a:ln/>
+        </p:spPr>
+        <p:txBody>
+          <a:bodyPr wrap="square" lIns="0" tIns="0" rIns="0" bIns="0" rtlCol="0" anchor="ctr"/>
+          <a:lstStyle/>
+          <a:p>
+            <a:pPr algn="ctr" indent="0" marL="0">
+              <a:buNone/>
+            </a:pPr>
+            <a:r>
+              <a:rPr lang="en-US" sz="1150" dirty="0">
+                <a:solidFill>
+                  <a:srgbClr val="8A93AD"/>
+                </a:solidFill>
+                <a:latin typeface="맑은 고딕" pitchFamily="34" charset="0"/>
+                <a:ea typeface="맑은 고딕" pitchFamily="34" charset="-122"/>
+                <a:cs typeface="맑은 고딕" pitchFamily="34" charset="-120"/>
+              </a:rPr>
+              <a:t>1 접수</a:t>
+            </a:r>
+            <a:endParaRPr lang="en-US" sz="1150" dirty="0"/>
+          </a:p>
+        </p:txBody>
+      </p:sp>
+      <p:sp>
+        <p:nvSpPr>
+          <p:cNvPr id="8" name="Shape 5"/>
+          <p:cNvSpPr/>
+          <p:nvPr/>
+        </p:nvSpPr>
+        <p:spPr>
+          <a:xfrm>
+            <a:off x="7690104" y="566928"/>
+            <a:ext cx="868680" cy="402336"/>
+          </a:xfrm>
+          <a:prstGeom prst="roundRect">
+            <a:avLst>
+              <a:gd name="adj" fmla="val 50000"/>
+            </a:avLst>
+          </a:prstGeom>
+          <a:solidFill>
+            <a:srgbClr val="1E2761"/>
+          </a:solidFill>
+          <a:ln/>
+        </p:spPr>
+      </p:sp>
+      <p:sp>
+        <p:nvSpPr>
+          <p:cNvPr id="9" name="Text 6"/>
+          <p:cNvSpPr txBox="1"/>
+          <p:nvPr/>
+        </p:nvSpPr>
+        <p:spPr>
+          <a:xfrm>
+            <a:off x="7690104" y="566928"/>
+            <a:ext cx="868680" cy="402336"/>
+          </a:xfrm>
+          <a:prstGeom prst="rect">
+            <a:avLst/>
+          </a:prstGeom>
+          <a:noFill/>
+          <a:ln/>
+        </p:spPr>
+        <p:txBody>
+          <a:bodyPr wrap="square" lIns="0" tIns="0" rIns="0" bIns="0" rtlCol="0" anchor="ctr"/>
+          <a:lstStyle/>
+          <a:p>
+            <a:pPr algn="ctr" indent="0" marL="0">
+              <a:buNone/>
+            </a:pPr>
+            <a:r>
+              <a:rPr lang="en-US" sz="1150" b="1" dirty="0">
+                <a:solidFill>
+                  <a:srgbClr val="FFFFFF"/>
+                </a:solidFill>
+                <a:latin typeface="맑은 고딕" pitchFamily="34" charset="0"/>
+                <a:ea typeface="맑은 고딕" pitchFamily="34" charset="-122"/>
+                <a:cs typeface="맑은 고딕" pitchFamily="34" charset="-120"/>
+              </a:rPr>
+              <a:t>2 서류</a:t>
+            </a:r>
+            <a:endParaRPr lang="en-US" sz="1150" dirty="0"/>
+          </a:p>
+        </p:txBody>
+      </p:sp>
+      <p:sp>
+        <p:nvSpPr>
+          <p:cNvPr id="10" name="Shape 7"/>
+          <p:cNvSpPr/>
+          <p:nvPr/>
+        </p:nvSpPr>
+        <p:spPr>
+          <a:xfrm>
+            <a:off x="8631936" y="566928"/>
+            <a:ext cx="868680" cy="402336"/>
+          </a:xfrm>
+          <a:prstGeom prst="roundRect">
+            <a:avLst>
+              <a:gd name="adj" fmla="val 50000"/>
+            </a:avLst>
+          </a:prstGeom>
+          <a:solidFill>
+            <a:srgbClr val="E8EFFC"/>
+          </a:solidFill>
+          <a:ln/>
+        </p:spPr>
+      </p:sp>
+      <p:sp>
+        <p:nvSpPr>
+          <p:cNvPr id="11" name="Text 8"/>
+          <p:cNvSpPr txBox="1"/>
+          <p:nvPr/>
+        </p:nvSpPr>
+        <p:spPr>
+          <a:xfrm>
+            <a:off x="8631936" y="566928"/>
+            <a:ext cx="868680" cy="402336"/>
+          </a:xfrm>
+          <a:prstGeom prst="rect">
+            <a:avLst/>
+          </a:prstGeom>
+          <a:noFill/>
+          <a:ln/>
+        </p:spPr>
+        <p:txBody>
+          <a:bodyPr wrap="square" lIns="0" tIns="0" rIns="0" bIns="0" rtlCol="0" anchor="ctr"/>
+          <a:lstStyle/>
+          <a:p>
+            <a:pPr algn="ctr" indent="0" marL="0">
+              <a:buNone/>
+            </a:pPr>
+            <a:r>
+              <a:rPr lang="en-US" sz="1150" dirty="0">
+                <a:solidFill>
+                  <a:srgbClr val="8A93AD"/>
+                </a:solidFill>
+                <a:latin typeface="맑은 고딕" pitchFamily="34" charset="0"/>
+                <a:ea typeface="맑은 고딕" pitchFamily="34" charset="-122"/>
+                <a:cs typeface="맑은 고딕" pitchFamily="34" charset="-120"/>
+              </a:rPr>
+              <a:t>3 면접</a:t>
+            </a:r>
+            <a:endParaRPr lang="en-US" sz="1150" dirty="0"/>
+          </a:p>
+        </p:txBody>
+      </p:sp>
+      <p:sp>
+        <p:nvSpPr>
+          <p:cNvPr id="12" name="Shape 9"/>
+          <p:cNvSpPr/>
+          <p:nvPr/>
+        </p:nvSpPr>
+        <p:spPr>
+          <a:xfrm>
+            <a:off x="9573768" y="566928"/>
+            <a:ext cx="868680" cy="402336"/>
+          </a:xfrm>
+          <a:prstGeom prst="roundRect">
+            <a:avLst>
+              <a:gd name="adj" fmla="val 50000"/>
+            </a:avLst>
+          </a:prstGeom>
+          <a:solidFill>
+            <a:srgbClr val="E8EFFC"/>
+          </a:solidFill>
+          <a:ln/>
+        </p:spPr>
+      </p:sp>
+      <p:sp>
+        <p:nvSpPr>
+          <p:cNvPr id="13" name="Text 10"/>
+          <p:cNvSpPr txBox="1"/>
+          <p:nvPr/>
+        </p:nvSpPr>
+        <p:spPr>
+          <a:xfrm>
+            <a:off x="9573768" y="566928"/>
+            <a:ext cx="868680" cy="402336"/>
+          </a:xfrm>
+          <a:prstGeom prst="rect">
+            <a:avLst/>
+          </a:prstGeom>
+          <a:noFill/>
+          <a:ln/>
+        </p:spPr>
+        <p:txBody>
+          <a:bodyPr wrap="square" lIns="0" tIns="0" rIns="0" bIns="0" rtlCol="0" anchor="ctr"/>
+          <a:lstStyle/>
+          <a:p>
+            <a:pPr algn="ctr" indent="0" marL="0">
+              <a:buNone/>
+            </a:pPr>
+            <a:r>
+              <a:rPr lang="en-US" sz="1150" dirty="0">
+                <a:solidFill>
+                  <a:srgbClr val="8A93AD"/>
+                </a:solidFill>
+                <a:latin typeface="맑은 고딕" pitchFamily="34" charset="0"/>
+                <a:ea typeface="맑은 고딕" pitchFamily="34" charset="-122"/>
+                <a:cs typeface="맑은 고딕" pitchFamily="34" charset="-120"/>
+              </a:rPr>
+              <a:t>4 검증</a:t>
+            </a:r>
+            <a:endParaRPr lang="en-US" sz="1150" dirty="0"/>
+          </a:p>
+        </p:txBody>
+      </p:sp>
+      <p:sp>
+        <p:nvSpPr>
+          <p:cNvPr id="14" name="Text 11"/>
           <p:cNvSpPr txBox="1"/>
           <p:nvPr/>
         </p:nvSpPr>
@@ -12695,7 +13495,7 @@
       </p:sp>
       <p:sp>
         <p:nvSpPr>
-          <p:cNvPr id="6" name="Text 3"/>
+          <p:cNvPr id="15" name="Text 12"/>
           <p:cNvSpPr txBox="1"/>
           <p:nvPr/>
         </p:nvSpPr>
@@ -13752,7 +14552,7 @@
       </p:graphicFrame>
       <p:sp>
         <p:nvSpPr>
-          <p:cNvPr id="8" name="Shape 4"/>
+          <p:cNvPr id="17" name="Shape 13"/>
           <p:cNvSpPr/>
           <p:nvPr/>
         </p:nvSpPr>
@@ -13786,7 +14586,7 @@
       </p:sp>
       <p:sp>
         <p:nvSpPr>
-          <p:cNvPr id="9" name="Text 5"/>
+          <p:cNvPr id="18" name="Text 14"/>
           <p:cNvSpPr txBox="1"/>
           <p:nvPr/>
         </p:nvSpPr>
@@ -13848,7 +14648,7 @@
       </p:sp>
       <p:sp>
         <p:nvSpPr>
-          <p:cNvPr id="10" name="Shape 6"/>
+          <p:cNvPr id="19" name="Shape 15"/>
           <p:cNvSpPr/>
           <p:nvPr/>
         </p:nvSpPr>
@@ -13868,7 +14668,7 @@
       </p:sp>
       <p:sp>
         <p:nvSpPr>
-          <p:cNvPr id="11" name="Text 7"/>
+          <p:cNvPr id="20" name="Text 16"/>
           <p:cNvSpPr txBox="1"/>
           <p:nvPr/>
         </p:nvSpPr>
@@ -13910,7 +14710,7 @@
       </p:sp>
       <p:sp>
         <p:nvSpPr>
-          <p:cNvPr id="12" name="Shape 8"/>
+          <p:cNvPr id="21" name="Shape 17"/>
           <p:cNvSpPr/>
           <p:nvPr/>
         </p:nvSpPr>
@@ -13930,7 +14730,7 @@
       </p:sp>
       <p:sp>
         <p:nvSpPr>
-          <p:cNvPr id="13" name="Text 9"/>
+          <p:cNvPr id="22" name="Text 18"/>
           <p:cNvSpPr txBox="1"/>
           <p:nvPr/>
         </p:nvSpPr>
@@ -13972,7 +14772,7 @@
       </p:sp>
       <p:sp>
         <p:nvSpPr>
-          <p:cNvPr id="14" name="Shape 10"/>
+          <p:cNvPr id="23" name="Shape 19"/>
           <p:cNvSpPr/>
           <p:nvPr/>
         </p:nvSpPr>
@@ -13992,7 +14792,7 @@
       </p:sp>
       <p:sp>
         <p:nvSpPr>
-          <p:cNvPr id="15" name="Text 11"/>
+          <p:cNvPr id="24" name="Text 20"/>
           <p:cNvSpPr txBox="1"/>
           <p:nvPr/>
         </p:nvSpPr>
@@ -14034,7 +14834,7 @@
       </p:sp>
       <p:sp>
         <p:nvSpPr>
-          <p:cNvPr id="16" name="Shape 12"/>
+          <p:cNvPr id="25" name="Shape 21"/>
           <p:cNvSpPr/>
           <p:nvPr/>
         </p:nvSpPr>
@@ -14068,7 +14868,7 @@
       </p:sp>
       <p:sp>
         <p:nvSpPr>
-          <p:cNvPr id="17" name="Text 13"/>
+          <p:cNvPr id="26" name="Text 22"/>
           <p:cNvSpPr txBox="1"/>
           <p:nvPr/>
         </p:nvSpPr>
@@ -14169,6 +14969,45 @@
         </p:nvSpPr>
         <p:spPr>
           <a:xfrm>
+            <a:off x="5166360" y="6309360"/>
+            <a:ext cx="1828800" cy="292608"/>
+          </a:xfrm>
+          <a:prstGeom prst="rect">
+            <a:avLst/>
+          </a:prstGeom>
+          <a:noFill/>
+          <a:ln/>
+        </p:spPr>
+        <p:txBody>
+          <a:bodyPr wrap="square" lIns="0" tIns="0" rIns="0" bIns="0" rtlCol="0" anchor="ctr"/>
+          <a:lstStyle/>
+          <a:p>
+            <a:pPr algn="ctr" indent="0" marL="0">
+              <a:buNone/>
+            </a:pPr>
+            <a:r>
+              <a:rPr lang="en-US" sz="1100" dirty="0">
+                <a:solidFill>
+                  <a:srgbClr val="6B7186"/>
+                </a:solidFill>
+                <a:latin typeface="맑은 고딕" pitchFamily="34" charset="0"/>
+                <a:ea typeface="맑은 고딕" pitchFamily="34" charset="-122"/>
+                <a:cs typeface="맑은 고딕" pitchFamily="34" charset="-120"/>
+              </a:rPr>
+              <a:t>- 7 -</a:t>
+            </a:r>
+            <a:endParaRPr lang="en-US" sz="1100" dirty="0"/>
+          </a:p>
+        </p:txBody>
+      </p:sp>
+      <p:sp>
+        <p:nvSpPr>
+          <p:cNvPr id="4" name="Text 1"/>
+          <p:cNvSpPr txBox="1"/>
+          <p:nvPr/>
+        </p:nvSpPr>
+        <p:spPr>
+          <a:xfrm>
             <a:off x="566928" y="329184"/>
             <a:ext cx="11027664" cy="237744"/>
           </a:xfrm>
@@ -14194,7 +15033,7 @@
                 <a:ea typeface="맑은 고딕" pitchFamily="34" charset="-122"/>
                 <a:cs typeface="맑은 고딕" pitchFamily="34" charset="-120"/>
               </a:rPr>
-              <a:t>STEP 03  INTERVIEW</a:t>
+              <a:t>전형 절차   3단계 / 4단계</a:t>
             </a:r>
             <a:endParaRPr lang="en-US" sz="1200" dirty="0"/>
           </a:p>
@@ -14202,7 +15041,7 @@
       </p:sp>
       <p:sp>
         <p:nvSpPr>
-          <p:cNvPr id="4" name="Text 1"/>
+          <p:cNvPr id="5" name="Text 2"/>
           <p:cNvSpPr txBox="1"/>
           <p:nvPr/>
         </p:nvSpPr>
@@ -14241,7 +15080,251 @@
       </p:sp>
       <p:sp>
         <p:nvSpPr>
-          <p:cNvPr id="5" name="Text 2"/>
+          <p:cNvPr id="6" name="Shape 3"/>
+          <p:cNvSpPr/>
+          <p:nvPr/>
+        </p:nvSpPr>
+        <p:spPr>
+          <a:xfrm>
+            <a:off x="6748272" y="566928"/>
+            <a:ext cx="868680" cy="402336"/>
+          </a:xfrm>
+          <a:prstGeom prst="roundRect">
+            <a:avLst>
+              <a:gd name="adj" fmla="val 50000"/>
+            </a:avLst>
+          </a:prstGeom>
+          <a:solidFill>
+            <a:srgbClr val="E8EFFC"/>
+          </a:solidFill>
+          <a:ln/>
+        </p:spPr>
+      </p:sp>
+      <p:sp>
+        <p:nvSpPr>
+          <p:cNvPr id="7" name="Text 4"/>
+          <p:cNvSpPr txBox="1"/>
+          <p:nvPr/>
+        </p:nvSpPr>
+        <p:spPr>
+          <a:xfrm>
+            <a:off x="6748272" y="566928"/>
+            <a:ext cx="868680" cy="402336"/>
+          </a:xfrm>
+          <a:prstGeom prst="rect">
+            <a:avLst/>
+          </a:prstGeom>
+          <a:noFill/>
+          <a:ln/>
+        </p:spPr>
+        <p:txBody>
+          <a:bodyPr wrap="square" lIns="0" tIns="0" rIns="0" bIns="0" rtlCol="0" anchor="ctr"/>
+          <a:lstStyle/>
+          <a:p>
+            <a:pPr algn="ctr" indent="0" marL="0">
+              <a:buNone/>
+            </a:pPr>
+            <a:r>
+              <a:rPr lang="en-US" sz="1150" dirty="0">
+                <a:solidFill>
+                  <a:srgbClr val="8A93AD"/>
+                </a:solidFill>
+                <a:latin typeface="맑은 고딕" pitchFamily="34" charset="0"/>
+                <a:ea typeface="맑은 고딕" pitchFamily="34" charset="-122"/>
+                <a:cs typeface="맑은 고딕" pitchFamily="34" charset="-120"/>
+              </a:rPr>
+              <a:t>1 접수</a:t>
+            </a:r>
+            <a:endParaRPr lang="en-US" sz="1150" dirty="0"/>
+          </a:p>
+        </p:txBody>
+      </p:sp>
+      <p:sp>
+        <p:nvSpPr>
+          <p:cNvPr id="8" name="Shape 5"/>
+          <p:cNvSpPr/>
+          <p:nvPr/>
+        </p:nvSpPr>
+        <p:spPr>
+          <a:xfrm>
+            <a:off x="7690104" y="566928"/>
+            <a:ext cx="868680" cy="402336"/>
+          </a:xfrm>
+          <a:prstGeom prst="roundRect">
+            <a:avLst>
+              <a:gd name="adj" fmla="val 50000"/>
+            </a:avLst>
+          </a:prstGeom>
+          <a:solidFill>
+            <a:srgbClr val="E8EFFC"/>
+          </a:solidFill>
+          <a:ln/>
+        </p:spPr>
+      </p:sp>
+      <p:sp>
+        <p:nvSpPr>
+          <p:cNvPr id="9" name="Text 6"/>
+          <p:cNvSpPr txBox="1"/>
+          <p:nvPr/>
+        </p:nvSpPr>
+        <p:spPr>
+          <a:xfrm>
+            <a:off x="7690104" y="566928"/>
+            <a:ext cx="868680" cy="402336"/>
+          </a:xfrm>
+          <a:prstGeom prst="rect">
+            <a:avLst/>
+          </a:prstGeom>
+          <a:noFill/>
+          <a:ln/>
+        </p:spPr>
+        <p:txBody>
+          <a:bodyPr wrap="square" lIns="0" tIns="0" rIns="0" bIns="0" rtlCol="0" anchor="ctr"/>
+          <a:lstStyle/>
+          <a:p>
+            <a:pPr algn="ctr" indent="0" marL="0">
+              <a:buNone/>
+            </a:pPr>
+            <a:r>
+              <a:rPr lang="en-US" sz="1150" dirty="0">
+                <a:solidFill>
+                  <a:srgbClr val="8A93AD"/>
+                </a:solidFill>
+                <a:latin typeface="맑은 고딕" pitchFamily="34" charset="0"/>
+                <a:ea typeface="맑은 고딕" pitchFamily="34" charset="-122"/>
+                <a:cs typeface="맑은 고딕" pitchFamily="34" charset="-120"/>
+              </a:rPr>
+              <a:t>2 서류</a:t>
+            </a:r>
+            <a:endParaRPr lang="en-US" sz="1150" dirty="0"/>
+          </a:p>
+        </p:txBody>
+      </p:sp>
+      <p:sp>
+        <p:nvSpPr>
+          <p:cNvPr id="10" name="Shape 7"/>
+          <p:cNvSpPr/>
+          <p:nvPr/>
+        </p:nvSpPr>
+        <p:spPr>
+          <a:xfrm>
+            <a:off x="8631936" y="566928"/>
+            <a:ext cx="868680" cy="402336"/>
+          </a:xfrm>
+          <a:prstGeom prst="roundRect">
+            <a:avLst>
+              <a:gd name="adj" fmla="val 50000"/>
+            </a:avLst>
+          </a:prstGeom>
+          <a:solidFill>
+            <a:srgbClr val="1E2761"/>
+          </a:solidFill>
+          <a:ln/>
+        </p:spPr>
+      </p:sp>
+      <p:sp>
+        <p:nvSpPr>
+          <p:cNvPr id="11" name="Text 8"/>
+          <p:cNvSpPr txBox="1"/>
+          <p:nvPr/>
+        </p:nvSpPr>
+        <p:spPr>
+          <a:xfrm>
+            <a:off x="8631936" y="566928"/>
+            <a:ext cx="868680" cy="402336"/>
+          </a:xfrm>
+          <a:prstGeom prst="rect">
+            <a:avLst/>
+          </a:prstGeom>
+          <a:noFill/>
+          <a:ln/>
+        </p:spPr>
+        <p:txBody>
+          <a:bodyPr wrap="square" lIns="0" tIns="0" rIns="0" bIns="0" rtlCol="0" anchor="ctr"/>
+          <a:lstStyle/>
+          <a:p>
+            <a:pPr algn="ctr" indent="0" marL="0">
+              <a:buNone/>
+            </a:pPr>
+            <a:r>
+              <a:rPr lang="en-US" sz="1150" b="1" dirty="0">
+                <a:solidFill>
+                  <a:srgbClr val="FFFFFF"/>
+                </a:solidFill>
+                <a:latin typeface="맑은 고딕" pitchFamily="34" charset="0"/>
+                <a:ea typeface="맑은 고딕" pitchFamily="34" charset="-122"/>
+                <a:cs typeface="맑은 고딕" pitchFamily="34" charset="-120"/>
+              </a:rPr>
+              <a:t>3 면접</a:t>
+            </a:r>
+            <a:endParaRPr lang="en-US" sz="1150" dirty="0"/>
+          </a:p>
+        </p:txBody>
+      </p:sp>
+      <p:sp>
+        <p:nvSpPr>
+          <p:cNvPr id="12" name="Shape 9"/>
+          <p:cNvSpPr/>
+          <p:nvPr/>
+        </p:nvSpPr>
+        <p:spPr>
+          <a:xfrm>
+            <a:off x="9573768" y="566928"/>
+            <a:ext cx="868680" cy="402336"/>
+          </a:xfrm>
+          <a:prstGeom prst="roundRect">
+            <a:avLst>
+              <a:gd name="adj" fmla="val 50000"/>
+            </a:avLst>
+          </a:prstGeom>
+          <a:solidFill>
+            <a:srgbClr val="E8EFFC"/>
+          </a:solidFill>
+          <a:ln/>
+        </p:spPr>
+      </p:sp>
+      <p:sp>
+        <p:nvSpPr>
+          <p:cNvPr id="13" name="Text 10"/>
+          <p:cNvSpPr txBox="1"/>
+          <p:nvPr/>
+        </p:nvSpPr>
+        <p:spPr>
+          <a:xfrm>
+            <a:off x="9573768" y="566928"/>
+            <a:ext cx="868680" cy="402336"/>
+          </a:xfrm>
+          <a:prstGeom prst="rect">
+            <a:avLst/>
+          </a:prstGeom>
+          <a:noFill/>
+          <a:ln/>
+        </p:spPr>
+        <p:txBody>
+          <a:bodyPr wrap="square" lIns="0" tIns="0" rIns="0" bIns="0" rtlCol="0" anchor="ctr"/>
+          <a:lstStyle/>
+          <a:p>
+            <a:pPr algn="ctr" indent="0" marL="0">
+              <a:buNone/>
+            </a:pPr>
+            <a:r>
+              <a:rPr lang="en-US" sz="1150" dirty="0">
+                <a:solidFill>
+                  <a:srgbClr val="8A93AD"/>
+                </a:solidFill>
+                <a:latin typeface="맑은 고딕" pitchFamily="34" charset="0"/>
+                <a:ea typeface="맑은 고딕" pitchFamily="34" charset="-122"/>
+                <a:cs typeface="맑은 고딕" pitchFamily="34" charset="-120"/>
+              </a:rPr>
+              <a:t>4 검증</a:t>
+            </a:r>
+            <a:endParaRPr lang="en-US" sz="1150" dirty="0"/>
+          </a:p>
+        </p:txBody>
+      </p:sp>
+      <p:sp>
+        <p:nvSpPr>
+          <p:cNvPr id="14" name="Text 11"/>
           <p:cNvSpPr txBox="1"/>
           <p:nvPr/>
         </p:nvSpPr>
@@ -14294,7 +15377,7 @@
       </p:sp>
       <p:sp>
         <p:nvSpPr>
-          <p:cNvPr id="6" name="Text 3"/>
+          <p:cNvPr id="15" name="Text 12"/>
           <p:cNvSpPr txBox="1"/>
           <p:nvPr/>
         </p:nvSpPr>
@@ -15351,7 +16434,7 @@
       </p:graphicFrame>
       <p:sp>
         <p:nvSpPr>
-          <p:cNvPr id="8" name="Shape 4"/>
+          <p:cNvPr id="17" name="Shape 13"/>
           <p:cNvSpPr/>
           <p:nvPr/>
         </p:nvSpPr>
@@ -15385,7 +16468,7 @@
       </p:sp>
       <p:sp>
         <p:nvSpPr>
-          <p:cNvPr id="9" name="Text 5"/>
+          <p:cNvPr id="18" name="Text 14"/>
           <p:cNvSpPr txBox="1"/>
           <p:nvPr/>
         </p:nvSpPr>
@@ -15424,7 +16507,7 @@
       </p:sp>
       <p:graphicFrame>
         <p:nvGraphicFramePr>
-          <p:cNvPr id="10" name="Chart 0" descr=""/>
+          <p:cNvPr id="19" name="Chart 0" descr=""/>
           <p:cNvGraphicFramePr/>
           <p:nvPr/>
         </p:nvGraphicFramePr>
@@ -15440,7 +16523,7 @@
       </p:graphicFrame>
       <p:sp>
         <p:nvSpPr>
-          <p:cNvPr id="11" name="Shape 6"/>
+          <p:cNvPr id="20" name="Shape 15"/>
           <p:cNvSpPr/>
           <p:nvPr/>
         </p:nvSpPr>
@@ -15462,7 +16545,7 @@
       </p:sp>
       <p:sp>
         <p:nvSpPr>
-          <p:cNvPr id="12" name="Text 7"/>
+          <p:cNvPr id="21" name="Text 16"/>
           <p:cNvSpPr txBox="1"/>
           <p:nvPr/>
         </p:nvSpPr>
@@ -15501,7 +16584,7 @@
       </p:sp>
       <p:sp>
         <p:nvSpPr>
-          <p:cNvPr id="13" name="Text 8"/>
+          <p:cNvPr id="22" name="Text 17"/>
           <p:cNvSpPr txBox="1"/>
           <p:nvPr/>
         </p:nvSpPr>
@@ -15540,7 +16623,7 @@
       </p:sp>
       <p:sp>
         <p:nvSpPr>
-          <p:cNvPr id="14" name="Shape 9"/>
+          <p:cNvPr id="23" name="Shape 18"/>
           <p:cNvSpPr/>
           <p:nvPr/>
         </p:nvSpPr>
@@ -15562,7 +16645,7 @@
       </p:sp>
       <p:sp>
         <p:nvSpPr>
-          <p:cNvPr id="15" name="Text 10"/>
+          <p:cNvPr id="24" name="Text 19"/>
           <p:cNvSpPr txBox="1"/>
           <p:nvPr/>
         </p:nvSpPr>
@@ -15601,7 +16684,7 @@
       </p:sp>
       <p:sp>
         <p:nvSpPr>
-          <p:cNvPr id="16" name="Text 11"/>
+          <p:cNvPr id="25" name="Text 20"/>
           <p:cNvSpPr txBox="1"/>
           <p:nvPr/>
         </p:nvSpPr>
@@ -15640,7 +16723,7 @@
       </p:sp>
       <p:sp>
         <p:nvSpPr>
-          <p:cNvPr id="17" name="Text 12"/>
+          <p:cNvPr id="26" name="Text 21"/>
           <p:cNvSpPr txBox="1"/>
           <p:nvPr/>
         </p:nvSpPr>
@@ -15679,7 +16762,7 @@
       </p:sp>
       <p:sp>
         <p:nvSpPr>
-          <p:cNvPr id="18" name="Text 13"/>
+          <p:cNvPr id="27" name="Text 22"/>
           <p:cNvSpPr txBox="1"/>
           <p:nvPr/>
         </p:nvSpPr>
@@ -15780,6 +16863,45 @@
         </p:nvSpPr>
         <p:spPr>
           <a:xfrm>
+            <a:off x="5166360" y="6309360"/>
+            <a:ext cx="1828800" cy="292608"/>
+          </a:xfrm>
+          <a:prstGeom prst="rect">
+            <a:avLst/>
+          </a:prstGeom>
+          <a:noFill/>
+          <a:ln/>
+        </p:spPr>
+        <p:txBody>
+          <a:bodyPr wrap="square" lIns="0" tIns="0" rIns="0" bIns="0" rtlCol="0" anchor="ctr"/>
+          <a:lstStyle/>
+          <a:p>
+            <a:pPr algn="ctr" indent="0" marL="0">
+              <a:buNone/>
+            </a:pPr>
+            <a:r>
+              <a:rPr lang="en-US" sz="1100" dirty="0">
+                <a:solidFill>
+                  <a:srgbClr val="6B7186"/>
+                </a:solidFill>
+                <a:latin typeface="맑은 고딕" pitchFamily="34" charset="0"/>
+                <a:ea typeface="맑은 고딕" pitchFamily="34" charset="-122"/>
+                <a:cs typeface="맑은 고딕" pitchFamily="34" charset="-120"/>
+              </a:rPr>
+              <a:t>- 8 -</a:t>
+            </a:r>
+            <a:endParaRPr lang="en-US" sz="1100" dirty="0"/>
+          </a:p>
+        </p:txBody>
+      </p:sp>
+      <p:sp>
+        <p:nvSpPr>
+          <p:cNvPr id="4" name="Text 1"/>
+          <p:cNvSpPr txBox="1"/>
+          <p:nvPr/>
+        </p:nvSpPr>
+        <p:spPr>
+          <a:xfrm>
             <a:off x="566928" y="329184"/>
             <a:ext cx="11027664" cy="237744"/>
           </a:xfrm>
@@ -15805,7 +16927,7 @@
                 <a:ea typeface="맑은 고딕" pitchFamily="34" charset="-122"/>
                 <a:cs typeface="맑은 고딕" pitchFamily="34" charset="-120"/>
               </a:rPr>
-              <a:t>STEP 04  VERIFICATION</a:t>
+              <a:t>전형 절차   4단계 / 4단계</a:t>
             </a:r>
             <a:endParaRPr lang="en-US" sz="1200" dirty="0"/>
           </a:p>
@@ -15813,7 +16935,7 @@
       </p:sp>
       <p:sp>
         <p:nvSpPr>
-          <p:cNvPr id="4" name="Text 1"/>
+          <p:cNvPr id="5" name="Text 2"/>
           <p:cNvSpPr txBox="1"/>
           <p:nvPr/>
         </p:nvSpPr>
@@ -15852,7 +16974,251 @@
       </p:sp>
       <p:sp>
         <p:nvSpPr>
-          <p:cNvPr id="5" name="Text 2"/>
+          <p:cNvPr id="6" name="Shape 3"/>
+          <p:cNvSpPr/>
+          <p:nvPr/>
+        </p:nvSpPr>
+        <p:spPr>
+          <a:xfrm>
+            <a:off x="6748272" y="566928"/>
+            <a:ext cx="868680" cy="402336"/>
+          </a:xfrm>
+          <a:prstGeom prst="roundRect">
+            <a:avLst>
+              <a:gd name="adj" fmla="val 50000"/>
+            </a:avLst>
+          </a:prstGeom>
+          <a:solidFill>
+            <a:srgbClr val="E8EFFC"/>
+          </a:solidFill>
+          <a:ln/>
+        </p:spPr>
+      </p:sp>
+      <p:sp>
+        <p:nvSpPr>
+          <p:cNvPr id="7" name="Text 4"/>
+          <p:cNvSpPr txBox="1"/>
+          <p:nvPr/>
+        </p:nvSpPr>
+        <p:spPr>
+          <a:xfrm>
+            <a:off x="6748272" y="566928"/>
+            <a:ext cx="868680" cy="402336"/>
+          </a:xfrm>
+          <a:prstGeom prst="rect">
+            <a:avLst/>
+          </a:prstGeom>
+          <a:noFill/>
+          <a:ln/>
+        </p:spPr>
+        <p:txBody>
+          <a:bodyPr wrap="square" lIns="0" tIns="0" rIns="0" bIns="0" rtlCol="0" anchor="ctr"/>
+          <a:lstStyle/>
+          <a:p>
+            <a:pPr algn="ctr" indent="0" marL="0">
+              <a:buNone/>
+            </a:pPr>
+            <a:r>
+              <a:rPr lang="en-US" sz="1150" dirty="0">
+                <a:solidFill>
+                  <a:srgbClr val="8A93AD"/>
+                </a:solidFill>
+                <a:latin typeface="맑은 고딕" pitchFamily="34" charset="0"/>
+                <a:ea typeface="맑은 고딕" pitchFamily="34" charset="-122"/>
+                <a:cs typeface="맑은 고딕" pitchFamily="34" charset="-120"/>
+              </a:rPr>
+              <a:t>1 접수</a:t>
+            </a:r>
+            <a:endParaRPr lang="en-US" sz="1150" dirty="0"/>
+          </a:p>
+        </p:txBody>
+      </p:sp>
+      <p:sp>
+        <p:nvSpPr>
+          <p:cNvPr id="8" name="Shape 5"/>
+          <p:cNvSpPr/>
+          <p:nvPr/>
+        </p:nvSpPr>
+        <p:spPr>
+          <a:xfrm>
+            <a:off x="7690104" y="566928"/>
+            <a:ext cx="868680" cy="402336"/>
+          </a:xfrm>
+          <a:prstGeom prst="roundRect">
+            <a:avLst>
+              <a:gd name="adj" fmla="val 50000"/>
+            </a:avLst>
+          </a:prstGeom>
+          <a:solidFill>
+            <a:srgbClr val="E8EFFC"/>
+          </a:solidFill>
+          <a:ln/>
+        </p:spPr>
+      </p:sp>
+      <p:sp>
+        <p:nvSpPr>
+          <p:cNvPr id="9" name="Text 6"/>
+          <p:cNvSpPr txBox="1"/>
+          <p:nvPr/>
+        </p:nvSpPr>
+        <p:spPr>
+          <a:xfrm>
+            <a:off x="7690104" y="566928"/>
+            <a:ext cx="868680" cy="402336"/>
+          </a:xfrm>
+          <a:prstGeom prst="rect">
+            <a:avLst/>
+          </a:prstGeom>
+          <a:noFill/>
+          <a:ln/>
+        </p:spPr>
+        <p:txBody>
+          <a:bodyPr wrap="square" lIns="0" tIns="0" rIns="0" bIns="0" rtlCol="0" anchor="ctr"/>
+          <a:lstStyle/>
+          <a:p>
+            <a:pPr algn="ctr" indent="0" marL="0">
+              <a:buNone/>
+            </a:pPr>
+            <a:r>
+              <a:rPr lang="en-US" sz="1150" dirty="0">
+                <a:solidFill>
+                  <a:srgbClr val="8A93AD"/>
+                </a:solidFill>
+                <a:latin typeface="맑은 고딕" pitchFamily="34" charset="0"/>
+                <a:ea typeface="맑은 고딕" pitchFamily="34" charset="-122"/>
+                <a:cs typeface="맑은 고딕" pitchFamily="34" charset="-120"/>
+              </a:rPr>
+              <a:t>2 서류</a:t>
+            </a:r>
+            <a:endParaRPr lang="en-US" sz="1150" dirty="0"/>
+          </a:p>
+        </p:txBody>
+      </p:sp>
+      <p:sp>
+        <p:nvSpPr>
+          <p:cNvPr id="10" name="Shape 7"/>
+          <p:cNvSpPr/>
+          <p:nvPr/>
+        </p:nvSpPr>
+        <p:spPr>
+          <a:xfrm>
+            <a:off x="8631936" y="566928"/>
+            <a:ext cx="868680" cy="402336"/>
+          </a:xfrm>
+          <a:prstGeom prst="roundRect">
+            <a:avLst>
+              <a:gd name="adj" fmla="val 50000"/>
+            </a:avLst>
+          </a:prstGeom>
+          <a:solidFill>
+            <a:srgbClr val="E8EFFC"/>
+          </a:solidFill>
+          <a:ln/>
+        </p:spPr>
+      </p:sp>
+      <p:sp>
+        <p:nvSpPr>
+          <p:cNvPr id="11" name="Text 8"/>
+          <p:cNvSpPr txBox="1"/>
+          <p:nvPr/>
+        </p:nvSpPr>
+        <p:spPr>
+          <a:xfrm>
+            <a:off x="8631936" y="566928"/>
+            <a:ext cx="868680" cy="402336"/>
+          </a:xfrm>
+          <a:prstGeom prst="rect">
+            <a:avLst/>
+          </a:prstGeom>
+          <a:noFill/>
+          <a:ln/>
+        </p:spPr>
+        <p:txBody>
+          <a:bodyPr wrap="square" lIns="0" tIns="0" rIns="0" bIns="0" rtlCol="0" anchor="ctr"/>
+          <a:lstStyle/>
+          <a:p>
+            <a:pPr algn="ctr" indent="0" marL="0">
+              <a:buNone/>
+            </a:pPr>
+            <a:r>
+              <a:rPr lang="en-US" sz="1150" dirty="0">
+                <a:solidFill>
+                  <a:srgbClr val="8A93AD"/>
+                </a:solidFill>
+                <a:latin typeface="맑은 고딕" pitchFamily="34" charset="0"/>
+                <a:ea typeface="맑은 고딕" pitchFamily="34" charset="-122"/>
+                <a:cs typeface="맑은 고딕" pitchFamily="34" charset="-120"/>
+              </a:rPr>
+              <a:t>3 면접</a:t>
+            </a:r>
+            <a:endParaRPr lang="en-US" sz="1150" dirty="0"/>
+          </a:p>
+        </p:txBody>
+      </p:sp>
+      <p:sp>
+        <p:nvSpPr>
+          <p:cNvPr id="12" name="Shape 9"/>
+          <p:cNvSpPr/>
+          <p:nvPr/>
+        </p:nvSpPr>
+        <p:spPr>
+          <a:xfrm>
+            <a:off x="9573768" y="566928"/>
+            <a:ext cx="868680" cy="402336"/>
+          </a:xfrm>
+          <a:prstGeom prst="roundRect">
+            <a:avLst>
+              <a:gd name="adj" fmla="val 50000"/>
+            </a:avLst>
+          </a:prstGeom>
+          <a:solidFill>
+            <a:srgbClr val="1E2761"/>
+          </a:solidFill>
+          <a:ln/>
+        </p:spPr>
+      </p:sp>
+      <p:sp>
+        <p:nvSpPr>
+          <p:cNvPr id="13" name="Text 10"/>
+          <p:cNvSpPr txBox="1"/>
+          <p:nvPr/>
+        </p:nvSpPr>
+        <p:spPr>
+          <a:xfrm>
+            <a:off x="9573768" y="566928"/>
+            <a:ext cx="868680" cy="402336"/>
+          </a:xfrm>
+          <a:prstGeom prst="rect">
+            <a:avLst/>
+          </a:prstGeom>
+          <a:noFill/>
+          <a:ln/>
+        </p:spPr>
+        <p:txBody>
+          <a:bodyPr wrap="square" lIns="0" tIns="0" rIns="0" bIns="0" rtlCol="0" anchor="ctr"/>
+          <a:lstStyle/>
+          <a:p>
+            <a:pPr algn="ctr" indent="0" marL="0">
+              <a:buNone/>
+            </a:pPr>
+            <a:r>
+              <a:rPr lang="en-US" sz="1150" b="1" dirty="0">
+                <a:solidFill>
+                  <a:srgbClr val="FFFFFF"/>
+                </a:solidFill>
+                <a:latin typeface="맑은 고딕" pitchFamily="34" charset="0"/>
+                <a:ea typeface="맑은 고딕" pitchFamily="34" charset="-122"/>
+                <a:cs typeface="맑은 고딕" pitchFamily="34" charset="-120"/>
+              </a:rPr>
+              <a:t>4 검증</a:t>
+            </a:r>
+            <a:endParaRPr lang="en-US" sz="1150" dirty="0"/>
+          </a:p>
+        </p:txBody>
+      </p:sp>
+      <p:sp>
+        <p:nvSpPr>
+          <p:cNvPr id="14" name="Text 11"/>
           <p:cNvSpPr txBox="1"/>
           <p:nvPr/>
         </p:nvSpPr>
@@ -15933,7 +17299,7 @@
       </p:sp>
       <p:sp>
         <p:nvSpPr>
-          <p:cNvPr id="6" name="Shape 3"/>
+          <p:cNvPr id="15" name="Shape 12"/>
           <p:cNvSpPr/>
           <p:nvPr/>
         </p:nvSpPr>
@@ -15967,7 +17333,7 @@
       </p:sp>
       <p:sp>
         <p:nvSpPr>
-          <p:cNvPr id="7" name="Text 4"/>
+          <p:cNvPr id="16" name="Text 13"/>
           <p:cNvSpPr txBox="1"/>
           <p:nvPr/>
         </p:nvSpPr>
@@ -16006,7 +17372,7 @@
       </p:sp>
       <p:sp>
         <p:nvSpPr>
-          <p:cNvPr id="8" name="Text 5"/>
+          <p:cNvPr id="17" name="Text 14"/>
           <p:cNvSpPr txBox="1"/>
           <p:nvPr/>
         </p:nvSpPr>
@@ -16045,7 +17411,7 @@
       </p:sp>
       <p:sp>
         <p:nvSpPr>
-          <p:cNvPr id="9" name="Text 6"/>
+          <p:cNvPr id="18" name="Text 15"/>
           <p:cNvSpPr txBox="1"/>
           <p:nvPr/>
         </p:nvSpPr>
@@ -16107,7 +17473,7 @@
       </p:sp>
       <p:sp>
         <p:nvSpPr>
-          <p:cNvPr id="10" name="Text 7"/>
+          <p:cNvPr id="19" name="Text 16"/>
           <p:cNvSpPr txBox="1"/>
           <p:nvPr/>
         </p:nvSpPr>
@@ -16146,7 +17512,7 @@
       </p:sp>
       <p:sp>
         <p:nvSpPr>
-          <p:cNvPr id="11" name="Text 8"/>
+          <p:cNvPr id="20" name="Text 17"/>
           <p:cNvSpPr txBox="1"/>
           <p:nvPr/>
         </p:nvSpPr>
@@ -16208,7 +17574,7 @@
       </p:sp>
       <p:sp>
         <p:nvSpPr>
-          <p:cNvPr id="12" name="Text 9"/>
+          <p:cNvPr id="21" name="Text 18"/>
           <p:cNvSpPr txBox="1"/>
           <p:nvPr/>
         </p:nvSpPr>
@@ -16924,7 +18290,7 @@
       </p:graphicFrame>
       <p:sp>
         <p:nvSpPr>
-          <p:cNvPr id="14" name="Shape 10"/>
+          <p:cNvPr id="23" name="Shape 19"/>
           <p:cNvSpPr/>
           <p:nvPr/>
         </p:nvSpPr>
@@ -16958,7 +18324,7 @@
       </p:sp>
       <p:sp>
         <p:nvSpPr>
-          <p:cNvPr id="15" name="Text 11"/>
+          <p:cNvPr id="24" name="Text 20"/>
           <p:cNvSpPr txBox="1"/>
           <p:nvPr/>
         </p:nvSpPr>
@@ -16997,7 +18363,7 @@
       </p:sp>
       <p:sp>
         <p:nvSpPr>
-          <p:cNvPr id="16" name="Shape 12"/>
+          <p:cNvPr id="25" name="Shape 21"/>
           <p:cNvSpPr/>
           <p:nvPr/>
         </p:nvSpPr>
@@ -17019,7 +18385,7 @@
       </p:sp>
       <p:sp>
         <p:nvSpPr>
-          <p:cNvPr id="17" name="Text 13"/>
+          <p:cNvPr id="26" name="Text 22"/>
           <p:cNvSpPr txBox="1"/>
           <p:nvPr/>
         </p:nvSpPr>
@@ -17058,7 +18424,7 @@
       </p:sp>
       <p:sp>
         <p:nvSpPr>
-          <p:cNvPr id="18" name="Shape 14"/>
+          <p:cNvPr id="27" name="Shape 23"/>
           <p:cNvSpPr/>
           <p:nvPr/>
         </p:nvSpPr>
@@ -17080,7 +18446,7 @@
       </p:sp>
       <p:sp>
         <p:nvSpPr>
-          <p:cNvPr id="19" name="Text 15"/>
+          <p:cNvPr id="28" name="Text 24"/>
           <p:cNvSpPr txBox="1"/>
           <p:nvPr/>
         </p:nvSpPr>
@@ -17119,7 +18485,7 @@
       </p:sp>
       <p:sp>
         <p:nvSpPr>
-          <p:cNvPr id="20" name="Shape 16"/>
+          <p:cNvPr id="29" name="Shape 25"/>
           <p:cNvSpPr/>
           <p:nvPr/>
         </p:nvSpPr>
@@ -17141,7 +18507,7 @@
       </p:sp>
       <p:sp>
         <p:nvSpPr>
-          <p:cNvPr id="21" name="Text 17"/>
+          <p:cNvPr id="30" name="Text 26"/>
           <p:cNvSpPr txBox="1"/>
           <p:nvPr/>
         </p:nvSpPr>

</xml_diff>